<commit_message>
update - adding tutorial and fixing powerpoint
</commit_message>
<xml_diff>
--- a/orchestrer-intelligence-gatherly.pptx
+++ b/orchestrer-intelligence-gatherly.pptx
@@ -7779,24 +7779,24 @@
         </p:nvSpPr>
         <p:spPr>
           <a:xfrm>
-            <a:off x="457200" y="2286000"/>
-            <a:ext cx="8229600" cy="914400"/>
-          </a:xfrm>
-          <a:prstGeom prst="rect">
-            <a:avLst/>
-          </a:prstGeom>
-          <a:noFill/>
-          <a:ln/>
-        </p:spPr>
-        <p:txBody>
-          <a:bodyPr wrap="square" lIns="0" tIns="0" rIns="0" bIns="0" rtlCol="0" anchor="ctr"/>
-          <a:lstStyle/>
-          <a:p>
-            <a:pPr marL="0" indent="0">
-              <a:buNone/>
-            </a:pPr>
-            <a:r>
-              <a:rPr lang="en-US" sz="6000" b="1" dirty="0">
+            <a:off x="503766" y="1568196"/>
+            <a:ext cx="4889500" cy="1748366"/>
+          </a:xfrm>
+          <a:prstGeom prst="rect">
+            <a:avLst/>
+          </a:prstGeom>
+          <a:noFill/>
+          <a:ln/>
+        </p:spPr>
+        <p:txBody>
+          <a:bodyPr wrap="square" lIns="0" tIns="0" rIns="0" bIns="0" rtlCol="0" anchor="ctr"/>
+          <a:lstStyle/>
+          <a:p>
+            <a:pPr marL="0" indent="0">
+              <a:buNone/>
+            </a:pPr>
+            <a:r>
+              <a:rPr lang="en-US" b="1" dirty="0">
                 <a:solidFill>
                   <a:srgbClr val="3B82F6"/>
                 </a:solidFill>
@@ -7804,9 +7804,20 @@
                 <a:ea typeface="Inter" pitchFamily="34" charset="-122"/>
                 <a:cs typeface="Inter" pitchFamily="34" charset="-120"/>
               </a:rPr>
-              <a:t>8   readiness gaps · 8 hours · no supervision</a:t>
-            </a:r>
-            <a:endParaRPr lang="en-US" sz="6000" dirty="0"/>
+              <a:t>8   readiness gaps · </a:t>
+            </a:r>
+            <a:r>
+              <a:rPr lang="en-US" sz="1400" b="1" dirty="0">
+                <a:solidFill>
+                  <a:srgbClr val="3B82F6"/>
+                </a:solidFill>
+                <a:latin typeface="Montserrat" pitchFamily="34" charset="0"/>
+                <a:ea typeface="Inter" pitchFamily="34" charset="-122"/>
+                <a:cs typeface="Inter" pitchFamily="34" charset="-120"/>
+              </a:rPr>
+              <a:t>8 hours · no supervision</a:t>
+            </a:r>
+            <a:endParaRPr lang="en-US" sz="1400" dirty="0"/>
           </a:p>
         </p:txBody>
       </p:sp>
@@ -14167,7 +14178,7 @@
           <p:nvPr>
             <p:extLst>
               <p:ext uri="{D42A27DB-BD31-4B8C-83A1-F6EECF244321}">
-                <p14:modId xmlns:p14="http://schemas.microsoft.com/office/powerpoint/2010/main" val="1579011935"/>
+                <p14:modId xmlns:p14="http://schemas.microsoft.com/office/powerpoint/2010/main" val="3926131547"/>
               </p:ext>
             </p:extLst>
           </p:nvPr>
@@ -14979,7 +14990,29 @@
                           <a:ea typeface="Inter" pitchFamily="34" charset="-122"/>
                           <a:cs typeface="Inter" pitchFamily="34" charset="-120"/>
                         </a:rPr>
-                        <a:t>diagnose, retry ×3, escalate</a:t>
+                        <a:t>diagnose</a:t>
+                      </a:r>
+                      <a:r>
+                        <a:rPr lang="en-US" sz="1200">
+                          <a:solidFill>
+                            <a:srgbClr val="F8FAFC"/>
+                          </a:solidFill>
+                          <a:latin typeface="Inter" pitchFamily="34" charset="0"/>
+                          <a:ea typeface="Inter" pitchFamily="34" charset="-122"/>
+                          <a:cs typeface="Inter" pitchFamily="34" charset="-120"/>
+                        </a:rPr>
+                        <a:t>, retry , </a:t>
+                      </a:r>
+                      <a:r>
+                        <a:rPr lang="en-US" sz="1200" dirty="0">
+                          <a:solidFill>
+                            <a:srgbClr val="F8FAFC"/>
+                          </a:solidFill>
+                          <a:latin typeface="Inter" pitchFamily="34" charset="0"/>
+                          <a:ea typeface="Inter" pitchFamily="34" charset="-122"/>
+                          <a:cs typeface="Inter" pitchFamily="34" charset="-120"/>
+                        </a:rPr>
+                        <a:t>escalate</a:t>
                       </a:r>
                       <a:endParaRPr lang="en-US" sz="1200" dirty="0">
                         <a:latin typeface="Inter" charset="0"/>
@@ -18000,4 +18033,10 @@
     </a:ext>
   </a:extLst>
 </a:theme>
+</file>
+
+<file path=docMetadata/LabelInfo.xml><?xml version="1.0" encoding="utf-8"?>
+<clbl:labelList xmlns:clbl="http://schemas.microsoft.com/office/2020/mipLabelMetadata">
+  <clbl:label id="{af3cd2ba-39fc-428b-a333-80f7eb18b18d}" enabled="1" method="Standard" siteId="{e8b88f3d-222b-4ce5-b9d1-46b0ff9466a0}" contentBits="0" removed="0"/>
+</clbl:labelList>
 </file>
</xml_diff>

<commit_message>
feat: redesign demo moments around the specialist team
- /implement: add Phase 1.5 "convene the specialist team" — after a feature is
  implemented, fan out code-reviewer + security-auditor + test-writer (and
  frontend-reviewer / migration-reviewer when relevant) IN PARALLEL via the Task
  tool, each in its own context. Adds Task to allowed-tools. Makes the demo's
  Moment 1 "the team assembles" real on screen.
- deck (slides 15-17 + FR notes): M1 → "watch the team assemble" + names the
  three specialists; M2 note → the security-auditor subagent catches the S2 leak;
  M3 → "the team works overnight" via real /work-issues. Notes rewritten in French.

Co-Authored-By: Claude Opus 4.8 (1M context) <noreply@anthropic.com>
</commit_message>
<xml_diff>
--- a/orchestrer-intelligence-gatherly.pptx
+++ b/orchestrer-intelligence-gatherly.pptx
@@ -827,8 +827,8 @@
           <a:lstStyle/>
           <a:p>
             <a:r>
-              <a:rPr lang="en-US" dirty="0"/>
-              <a:t>Moment 1 : une seule commande, l'orchestrateur fait le reste. Narrer les invocations à voix haute. DÉBRIEF À L'ORAL (la slide récap a été coupée, format 20 min) : 1 orchestrateur, 7 spécialistes invoqués ; critères d'acceptation définis au départ, vérifiés à la fin ; 1 race condition attrapée par /review-pr avant commit ; PR ouverte, CI verte, ~8 minutes. Punchline : personne n'a choisi les spécialistes — le routage est dans le système.</a:t>
+              <a:rPr lang="fr-FR" dirty="0"/>
+              <a:t>Moment 1 — « l'équipe s'assemble ». Une seule commande : /implement. L'orchestrateur planifie, explore, implémente, puis FAIT APPEL À TROIS SPÉCIALISTES EN PARALLÈLE — code-reviewer, security-auditor, test-writer — chacun dans son propre contexte. Narrer les invocations à voix haute pendant qu'elles apparaissent à l'écran. DÉBRIEF À L'ORAL : critères d'acceptation définis au départ et vérifiés à la fin ; les trois spécialistes reviennent verts (relecture LGTM, audit CLEAN, tests ≥ 80 % sur le nouveau code) ; PR ouverte, CI verte, ~8 minutes. Punchline : « Je n'ai jamais dit quel spécialiste utiliser — l'orchestrateur a assemblé l'équipe. Ce n'est pas de l'autocomplétion, c'est une équipe. »</a:t>
             </a:r>
           </a:p>
         </p:txBody>
@@ -914,8 +914,8 @@
           <a:lstStyle/>
           <a:p>
             <a:r>
-              <a:rPr lang="en-US" dirty="0"/>
-              <a:t>Moment 2 : montrer l'échec volontaire. Transparence : annoncer que l'erreur est pré-injectée — ça renforce la crédibilité. DÉBRIEF À L'ORAL : /audit-security (et le test d'isolation) a signalé la fuite de confidentialité en quelques secondes ; la boucle de fix a restauré le contrôle de propriété manquant ; re-audit propre, commit passé — zéro humain impliqué. Punchline : le système a attrapé sa propre erreur avant qu'un humain voie le code. Si on demande « et si le fix échoue 3 fois ? » → moment 3 le montre.</a:t>
+              <a:rPr lang="fr-FR" dirty="0"/>
+              <a:t>Moment 2 — « l'équipe s'attrape elle-même ». Montrer l'échec volontaire ; annoncer que la faille est pré-injectée (un invité pouvait lire la liste d'invités d'un autre organisateur) — la transparence renforce la crédibilité. À l'écran : le subagent security-auditor (lecture seule, contexte isolé) signale la violation S2 (isolation des locataires) avec preuve fichier:ligne en quelques secondes → la barrière BLOQUE le commit → la boucle de fix interne rétablit le contrôle de propriété manquant → re-audit propre. Punchline : « L'auditeur est un spécialiste à part : outils en lecture seule, son propre contexte. Il ne peut pas modifier votre code, et on ne peut pas le convaincre d'ignorer une faille. Il a attrapé la fuite avant qu'un humain voie le code. Zéro humain. » Si on demande « et si le fix échoue 3 fois ? » → c'est exactement le moment 3.</a:t>
             </a:r>
           </a:p>
         </p:txBody>
@@ -1001,8 +1001,8 @@
           <a:lstStyle/>
           <a:p>
             <a:r>
-              <a:rPr lang="en-US" dirty="0"/>
-              <a:t>Moment 3 : la nuit en timelapse. C'est ici que « agent à la demande » prend tout son sens : le système s'est réveillé pour chaque écart de préparation, a travaillé, s'est arrêté. Enchaîner directement sur la slide résultats (7 PRs + 1 escalade).</a:t>
+              <a:rPr lang="fr-FR" dirty="0"/>
+              <a:t>Moment 3 — « l'équipe travaille pendant que vous dormez ». Autonomie complète, et c'est RÉEL sur ce dépôt : /work-issues tourne en headless, planifié, la nuit. Montrer le run de la nuit dernière en timelapse, puis la liste des PR sur GitHub. Chaque écart est passé dans la boucle complète AVEC l'équipe de spécialistes → 7 PR ouvertes, 1 escalade marquée « needs-human » avec trace complète après 3 tentatives. Punchline : « Huit écarts, huit heures, sans supervision. Sept corrigés et mis en PR. Un qu'il n'a pas su résoudre — alors il s'est arrêté et a tagué un humain. L'escalade, c'est l'essentiel : un système qui sait s'arrêter est le seul qu'on peut déployer. » (Backup : avoir le timelapse enregistré — impossible de lancer un run de 8 h en direct.)</a:t>
             </a:r>
           </a:p>
         </p:txBody>
@@ -6812,261 +6812,8 @@
 </p:sld>
 </file>
 
-<file path=ppt/slides/slide15.xml><?xml version="1.0" encoding="utf-8"?>
-<p:sld xmlns:a="http://schemas.openxmlformats.org/drawingml/2006/main" xmlns:r="http://schemas.openxmlformats.org/officeDocument/2006/relationships" xmlns:p="http://schemas.openxmlformats.org/presentationml/2006/main">
-  <p:cSld name="Slide 15">
-    <p:bg>
-      <p:bgPr>
-        <a:solidFill>
-          <a:srgbClr val="0F1729"/>
-        </a:solidFill>
-        <a:effectLst/>
-      </p:bgPr>
-    </p:bg>
-    <p:spTree>
-      <p:nvGrpSpPr>
-        <p:cNvPr id="1" name=""/>
-        <p:cNvGrpSpPr/>
-        <p:nvPr/>
-      </p:nvGrpSpPr>
-      <p:grpSpPr>
-        <a:xfrm>
-          <a:off x="0" y="0"/>
-          <a:ext cx="0" cy="0"/>
-          <a:chOff x="0" y="0"/>
-          <a:chExt cx="0" cy="0"/>
-        </a:xfrm>
-      </p:grpSpPr>
-      <p:sp>
-        <p:nvSpPr>
-          <p:cNvPr id="2" name="Text 0"/>
-          <p:cNvSpPr/>
-          <p:nvPr/>
-        </p:nvSpPr>
-        <p:spPr>
-          <a:xfrm>
-            <a:off x="457200" y="4796028"/>
-            <a:ext cx="4572000" cy="274320"/>
-          </a:xfrm>
-          <a:prstGeom prst="rect">
-            <a:avLst/>
-          </a:prstGeom>
-          <a:noFill/>
-          <a:ln/>
-        </p:spPr>
-        <p:txBody>
-          <a:bodyPr wrap="square" lIns="0" tIns="0" rIns="0" bIns="0" rtlCol="0" anchor="ctr"/>
-          <a:lstStyle/>
-          <a:p>
-            <a:pPr marL="0" indent="0">
-              <a:buNone/>
-            </a:pPr>
-            <a:r>
-              <a:rPr lang="en-US" sz="800" kern="0" spc="200" dirty="0">
-                <a:solidFill>
-                  <a:srgbClr val="64748B"/>
-                </a:solidFill>
-                <a:latin typeface="Inter" pitchFamily="34" charset="0"/>
-                <a:ea typeface="Inter" pitchFamily="34" charset="-122"/>
-                <a:cs typeface="Inter" pitchFamily="34" charset="-120"/>
-              </a:rPr>
-              <a:t>03 · demo · moment 1</a:t>
-            </a:r>
-            <a:endParaRPr lang="en-US" sz="800" dirty="0"/>
-          </a:p>
-        </p:txBody>
-      </p:sp>
-      <p:sp>
-        <p:nvSpPr>
-          <p:cNvPr id="3" name="Text 1"/>
-          <p:cNvSpPr/>
-          <p:nvPr/>
-        </p:nvSpPr>
-        <p:spPr>
-          <a:xfrm>
-            <a:off x="8229600" y="4796028"/>
-            <a:ext cx="457200" cy="274320"/>
-          </a:xfrm>
-          <a:prstGeom prst="rect">
-            <a:avLst/>
-          </a:prstGeom>
-          <a:noFill/>
-          <a:ln/>
-        </p:spPr>
-        <p:txBody>
-          <a:bodyPr wrap="square" lIns="0" tIns="0" rIns="0" bIns="0" rtlCol="0" anchor="ctr"/>
-          <a:lstStyle/>
-          <a:p>
-            <a:pPr marL="0" indent="0" algn="r">
-              <a:buNone/>
-            </a:pPr>
-            <a:r>
-              <a:rPr lang="en-US" sz="800" dirty="0">
-                <a:solidFill>
-                  <a:srgbClr val="64748B"/>
-                </a:solidFill>
-                <a:latin typeface="Inter" pitchFamily="34" charset="0"/>
-                <a:ea typeface="Inter" pitchFamily="34" charset="-122"/>
-                <a:cs typeface="Inter" pitchFamily="34" charset="-120"/>
-              </a:rPr>
-              <a:t>15</a:t>
-            </a:r>
-            <a:endParaRPr lang="en-US" sz="800" dirty="0"/>
-          </a:p>
-        </p:txBody>
-      </p:sp>
-      <p:sp>
-        <p:nvSpPr>
-          <p:cNvPr id="4" name="Text 2"/>
-          <p:cNvSpPr/>
-          <p:nvPr/>
-        </p:nvSpPr>
-        <p:spPr>
-          <a:xfrm>
-            <a:off x="457200" y="384048"/>
-            <a:ext cx="8229600" cy="274320"/>
-          </a:xfrm>
-          <a:prstGeom prst="rect">
-            <a:avLst/>
-          </a:prstGeom>
-          <a:noFill/>
-          <a:ln/>
-        </p:spPr>
-        <p:txBody>
-          <a:bodyPr wrap="square" lIns="0" tIns="0" rIns="0" bIns="0" rtlCol="0" anchor="ctr"/>
-          <a:lstStyle/>
-          <a:p>
-            <a:pPr marL="0" indent="0">
-              <a:buNone/>
-            </a:pPr>
-            <a:r>
-              <a:rPr lang="en-US" sz="1000" b="1" kern="0" spc="300" dirty="0">
-                <a:solidFill>
-                  <a:srgbClr val="FBBF24"/>
-                </a:solidFill>
-                <a:latin typeface="Inter" pitchFamily="34" charset="0"/>
-                <a:ea typeface="Inter" pitchFamily="34" charset="-122"/>
-                <a:cs typeface="Inter" pitchFamily="34" charset="-120"/>
-              </a:rPr>
-              <a:t>MOMENT 1 OF 3</a:t>
-            </a:r>
-            <a:endParaRPr lang="en-US" sz="1000" dirty="0"/>
-          </a:p>
-        </p:txBody>
-      </p:sp>
-      <p:sp>
-        <p:nvSpPr>
-          <p:cNvPr id="5" name="Text 3"/>
-          <p:cNvSpPr/>
-          <p:nvPr/>
-        </p:nvSpPr>
-        <p:spPr>
-          <a:xfrm>
-            <a:off x="457200" y="1371600"/>
-            <a:ext cx="8229600" cy="731520"/>
-          </a:xfrm>
-          <a:prstGeom prst="rect">
-            <a:avLst/>
-          </a:prstGeom>
-          <a:noFill/>
-          <a:ln/>
-        </p:spPr>
-        <p:txBody>
-          <a:bodyPr wrap="square" lIns="0" tIns="0" rIns="0" bIns="0" rtlCol="0" anchor="ctr"/>
-          <a:lstStyle/>
-          <a:p>
-            <a:pPr marL="0" indent="0">
-              <a:buNone/>
-            </a:pPr>
-            <a:r>
-              <a:rPr lang="en-US" sz="3600" b="1" dirty="0">
-                <a:solidFill>
-                  <a:srgbClr val="F8FAFC"/>
-                </a:solidFill>
-                <a:latin typeface="Montserrat" pitchFamily="34" charset="0"/>
-                <a:ea typeface="Inter" pitchFamily="34" charset="-122"/>
-                <a:cs typeface="Inter" pitchFamily="34" charset="-120"/>
-              </a:rPr>
-              <a:t>total orchestration</a:t>
-            </a:r>
-            <a:endParaRPr lang="en-US" sz="3600" dirty="0"/>
-          </a:p>
-        </p:txBody>
-      </p:sp>
-      <p:sp>
-        <p:nvSpPr>
-          <p:cNvPr id="6" name="Shape 4"/>
-          <p:cNvSpPr/>
-          <p:nvPr/>
-        </p:nvSpPr>
-        <p:spPr>
-          <a:xfrm>
-            <a:off x="457200" y="2331720"/>
-            <a:ext cx="8229600" cy="777240"/>
-          </a:xfrm>
-          <a:prstGeom prst="roundRect">
-            <a:avLst>
-              <a:gd name="adj" fmla="val 7059"/>
-            </a:avLst>
-          </a:prstGeom>
-          <a:solidFill>
-            <a:srgbClr val="0A101F"/>
-          </a:solidFill>
-          <a:ln/>
-        </p:spPr>
-        <p:txBody>
-          <a:bodyPr/>
-          <a:lstStyle/>
-          <a:p>
-            <a:endParaRPr/>
-          </a:p>
-        </p:txBody>
-      </p:sp>
-      <p:sp>
-        <p:nvSpPr>
-          <p:cNvPr id="7" name="Text 5"/>
-          <p:cNvSpPr/>
-          <p:nvPr/>
-        </p:nvSpPr>
-        <p:spPr>
-          <a:xfrm>
-            <a:off x="640080" y="2331720"/>
-            <a:ext cx="7863840" cy="777240"/>
-          </a:xfrm>
-          <a:prstGeom prst="rect">
-            <a:avLst/>
-          </a:prstGeom>
-          <a:noFill/>
-          <a:ln/>
-        </p:spPr>
-        <p:txBody>
-          <a:bodyPr wrap="square" lIns="0" tIns="0" rIns="0" bIns="0" rtlCol="0" anchor="ctr"/>
-          <a:lstStyle/>
-          <a:p>
-            <a:pPr marL="0" indent="0">
-              <a:buNone/>
-            </a:pPr>
-            <a:r>
-              <a:rPr lang="en-US" sz="1200" dirty="0">
-                <a:solidFill>
-                  <a:srgbClr val="34D399"/>
-                </a:solidFill>
-                <a:latin typeface="Menlo" pitchFamily="34" charset="0"/>
-                <a:ea typeface="Menlo" pitchFamily="34" charset="-122"/>
-                <a:cs typeface="Menlo" pitchFamily="34" charset="-120"/>
-              </a:rPr>
-              <a:t>$ /implement  auto-promote the next waitlisted guest when a confirmed guest cancels</a:t>
-            </a:r>
-            <a:endParaRPr lang="en-US" sz="1200" dirty="0"/>
-          </a:p>
-        </p:txBody>
-      </p:sp>
-    </p:spTree>
-  </p:cSld>
-  <p:clrMapOvr>
-    <a:masterClrMapping/>
-  </p:clrMapOvr>
-</p:sld>
+<file path=ppt/slides/slide15.xml><?xml version="1.0" encoding="UTF-8" standalone="yes"?>
+<p:sld xmlns:a="http://schemas.openxmlformats.org/drawingml/2006/main" xmlns:r="http://schemas.openxmlformats.org/officeDocument/2006/relationships" xmlns:p="http://schemas.openxmlformats.org/presentationml/2006/main"><p:cSld name="Slide 15"><p:bg><p:bgPr><a:solidFill><a:srgbClr val="0F1729"/></a:solidFill><a:effectLst/></p:bgPr></p:bg><p:spTree><p:nvGrpSpPr><p:cNvPr id="1" name=""/><p:cNvGrpSpPr/><p:nvPr/></p:nvGrpSpPr><p:grpSpPr><a:xfrm><a:off x="0" y="0"/><a:ext cx="0" cy="0"/><a:chOff x="0" y="0"/><a:chExt cx="0" cy="0"/></a:xfrm></p:grpSpPr><p:sp><p:nvSpPr><p:cNvPr id="2" name="Text 0"/><p:cNvSpPr/><p:nvPr/></p:nvSpPr><p:spPr><a:xfrm><a:off x="457200" y="4796028"/><a:ext cx="4572000" cy="274320"/></a:xfrm><a:prstGeom prst="rect"><a:avLst/></a:prstGeom><a:noFill/><a:ln/></p:spPr><p:txBody><a:bodyPr wrap="square" lIns="0" tIns="0" rIns="0" bIns="0" rtlCol="0" anchor="ctr"/><a:lstStyle/><a:p><a:pPr marL="0" indent="0"><a:buNone/></a:pPr><a:r><a:rPr lang="en-US" sz="800" kern="0" spc="200" dirty="0"><a:solidFill><a:srgbClr val="64748B"/></a:solidFill><a:latin typeface="Inter" pitchFamily="34" charset="0"/><a:ea typeface="Inter" pitchFamily="34" charset="-122"/><a:cs typeface="Inter" pitchFamily="34" charset="-120"/></a:rPr><a:t>03 · demo · moment 1</a:t></a:r><a:endParaRPr lang="en-US" sz="800" dirty="0"/></a:p></p:txBody></p:sp><p:sp><p:nvSpPr><p:cNvPr id="3" name="Text 1"/><p:cNvSpPr/><p:nvPr/></p:nvSpPr><p:spPr><a:xfrm><a:off x="8229600" y="4796028"/><a:ext cx="457200" cy="274320"/></a:xfrm><a:prstGeom prst="rect"><a:avLst/></a:prstGeom><a:noFill/><a:ln/></p:spPr><p:txBody><a:bodyPr wrap="square" lIns="0" tIns="0" rIns="0" bIns="0" rtlCol="0" anchor="ctr"/><a:lstStyle/><a:p><a:pPr marL="0" indent="0" algn="r"><a:buNone/></a:pPr><a:r><a:rPr lang="en-US" sz="800" dirty="0"><a:solidFill><a:srgbClr val="64748B"/></a:solidFill><a:latin typeface="Inter" pitchFamily="34" charset="0"/><a:ea typeface="Inter" pitchFamily="34" charset="-122"/><a:cs typeface="Inter" pitchFamily="34" charset="-120"/></a:rPr><a:t>15</a:t></a:r><a:endParaRPr lang="en-US" sz="800" dirty="0"/></a:p></p:txBody></p:sp><p:sp><p:nvSpPr><p:cNvPr id="4" name="Text 2"/><p:cNvSpPr/><p:nvPr/></p:nvSpPr><p:spPr><a:xfrm><a:off x="457200" y="384048"/><a:ext cx="8229600" cy="274320"/></a:xfrm><a:prstGeom prst="rect"><a:avLst/></a:prstGeom><a:noFill/><a:ln/></p:spPr><p:txBody><a:bodyPr wrap="square" lIns="0" tIns="0" rIns="0" bIns="0" rtlCol="0" anchor="ctr"/><a:lstStyle/><a:p><a:pPr marL="0" indent="0"><a:buNone/></a:pPr><a:r><a:rPr lang="en-US" sz="1000" b="1" kern="0" spc="300" dirty="0"><a:solidFill><a:srgbClr val="FBBF24"/></a:solidFill><a:latin typeface="Inter" pitchFamily="34" charset="0"/><a:ea typeface="Inter" pitchFamily="34" charset="-122"/><a:cs typeface="Inter" pitchFamily="34" charset="-120"/></a:rPr><a:t>MOMENT 1 OF 3</a:t></a:r><a:endParaRPr lang="en-US" sz="1000" dirty="0"/></a:p></p:txBody></p:sp><p:sp><p:nvSpPr><p:cNvPr id="5" name="Text 3"/><p:cNvSpPr/><p:nvPr/></p:nvSpPr><p:spPr><a:xfrm><a:off x="457200" y="1371600"/><a:ext cx="8229600" cy="731520"/></a:xfrm><a:prstGeom prst="rect"><a:avLst/></a:prstGeom><a:noFill/><a:ln/></p:spPr><p:txBody><a:bodyPr wrap="square" lIns="0" tIns="0" rIns="0" bIns="0" rtlCol="0" anchor="ctr"/><a:lstStyle/><a:p><a:pPr marL="0" indent="0"><a:buNone/></a:pPr><a:r><a:rPr lang="en-US" sz="3600" b="1" dirty="0"><a:solidFill><a:srgbClr val="F8FAFC"/></a:solidFill><a:latin typeface="Montserrat" pitchFamily="34" charset="0"/><a:ea typeface="Inter" pitchFamily="34" charset="-122"/><a:cs typeface="Inter" pitchFamily="34" charset="-120"/></a:rPr><a:t>watch the team assemble</a:t></a:r><a:endParaRPr lang="en-US" sz="3600" dirty="0"/></a:p></p:txBody></p:sp><p:sp><p:nvSpPr><p:cNvPr id="6" name="Shape 4"/><p:cNvSpPr/><p:nvPr/></p:nvSpPr><p:spPr><a:xfrm><a:off x="457200" y="2331720"/><a:ext cx="8229600" cy="777240"/></a:xfrm><a:prstGeom prst="roundRect"><a:avLst><a:gd name="adj" fmla="val 7059"/></a:avLst></a:prstGeom><a:solidFill><a:srgbClr val="0A101F"/></a:solidFill><a:ln/></p:spPr><p:txBody><a:bodyPr/><a:lstStyle/><a:p><a:endParaRPr/></a:p></p:txBody></p:sp><p:sp><p:nvSpPr><p:cNvPr id="7" name="Text 5"/><p:cNvSpPr/><p:nvPr/></p:nvSpPr><p:spPr><a:xfrm><a:off x="640080" y="2331720"/><a:ext cx="7863840" cy="777240"/></a:xfrm><a:prstGeom prst="rect"><a:avLst/></a:prstGeom><a:noFill/><a:ln/></p:spPr><p:txBody><a:bodyPr wrap="square" lIns="0" tIns="0" rIns="0" bIns="0" rtlCol="0" anchor="ctr"/><a:lstStyle/><a:p><a:pPr marL="0" indent="0"><a:buNone/></a:pPr><a:r><a:rPr lang="en-US" sz="1200" dirty="0"><a:solidFill><a:srgbClr val="34D399"/></a:solidFill><a:latin typeface="Menlo" pitchFamily="34" charset="0"/><a:ea typeface="Menlo" pitchFamily="34" charset="-122"/><a:cs typeface="Menlo" pitchFamily="34" charset="-120"/></a:rPr><a:t>$ /implement  auto-promote the next waitlisted guest when a confirmed guest cancels</a:t></a:r><a:endParaRPr lang="en-US" sz="1200" dirty="0"/></a:p><a:p><a:pPr marL="0" indent="0"><a:buNone/></a:pPr><a:r><a:rPr lang="en-US" sz="1000" dirty="0"><a:solidFill><a:srgbClr val="94A3B8"/></a:solidFill><a:latin typeface="Menlo" pitchFamily="34" charset="0"/><a:ea typeface="Menlo" pitchFamily="34" charset="-122"/><a:cs typeface="Menlo" pitchFamily="34" charset="-120"/></a:rPr><a:t>→ the team: code-reviewer · security-auditor · test-writer  (in parallel)</a:t><a:endParaRPr lang="en-US" sz="1000" dirty="0"/></a:p></p:txBody></p:sp></p:spTree></p:cSld><p:clrMapOvr><a:masterClrMapping/></p:clrMapOvr></p:sld>
 </file>
 
 <file path=ppt/slides/slide16.xml><?xml version="1.0" encoding="utf-8"?>
@@ -7511,7 +7258,7 @@
                 <a:ea typeface="Inter" pitchFamily="34" charset="-122"/>
                 <a:cs typeface="Inter" pitchFamily="34" charset="-120"/>
               </a:rPr>
-              <a:t>full autonomy, overnight</a:t>
+              <a:t>full autonomy — the team works overnight</a:t>
             </a:r>
             <a:endParaRPr lang="en-US" sz="3600" dirty="0"/>
           </a:p>

</xml_diff>

<commit_message>
feat: redesign demo moments around the specialist team (#37)
- /implement: add Phase 1.5 "convene the specialist team" — after a feature is
  implemented, fan out code-reviewer + security-auditor + test-writer (and
  frontend-reviewer / migration-reviewer when relevant) IN PARALLEL via the Task
  tool, each in its own context. Adds Task to allowed-tools. Makes the demo's
  Moment 1 "the team assembles" real on screen.
- deck (slides 15-17 + FR notes): M1 → "watch the team assemble" + names the
  three specialists; M2 note → the security-auditor subagent catches the S2 leak;
  M3 → "the team works overnight" via real /work-issues. Notes rewritten in French.

Co-authored-by: dev-servicecat <dev@servicecat.local>
Co-authored-by: Claude Opus 4.8 (1M context) <noreply@anthropic.com>
</commit_message>
<xml_diff>
--- a/orchestrer-intelligence-gatherly.pptx
+++ b/orchestrer-intelligence-gatherly.pptx
@@ -827,8 +827,8 @@
           <a:lstStyle/>
           <a:p>
             <a:r>
-              <a:rPr lang="en-US" dirty="0"/>
-              <a:t>Moment 1 : une seule commande, l'orchestrateur fait le reste. Narrer les invocations à voix haute. DÉBRIEF À L'ORAL (la slide récap a été coupée, format 20 min) : 1 orchestrateur, 7 spécialistes invoqués ; critères d'acceptation définis au départ, vérifiés à la fin ; 1 race condition attrapée par /review-pr avant commit ; PR ouverte, CI verte, ~8 minutes. Punchline : personne n'a choisi les spécialistes — le routage est dans le système.</a:t>
+              <a:rPr lang="fr-FR" dirty="0"/>
+              <a:t>Moment 1 — « l'équipe s'assemble ». Une seule commande : /implement. L'orchestrateur planifie, explore, implémente, puis FAIT APPEL À TROIS SPÉCIALISTES EN PARALLÈLE — code-reviewer, security-auditor, test-writer — chacun dans son propre contexte. Narrer les invocations à voix haute pendant qu'elles apparaissent à l'écran. DÉBRIEF À L'ORAL : critères d'acceptation définis au départ et vérifiés à la fin ; les trois spécialistes reviennent verts (relecture LGTM, audit CLEAN, tests ≥ 80 % sur le nouveau code) ; PR ouverte, CI verte, ~8 minutes. Punchline : « Je n'ai jamais dit quel spécialiste utiliser — l'orchestrateur a assemblé l'équipe. Ce n'est pas de l'autocomplétion, c'est une équipe. »</a:t>
             </a:r>
           </a:p>
         </p:txBody>
@@ -914,8 +914,8 @@
           <a:lstStyle/>
           <a:p>
             <a:r>
-              <a:rPr lang="en-US" dirty="0"/>
-              <a:t>Moment 2 : montrer l'échec volontaire. Transparence : annoncer que l'erreur est pré-injectée — ça renforce la crédibilité. DÉBRIEF À L'ORAL : /audit-security (et le test d'isolation) a signalé la fuite de confidentialité en quelques secondes ; la boucle de fix a restauré le contrôle de propriété manquant ; re-audit propre, commit passé — zéro humain impliqué. Punchline : le système a attrapé sa propre erreur avant qu'un humain voie le code. Si on demande « et si le fix échoue 3 fois ? » → moment 3 le montre.</a:t>
+              <a:rPr lang="fr-FR" dirty="0"/>
+              <a:t>Moment 2 — « l'équipe s'attrape elle-même ». Montrer l'échec volontaire ; annoncer que la faille est pré-injectée (un invité pouvait lire la liste d'invités d'un autre organisateur) — la transparence renforce la crédibilité. À l'écran : le subagent security-auditor (lecture seule, contexte isolé) signale la violation S2 (isolation des locataires) avec preuve fichier:ligne en quelques secondes → la barrière BLOQUE le commit → la boucle de fix interne rétablit le contrôle de propriété manquant → re-audit propre. Punchline : « L'auditeur est un spécialiste à part : outils en lecture seule, son propre contexte. Il ne peut pas modifier votre code, et on ne peut pas le convaincre d'ignorer une faille. Il a attrapé la fuite avant qu'un humain voie le code. Zéro humain. » Si on demande « et si le fix échoue 3 fois ? » → c'est exactement le moment 3.</a:t>
             </a:r>
           </a:p>
         </p:txBody>
@@ -1001,8 +1001,8 @@
           <a:lstStyle/>
           <a:p>
             <a:r>
-              <a:rPr lang="en-US" dirty="0"/>
-              <a:t>Moment 3 : la nuit en timelapse. C'est ici que « agent à la demande » prend tout son sens : le système s'est réveillé pour chaque écart de préparation, a travaillé, s'est arrêté. Enchaîner directement sur la slide résultats (7 PRs + 1 escalade).</a:t>
+              <a:rPr lang="fr-FR" dirty="0"/>
+              <a:t>Moment 3 — « l'équipe travaille pendant que vous dormez ». Autonomie complète, et c'est RÉEL sur ce dépôt : /work-issues tourne en headless, planifié, la nuit. Montrer le run de la nuit dernière en timelapse, puis la liste des PR sur GitHub. Chaque écart est passé dans la boucle complète AVEC l'équipe de spécialistes → 7 PR ouvertes, 1 escalade marquée « needs-human » avec trace complète après 3 tentatives. Punchline : « Huit écarts, huit heures, sans supervision. Sept corrigés et mis en PR. Un qu'il n'a pas su résoudre — alors il s'est arrêté et a tagué un humain. L'escalade, c'est l'essentiel : un système qui sait s'arrêter est le seul qu'on peut déployer. » (Backup : avoir le timelapse enregistré — impossible de lancer un run de 8 h en direct.)</a:t>
             </a:r>
           </a:p>
         </p:txBody>
@@ -6812,261 +6812,8 @@
 </p:sld>
 </file>
 
-<file path=ppt/slides/slide15.xml><?xml version="1.0" encoding="utf-8"?>
-<p:sld xmlns:a="http://schemas.openxmlformats.org/drawingml/2006/main" xmlns:r="http://schemas.openxmlformats.org/officeDocument/2006/relationships" xmlns:p="http://schemas.openxmlformats.org/presentationml/2006/main">
-  <p:cSld name="Slide 15">
-    <p:bg>
-      <p:bgPr>
-        <a:solidFill>
-          <a:srgbClr val="0F1729"/>
-        </a:solidFill>
-        <a:effectLst/>
-      </p:bgPr>
-    </p:bg>
-    <p:spTree>
-      <p:nvGrpSpPr>
-        <p:cNvPr id="1" name=""/>
-        <p:cNvGrpSpPr/>
-        <p:nvPr/>
-      </p:nvGrpSpPr>
-      <p:grpSpPr>
-        <a:xfrm>
-          <a:off x="0" y="0"/>
-          <a:ext cx="0" cy="0"/>
-          <a:chOff x="0" y="0"/>
-          <a:chExt cx="0" cy="0"/>
-        </a:xfrm>
-      </p:grpSpPr>
-      <p:sp>
-        <p:nvSpPr>
-          <p:cNvPr id="2" name="Text 0"/>
-          <p:cNvSpPr/>
-          <p:nvPr/>
-        </p:nvSpPr>
-        <p:spPr>
-          <a:xfrm>
-            <a:off x="457200" y="4796028"/>
-            <a:ext cx="4572000" cy="274320"/>
-          </a:xfrm>
-          <a:prstGeom prst="rect">
-            <a:avLst/>
-          </a:prstGeom>
-          <a:noFill/>
-          <a:ln/>
-        </p:spPr>
-        <p:txBody>
-          <a:bodyPr wrap="square" lIns="0" tIns="0" rIns="0" bIns="0" rtlCol="0" anchor="ctr"/>
-          <a:lstStyle/>
-          <a:p>
-            <a:pPr marL="0" indent="0">
-              <a:buNone/>
-            </a:pPr>
-            <a:r>
-              <a:rPr lang="en-US" sz="800" kern="0" spc="200" dirty="0">
-                <a:solidFill>
-                  <a:srgbClr val="64748B"/>
-                </a:solidFill>
-                <a:latin typeface="Inter" pitchFamily="34" charset="0"/>
-                <a:ea typeface="Inter" pitchFamily="34" charset="-122"/>
-                <a:cs typeface="Inter" pitchFamily="34" charset="-120"/>
-              </a:rPr>
-              <a:t>03 · demo · moment 1</a:t>
-            </a:r>
-            <a:endParaRPr lang="en-US" sz="800" dirty="0"/>
-          </a:p>
-        </p:txBody>
-      </p:sp>
-      <p:sp>
-        <p:nvSpPr>
-          <p:cNvPr id="3" name="Text 1"/>
-          <p:cNvSpPr/>
-          <p:nvPr/>
-        </p:nvSpPr>
-        <p:spPr>
-          <a:xfrm>
-            <a:off x="8229600" y="4796028"/>
-            <a:ext cx="457200" cy="274320"/>
-          </a:xfrm>
-          <a:prstGeom prst="rect">
-            <a:avLst/>
-          </a:prstGeom>
-          <a:noFill/>
-          <a:ln/>
-        </p:spPr>
-        <p:txBody>
-          <a:bodyPr wrap="square" lIns="0" tIns="0" rIns="0" bIns="0" rtlCol="0" anchor="ctr"/>
-          <a:lstStyle/>
-          <a:p>
-            <a:pPr marL="0" indent="0" algn="r">
-              <a:buNone/>
-            </a:pPr>
-            <a:r>
-              <a:rPr lang="en-US" sz="800" dirty="0">
-                <a:solidFill>
-                  <a:srgbClr val="64748B"/>
-                </a:solidFill>
-                <a:latin typeface="Inter" pitchFamily="34" charset="0"/>
-                <a:ea typeface="Inter" pitchFamily="34" charset="-122"/>
-                <a:cs typeface="Inter" pitchFamily="34" charset="-120"/>
-              </a:rPr>
-              <a:t>15</a:t>
-            </a:r>
-            <a:endParaRPr lang="en-US" sz="800" dirty="0"/>
-          </a:p>
-        </p:txBody>
-      </p:sp>
-      <p:sp>
-        <p:nvSpPr>
-          <p:cNvPr id="4" name="Text 2"/>
-          <p:cNvSpPr/>
-          <p:nvPr/>
-        </p:nvSpPr>
-        <p:spPr>
-          <a:xfrm>
-            <a:off x="457200" y="384048"/>
-            <a:ext cx="8229600" cy="274320"/>
-          </a:xfrm>
-          <a:prstGeom prst="rect">
-            <a:avLst/>
-          </a:prstGeom>
-          <a:noFill/>
-          <a:ln/>
-        </p:spPr>
-        <p:txBody>
-          <a:bodyPr wrap="square" lIns="0" tIns="0" rIns="0" bIns="0" rtlCol="0" anchor="ctr"/>
-          <a:lstStyle/>
-          <a:p>
-            <a:pPr marL="0" indent="0">
-              <a:buNone/>
-            </a:pPr>
-            <a:r>
-              <a:rPr lang="en-US" sz="1000" b="1" kern="0" spc="300" dirty="0">
-                <a:solidFill>
-                  <a:srgbClr val="FBBF24"/>
-                </a:solidFill>
-                <a:latin typeface="Inter" pitchFamily="34" charset="0"/>
-                <a:ea typeface="Inter" pitchFamily="34" charset="-122"/>
-                <a:cs typeface="Inter" pitchFamily="34" charset="-120"/>
-              </a:rPr>
-              <a:t>MOMENT 1 OF 3</a:t>
-            </a:r>
-            <a:endParaRPr lang="en-US" sz="1000" dirty="0"/>
-          </a:p>
-        </p:txBody>
-      </p:sp>
-      <p:sp>
-        <p:nvSpPr>
-          <p:cNvPr id="5" name="Text 3"/>
-          <p:cNvSpPr/>
-          <p:nvPr/>
-        </p:nvSpPr>
-        <p:spPr>
-          <a:xfrm>
-            <a:off x="457200" y="1371600"/>
-            <a:ext cx="8229600" cy="731520"/>
-          </a:xfrm>
-          <a:prstGeom prst="rect">
-            <a:avLst/>
-          </a:prstGeom>
-          <a:noFill/>
-          <a:ln/>
-        </p:spPr>
-        <p:txBody>
-          <a:bodyPr wrap="square" lIns="0" tIns="0" rIns="0" bIns="0" rtlCol="0" anchor="ctr"/>
-          <a:lstStyle/>
-          <a:p>
-            <a:pPr marL="0" indent="0">
-              <a:buNone/>
-            </a:pPr>
-            <a:r>
-              <a:rPr lang="en-US" sz="3600" b="1" dirty="0">
-                <a:solidFill>
-                  <a:srgbClr val="F8FAFC"/>
-                </a:solidFill>
-                <a:latin typeface="Montserrat" pitchFamily="34" charset="0"/>
-                <a:ea typeface="Inter" pitchFamily="34" charset="-122"/>
-                <a:cs typeface="Inter" pitchFamily="34" charset="-120"/>
-              </a:rPr>
-              <a:t>total orchestration</a:t>
-            </a:r>
-            <a:endParaRPr lang="en-US" sz="3600" dirty="0"/>
-          </a:p>
-        </p:txBody>
-      </p:sp>
-      <p:sp>
-        <p:nvSpPr>
-          <p:cNvPr id="6" name="Shape 4"/>
-          <p:cNvSpPr/>
-          <p:nvPr/>
-        </p:nvSpPr>
-        <p:spPr>
-          <a:xfrm>
-            <a:off x="457200" y="2331720"/>
-            <a:ext cx="8229600" cy="777240"/>
-          </a:xfrm>
-          <a:prstGeom prst="roundRect">
-            <a:avLst>
-              <a:gd name="adj" fmla="val 7059"/>
-            </a:avLst>
-          </a:prstGeom>
-          <a:solidFill>
-            <a:srgbClr val="0A101F"/>
-          </a:solidFill>
-          <a:ln/>
-        </p:spPr>
-        <p:txBody>
-          <a:bodyPr/>
-          <a:lstStyle/>
-          <a:p>
-            <a:endParaRPr/>
-          </a:p>
-        </p:txBody>
-      </p:sp>
-      <p:sp>
-        <p:nvSpPr>
-          <p:cNvPr id="7" name="Text 5"/>
-          <p:cNvSpPr/>
-          <p:nvPr/>
-        </p:nvSpPr>
-        <p:spPr>
-          <a:xfrm>
-            <a:off x="640080" y="2331720"/>
-            <a:ext cx="7863840" cy="777240"/>
-          </a:xfrm>
-          <a:prstGeom prst="rect">
-            <a:avLst/>
-          </a:prstGeom>
-          <a:noFill/>
-          <a:ln/>
-        </p:spPr>
-        <p:txBody>
-          <a:bodyPr wrap="square" lIns="0" tIns="0" rIns="0" bIns="0" rtlCol="0" anchor="ctr"/>
-          <a:lstStyle/>
-          <a:p>
-            <a:pPr marL="0" indent="0">
-              <a:buNone/>
-            </a:pPr>
-            <a:r>
-              <a:rPr lang="en-US" sz="1200" dirty="0">
-                <a:solidFill>
-                  <a:srgbClr val="34D399"/>
-                </a:solidFill>
-                <a:latin typeface="Menlo" pitchFamily="34" charset="0"/>
-                <a:ea typeface="Menlo" pitchFamily="34" charset="-122"/>
-                <a:cs typeface="Menlo" pitchFamily="34" charset="-120"/>
-              </a:rPr>
-              <a:t>$ /implement  auto-promote the next waitlisted guest when a confirmed guest cancels</a:t>
-            </a:r>
-            <a:endParaRPr lang="en-US" sz="1200" dirty="0"/>
-          </a:p>
-        </p:txBody>
-      </p:sp>
-    </p:spTree>
-  </p:cSld>
-  <p:clrMapOvr>
-    <a:masterClrMapping/>
-  </p:clrMapOvr>
-</p:sld>
+<file path=ppt/slides/slide15.xml><?xml version="1.0" encoding="UTF-8" standalone="yes"?>
+<p:sld xmlns:a="http://schemas.openxmlformats.org/drawingml/2006/main" xmlns:r="http://schemas.openxmlformats.org/officeDocument/2006/relationships" xmlns:p="http://schemas.openxmlformats.org/presentationml/2006/main"><p:cSld name="Slide 15"><p:bg><p:bgPr><a:solidFill><a:srgbClr val="0F1729"/></a:solidFill><a:effectLst/></p:bgPr></p:bg><p:spTree><p:nvGrpSpPr><p:cNvPr id="1" name=""/><p:cNvGrpSpPr/><p:nvPr/></p:nvGrpSpPr><p:grpSpPr><a:xfrm><a:off x="0" y="0"/><a:ext cx="0" cy="0"/><a:chOff x="0" y="0"/><a:chExt cx="0" cy="0"/></a:xfrm></p:grpSpPr><p:sp><p:nvSpPr><p:cNvPr id="2" name="Text 0"/><p:cNvSpPr/><p:nvPr/></p:nvSpPr><p:spPr><a:xfrm><a:off x="457200" y="4796028"/><a:ext cx="4572000" cy="274320"/></a:xfrm><a:prstGeom prst="rect"><a:avLst/></a:prstGeom><a:noFill/><a:ln/></p:spPr><p:txBody><a:bodyPr wrap="square" lIns="0" tIns="0" rIns="0" bIns="0" rtlCol="0" anchor="ctr"/><a:lstStyle/><a:p><a:pPr marL="0" indent="0"><a:buNone/></a:pPr><a:r><a:rPr lang="en-US" sz="800" kern="0" spc="200" dirty="0"><a:solidFill><a:srgbClr val="64748B"/></a:solidFill><a:latin typeface="Inter" pitchFamily="34" charset="0"/><a:ea typeface="Inter" pitchFamily="34" charset="-122"/><a:cs typeface="Inter" pitchFamily="34" charset="-120"/></a:rPr><a:t>03 · demo · moment 1</a:t></a:r><a:endParaRPr lang="en-US" sz="800" dirty="0"/></a:p></p:txBody></p:sp><p:sp><p:nvSpPr><p:cNvPr id="3" name="Text 1"/><p:cNvSpPr/><p:nvPr/></p:nvSpPr><p:spPr><a:xfrm><a:off x="8229600" y="4796028"/><a:ext cx="457200" cy="274320"/></a:xfrm><a:prstGeom prst="rect"><a:avLst/></a:prstGeom><a:noFill/><a:ln/></p:spPr><p:txBody><a:bodyPr wrap="square" lIns="0" tIns="0" rIns="0" bIns="0" rtlCol="0" anchor="ctr"/><a:lstStyle/><a:p><a:pPr marL="0" indent="0" algn="r"><a:buNone/></a:pPr><a:r><a:rPr lang="en-US" sz="800" dirty="0"><a:solidFill><a:srgbClr val="64748B"/></a:solidFill><a:latin typeface="Inter" pitchFamily="34" charset="0"/><a:ea typeface="Inter" pitchFamily="34" charset="-122"/><a:cs typeface="Inter" pitchFamily="34" charset="-120"/></a:rPr><a:t>15</a:t></a:r><a:endParaRPr lang="en-US" sz="800" dirty="0"/></a:p></p:txBody></p:sp><p:sp><p:nvSpPr><p:cNvPr id="4" name="Text 2"/><p:cNvSpPr/><p:nvPr/></p:nvSpPr><p:spPr><a:xfrm><a:off x="457200" y="384048"/><a:ext cx="8229600" cy="274320"/></a:xfrm><a:prstGeom prst="rect"><a:avLst/></a:prstGeom><a:noFill/><a:ln/></p:spPr><p:txBody><a:bodyPr wrap="square" lIns="0" tIns="0" rIns="0" bIns="0" rtlCol="0" anchor="ctr"/><a:lstStyle/><a:p><a:pPr marL="0" indent="0"><a:buNone/></a:pPr><a:r><a:rPr lang="en-US" sz="1000" b="1" kern="0" spc="300" dirty="0"><a:solidFill><a:srgbClr val="FBBF24"/></a:solidFill><a:latin typeface="Inter" pitchFamily="34" charset="0"/><a:ea typeface="Inter" pitchFamily="34" charset="-122"/><a:cs typeface="Inter" pitchFamily="34" charset="-120"/></a:rPr><a:t>MOMENT 1 OF 3</a:t></a:r><a:endParaRPr lang="en-US" sz="1000" dirty="0"/></a:p></p:txBody></p:sp><p:sp><p:nvSpPr><p:cNvPr id="5" name="Text 3"/><p:cNvSpPr/><p:nvPr/></p:nvSpPr><p:spPr><a:xfrm><a:off x="457200" y="1371600"/><a:ext cx="8229600" cy="731520"/></a:xfrm><a:prstGeom prst="rect"><a:avLst/></a:prstGeom><a:noFill/><a:ln/></p:spPr><p:txBody><a:bodyPr wrap="square" lIns="0" tIns="0" rIns="0" bIns="0" rtlCol="0" anchor="ctr"/><a:lstStyle/><a:p><a:pPr marL="0" indent="0"><a:buNone/></a:pPr><a:r><a:rPr lang="en-US" sz="3600" b="1" dirty="0"><a:solidFill><a:srgbClr val="F8FAFC"/></a:solidFill><a:latin typeface="Montserrat" pitchFamily="34" charset="0"/><a:ea typeface="Inter" pitchFamily="34" charset="-122"/><a:cs typeface="Inter" pitchFamily="34" charset="-120"/></a:rPr><a:t>watch the team assemble</a:t></a:r><a:endParaRPr lang="en-US" sz="3600" dirty="0"/></a:p></p:txBody></p:sp><p:sp><p:nvSpPr><p:cNvPr id="6" name="Shape 4"/><p:cNvSpPr/><p:nvPr/></p:nvSpPr><p:spPr><a:xfrm><a:off x="457200" y="2331720"/><a:ext cx="8229600" cy="777240"/></a:xfrm><a:prstGeom prst="roundRect"><a:avLst><a:gd name="adj" fmla="val 7059"/></a:avLst></a:prstGeom><a:solidFill><a:srgbClr val="0A101F"/></a:solidFill><a:ln/></p:spPr><p:txBody><a:bodyPr/><a:lstStyle/><a:p><a:endParaRPr/></a:p></p:txBody></p:sp><p:sp><p:nvSpPr><p:cNvPr id="7" name="Text 5"/><p:cNvSpPr/><p:nvPr/></p:nvSpPr><p:spPr><a:xfrm><a:off x="640080" y="2331720"/><a:ext cx="7863840" cy="777240"/></a:xfrm><a:prstGeom prst="rect"><a:avLst/></a:prstGeom><a:noFill/><a:ln/></p:spPr><p:txBody><a:bodyPr wrap="square" lIns="0" tIns="0" rIns="0" bIns="0" rtlCol="0" anchor="ctr"/><a:lstStyle/><a:p><a:pPr marL="0" indent="0"><a:buNone/></a:pPr><a:r><a:rPr lang="en-US" sz="1200" dirty="0"><a:solidFill><a:srgbClr val="34D399"/></a:solidFill><a:latin typeface="Menlo" pitchFamily="34" charset="0"/><a:ea typeface="Menlo" pitchFamily="34" charset="-122"/><a:cs typeface="Menlo" pitchFamily="34" charset="-120"/></a:rPr><a:t>$ /implement  auto-promote the next waitlisted guest when a confirmed guest cancels</a:t></a:r><a:endParaRPr lang="en-US" sz="1200" dirty="0"/></a:p><a:p><a:pPr marL="0" indent="0"><a:buNone/></a:pPr><a:r><a:rPr lang="en-US" sz="1000" dirty="0"><a:solidFill><a:srgbClr val="94A3B8"/></a:solidFill><a:latin typeface="Menlo" pitchFamily="34" charset="0"/><a:ea typeface="Menlo" pitchFamily="34" charset="-122"/><a:cs typeface="Menlo" pitchFamily="34" charset="-120"/></a:rPr><a:t>→ the team: code-reviewer · security-auditor · test-writer  (in parallel)</a:t><a:endParaRPr lang="en-US" sz="1000" dirty="0"/></a:p></p:txBody></p:sp></p:spTree></p:cSld><p:clrMapOvr><a:masterClrMapping/></p:clrMapOvr></p:sld>
 </file>
 
 <file path=ppt/slides/slide16.xml><?xml version="1.0" encoding="utf-8"?>
@@ -7511,7 +7258,7 @@
                 <a:ea typeface="Inter" pitchFamily="34" charset="-122"/>
                 <a:cs typeface="Inter" pitchFamily="34" charset="-120"/>
               </a:rPr>
-              <a:t>full autonomy, overnight</a:t>
+              <a:t>full autonomy — the team works overnight</a:t>
             </a:r>
             <a:endParaRPr lang="en-US" sz="3600" dirty="0"/>
           </a:p>

</xml_diff>

<commit_message>
fix(deck): repair malformed slide 15 XML (PowerPoint repair prompt)
The demo-moments edit (#37) added the "→ the team: …" line to slide 15 but
dropped the run's closing </a:r>, leaving mismatched tags. The zip stayed valid
so it passed checks, but PowerPoint's schema validator rejected it ("detected a
problem… Repair"). Adds the missing </a:r>; all 114 parts now parse. Redesign
content unchanged.

Co-Authored-By: Claude Opus 4.8 (1M context) <noreply@anthropic.com>
</commit_message>
<xml_diff>
--- a/orchestrer-intelligence-gatherly.pptx
+++ b/orchestrer-intelligence-gatherly.pptx
@@ -6812,8 +6812,278 @@
 </p:sld>
 </file>
 
-<file path=ppt/slides/slide15.xml><?xml version="1.0" encoding="UTF-8" standalone="yes"?>
-<p:sld xmlns:a="http://schemas.openxmlformats.org/drawingml/2006/main" xmlns:r="http://schemas.openxmlformats.org/officeDocument/2006/relationships" xmlns:p="http://schemas.openxmlformats.org/presentationml/2006/main"><p:cSld name="Slide 15"><p:bg><p:bgPr><a:solidFill><a:srgbClr val="0F1729"/></a:solidFill><a:effectLst/></p:bgPr></p:bg><p:spTree><p:nvGrpSpPr><p:cNvPr id="1" name=""/><p:cNvGrpSpPr/><p:nvPr/></p:nvGrpSpPr><p:grpSpPr><a:xfrm><a:off x="0" y="0"/><a:ext cx="0" cy="0"/><a:chOff x="0" y="0"/><a:chExt cx="0" cy="0"/></a:xfrm></p:grpSpPr><p:sp><p:nvSpPr><p:cNvPr id="2" name="Text 0"/><p:cNvSpPr/><p:nvPr/></p:nvSpPr><p:spPr><a:xfrm><a:off x="457200" y="4796028"/><a:ext cx="4572000" cy="274320"/></a:xfrm><a:prstGeom prst="rect"><a:avLst/></a:prstGeom><a:noFill/><a:ln/></p:spPr><p:txBody><a:bodyPr wrap="square" lIns="0" tIns="0" rIns="0" bIns="0" rtlCol="0" anchor="ctr"/><a:lstStyle/><a:p><a:pPr marL="0" indent="0"><a:buNone/></a:pPr><a:r><a:rPr lang="en-US" sz="800" kern="0" spc="200" dirty="0"><a:solidFill><a:srgbClr val="64748B"/></a:solidFill><a:latin typeface="Inter" pitchFamily="34" charset="0"/><a:ea typeface="Inter" pitchFamily="34" charset="-122"/><a:cs typeface="Inter" pitchFamily="34" charset="-120"/></a:rPr><a:t>03 · demo · moment 1</a:t></a:r><a:endParaRPr lang="en-US" sz="800" dirty="0"/></a:p></p:txBody></p:sp><p:sp><p:nvSpPr><p:cNvPr id="3" name="Text 1"/><p:cNvSpPr/><p:nvPr/></p:nvSpPr><p:spPr><a:xfrm><a:off x="8229600" y="4796028"/><a:ext cx="457200" cy="274320"/></a:xfrm><a:prstGeom prst="rect"><a:avLst/></a:prstGeom><a:noFill/><a:ln/></p:spPr><p:txBody><a:bodyPr wrap="square" lIns="0" tIns="0" rIns="0" bIns="0" rtlCol="0" anchor="ctr"/><a:lstStyle/><a:p><a:pPr marL="0" indent="0" algn="r"><a:buNone/></a:pPr><a:r><a:rPr lang="en-US" sz="800" dirty="0"><a:solidFill><a:srgbClr val="64748B"/></a:solidFill><a:latin typeface="Inter" pitchFamily="34" charset="0"/><a:ea typeface="Inter" pitchFamily="34" charset="-122"/><a:cs typeface="Inter" pitchFamily="34" charset="-120"/></a:rPr><a:t>15</a:t></a:r><a:endParaRPr lang="en-US" sz="800" dirty="0"/></a:p></p:txBody></p:sp><p:sp><p:nvSpPr><p:cNvPr id="4" name="Text 2"/><p:cNvSpPr/><p:nvPr/></p:nvSpPr><p:spPr><a:xfrm><a:off x="457200" y="384048"/><a:ext cx="8229600" cy="274320"/></a:xfrm><a:prstGeom prst="rect"><a:avLst/></a:prstGeom><a:noFill/><a:ln/></p:spPr><p:txBody><a:bodyPr wrap="square" lIns="0" tIns="0" rIns="0" bIns="0" rtlCol="0" anchor="ctr"/><a:lstStyle/><a:p><a:pPr marL="0" indent="0"><a:buNone/></a:pPr><a:r><a:rPr lang="en-US" sz="1000" b="1" kern="0" spc="300" dirty="0"><a:solidFill><a:srgbClr val="FBBF24"/></a:solidFill><a:latin typeface="Inter" pitchFamily="34" charset="0"/><a:ea typeface="Inter" pitchFamily="34" charset="-122"/><a:cs typeface="Inter" pitchFamily="34" charset="-120"/></a:rPr><a:t>MOMENT 1 OF 3</a:t></a:r><a:endParaRPr lang="en-US" sz="1000" dirty="0"/></a:p></p:txBody></p:sp><p:sp><p:nvSpPr><p:cNvPr id="5" name="Text 3"/><p:cNvSpPr/><p:nvPr/></p:nvSpPr><p:spPr><a:xfrm><a:off x="457200" y="1371600"/><a:ext cx="8229600" cy="731520"/></a:xfrm><a:prstGeom prst="rect"><a:avLst/></a:prstGeom><a:noFill/><a:ln/></p:spPr><p:txBody><a:bodyPr wrap="square" lIns="0" tIns="0" rIns="0" bIns="0" rtlCol="0" anchor="ctr"/><a:lstStyle/><a:p><a:pPr marL="0" indent="0"><a:buNone/></a:pPr><a:r><a:rPr lang="en-US" sz="3600" b="1" dirty="0"><a:solidFill><a:srgbClr val="F8FAFC"/></a:solidFill><a:latin typeface="Montserrat" pitchFamily="34" charset="0"/><a:ea typeface="Inter" pitchFamily="34" charset="-122"/><a:cs typeface="Inter" pitchFamily="34" charset="-120"/></a:rPr><a:t>watch the team assemble</a:t></a:r><a:endParaRPr lang="en-US" sz="3600" dirty="0"/></a:p></p:txBody></p:sp><p:sp><p:nvSpPr><p:cNvPr id="6" name="Shape 4"/><p:cNvSpPr/><p:nvPr/></p:nvSpPr><p:spPr><a:xfrm><a:off x="457200" y="2331720"/><a:ext cx="8229600" cy="777240"/></a:xfrm><a:prstGeom prst="roundRect"><a:avLst><a:gd name="adj" fmla="val 7059"/></a:avLst></a:prstGeom><a:solidFill><a:srgbClr val="0A101F"/></a:solidFill><a:ln/></p:spPr><p:txBody><a:bodyPr/><a:lstStyle/><a:p><a:endParaRPr/></a:p></p:txBody></p:sp><p:sp><p:nvSpPr><p:cNvPr id="7" name="Text 5"/><p:cNvSpPr/><p:nvPr/></p:nvSpPr><p:spPr><a:xfrm><a:off x="640080" y="2331720"/><a:ext cx="7863840" cy="777240"/></a:xfrm><a:prstGeom prst="rect"><a:avLst/></a:prstGeom><a:noFill/><a:ln/></p:spPr><p:txBody><a:bodyPr wrap="square" lIns="0" tIns="0" rIns="0" bIns="0" rtlCol="0" anchor="ctr"/><a:lstStyle/><a:p><a:pPr marL="0" indent="0"><a:buNone/></a:pPr><a:r><a:rPr lang="en-US" sz="1200" dirty="0"><a:solidFill><a:srgbClr val="34D399"/></a:solidFill><a:latin typeface="Menlo" pitchFamily="34" charset="0"/><a:ea typeface="Menlo" pitchFamily="34" charset="-122"/><a:cs typeface="Menlo" pitchFamily="34" charset="-120"/></a:rPr><a:t>$ /implement  auto-promote the next waitlisted guest when a confirmed guest cancels</a:t></a:r><a:endParaRPr lang="en-US" sz="1200" dirty="0"/></a:p><a:p><a:pPr marL="0" indent="0"><a:buNone/></a:pPr><a:r><a:rPr lang="en-US" sz="1000" dirty="0"><a:solidFill><a:srgbClr val="94A3B8"/></a:solidFill><a:latin typeface="Menlo" pitchFamily="34" charset="0"/><a:ea typeface="Menlo" pitchFamily="34" charset="-122"/><a:cs typeface="Menlo" pitchFamily="34" charset="-120"/></a:rPr><a:t>→ the team: code-reviewer · security-auditor · test-writer  (in parallel)</a:t><a:endParaRPr lang="en-US" sz="1000" dirty="0"/></a:p></p:txBody></p:sp></p:spTree></p:cSld><p:clrMapOvr><a:masterClrMapping/></p:clrMapOvr></p:sld>
+<file path=ppt/slides/slide15.xml><?xml version="1.0" encoding="utf-8"?>
+<p:sld xmlns:a="http://schemas.openxmlformats.org/drawingml/2006/main" xmlns:r="http://schemas.openxmlformats.org/officeDocument/2006/relationships" xmlns:p="http://schemas.openxmlformats.org/presentationml/2006/main">
+  <p:cSld name="Slide 15">
+    <p:bg>
+      <p:bgPr>
+        <a:solidFill>
+          <a:srgbClr val="0F1729"/>
+        </a:solidFill>
+        <a:effectLst/>
+      </p:bgPr>
+    </p:bg>
+    <p:spTree>
+      <p:nvGrpSpPr>
+        <p:cNvPr id="1" name=""/>
+        <p:cNvGrpSpPr/>
+        <p:nvPr/>
+      </p:nvGrpSpPr>
+      <p:grpSpPr>
+        <a:xfrm>
+          <a:off x="0" y="0"/>
+          <a:ext cx="0" cy="0"/>
+          <a:chOff x="0" y="0"/>
+          <a:chExt cx="0" cy="0"/>
+        </a:xfrm>
+      </p:grpSpPr>
+      <p:sp>
+        <p:nvSpPr>
+          <p:cNvPr id="2" name="Text 0"/>
+          <p:cNvSpPr/>
+          <p:nvPr/>
+        </p:nvSpPr>
+        <p:spPr>
+          <a:xfrm>
+            <a:off x="457200" y="4796028"/>
+            <a:ext cx="4572000" cy="274320"/>
+          </a:xfrm>
+          <a:prstGeom prst="rect">
+            <a:avLst/>
+          </a:prstGeom>
+          <a:noFill/>
+          <a:ln/>
+        </p:spPr>
+        <p:txBody>
+          <a:bodyPr wrap="square" lIns="0" tIns="0" rIns="0" bIns="0" rtlCol="0" anchor="ctr"/>
+          <a:lstStyle/>
+          <a:p>
+            <a:pPr marL="0" indent="0">
+              <a:buNone/>
+            </a:pPr>
+            <a:r>
+              <a:rPr lang="en-US" sz="800" kern="0" spc="200" dirty="0">
+                <a:solidFill>
+                  <a:srgbClr val="64748B"/>
+                </a:solidFill>
+                <a:latin typeface="Inter" pitchFamily="34" charset="0"/>
+                <a:ea typeface="Inter" pitchFamily="34" charset="-122"/>
+                <a:cs typeface="Inter" pitchFamily="34" charset="-120"/>
+              </a:rPr>
+              <a:t>03 · demo · moment 1</a:t>
+            </a:r>
+            <a:endParaRPr lang="en-US" sz="800" dirty="0"/>
+          </a:p>
+        </p:txBody>
+      </p:sp>
+      <p:sp>
+        <p:nvSpPr>
+          <p:cNvPr id="3" name="Text 1"/>
+          <p:cNvSpPr/>
+          <p:nvPr/>
+        </p:nvSpPr>
+        <p:spPr>
+          <a:xfrm>
+            <a:off x="8229600" y="4796028"/>
+            <a:ext cx="457200" cy="274320"/>
+          </a:xfrm>
+          <a:prstGeom prst="rect">
+            <a:avLst/>
+          </a:prstGeom>
+          <a:noFill/>
+          <a:ln/>
+        </p:spPr>
+        <p:txBody>
+          <a:bodyPr wrap="square" lIns="0" tIns="0" rIns="0" bIns="0" rtlCol="0" anchor="ctr"/>
+          <a:lstStyle/>
+          <a:p>
+            <a:pPr marL="0" indent="0" algn="r">
+              <a:buNone/>
+            </a:pPr>
+            <a:r>
+              <a:rPr lang="en-US" sz="800" dirty="0">
+                <a:solidFill>
+                  <a:srgbClr val="64748B"/>
+                </a:solidFill>
+                <a:latin typeface="Inter" pitchFamily="34" charset="0"/>
+                <a:ea typeface="Inter" pitchFamily="34" charset="-122"/>
+                <a:cs typeface="Inter" pitchFamily="34" charset="-120"/>
+              </a:rPr>
+              <a:t>15</a:t>
+            </a:r>
+            <a:endParaRPr lang="en-US" sz="800" dirty="0"/>
+          </a:p>
+        </p:txBody>
+      </p:sp>
+      <p:sp>
+        <p:nvSpPr>
+          <p:cNvPr id="4" name="Text 2"/>
+          <p:cNvSpPr/>
+          <p:nvPr/>
+        </p:nvSpPr>
+        <p:spPr>
+          <a:xfrm>
+            <a:off x="457200" y="384048"/>
+            <a:ext cx="8229600" cy="274320"/>
+          </a:xfrm>
+          <a:prstGeom prst="rect">
+            <a:avLst/>
+          </a:prstGeom>
+          <a:noFill/>
+          <a:ln/>
+        </p:spPr>
+        <p:txBody>
+          <a:bodyPr wrap="square" lIns="0" tIns="0" rIns="0" bIns="0" rtlCol="0" anchor="ctr"/>
+          <a:lstStyle/>
+          <a:p>
+            <a:pPr marL="0" indent="0">
+              <a:buNone/>
+            </a:pPr>
+            <a:r>
+              <a:rPr lang="en-US" sz="1000" b="1" kern="0" spc="300" dirty="0">
+                <a:solidFill>
+                  <a:srgbClr val="FBBF24"/>
+                </a:solidFill>
+                <a:latin typeface="Inter" pitchFamily="34" charset="0"/>
+                <a:ea typeface="Inter" pitchFamily="34" charset="-122"/>
+                <a:cs typeface="Inter" pitchFamily="34" charset="-120"/>
+              </a:rPr>
+              <a:t>MOMENT 1 OF 3</a:t>
+            </a:r>
+            <a:endParaRPr lang="en-US" sz="1000" dirty="0"/>
+          </a:p>
+        </p:txBody>
+      </p:sp>
+      <p:sp>
+        <p:nvSpPr>
+          <p:cNvPr id="5" name="Text 3"/>
+          <p:cNvSpPr/>
+          <p:nvPr/>
+        </p:nvSpPr>
+        <p:spPr>
+          <a:xfrm>
+            <a:off x="457200" y="1371600"/>
+            <a:ext cx="8229600" cy="731520"/>
+          </a:xfrm>
+          <a:prstGeom prst="rect">
+            <a:avLst/>
+          </a:prstGeom>
+          <a:noFill/>
+          <a:ln/>
+        </p:spPr>
+        <p:txBody>
+          <a:bodyPr wrap="square" lIns="0" tIns="0" rIns="0" bIns="0" rtlCol="0" anchor="ctr"/>
+          <a:lstStyle/>
+          <a:p>
+            <a:pPr marL="0" indent="0">
+              <a:buNone/>
+            </a:pPr>
+            <a:r>
+              <a:rPr lang="en-US" sz="3600" b="1" dirty="0">
+                <a:solidFill>
+                  <a:srgbClr val="F8FAFC"/>
+                </a:solidFill>
+                <a:latin typeface="Montserrat" pitchFamily="34" charset="0"/>
+                <a:ea typeface="Inter" pitchFamily="34" charset="-122"/>
+                <a:cs typeface="Inter" pitchFamily="34" charset="-120"/>
+              </a:rPr>
+              <a:t>watch the team assemble</a:t>
+            </a:r>
+            <a:endParaRPr lang="en-US" sz="3600" dirty="0"/>
+          </a:p>
+        </p:txBody>
+      </p:sp>
+      <p:sp>
+        <p:nvSpPr>
+          <p:cNvPr id="6" name="Shape 4"/>
+          <p:cNvSpPr/>
+          <p:nvPr/>
+        </p:nvSpPr>
+        <p:spPr>
+          <a:xfrm>
+            <a:off x="457200" y="2331720"/>
+            <a:ext cx="8229600" cy="777240"/>
+          </a:xfrm>
+          <a:prstGeom prst="roundRect">
+            <a:avLst>
+              <a:gd name="adj" fmla="val 7059"/>
+            </a:avLst>
+          </a:prstGeom>
+          <a:solidFill>
+            <a:srgbClr val="0A101F"/>
+          </a:solidFill>
+          <a:ln/>
+        </p:spPr>
+        <p:txBody>
+          <a:bodyPr/>
+          <a:lstStyle/>
+          <a:p>
+            <a:endParaRPr/>
+          </a:p>
+        </p:txBody>
+      </p:sp>
+      <p:sp>
+        <p:nvSpPr>
+          <p:cNvPr id="7" name="Text 5"/>
+          <p:cNvSpPr/>
+          <p:nvPr/>
+        </p:nvSpPr>
+        <p:spPr>
+          <a:xfrm>
+            <a:off x="640080" y="2331720"/>
+            <a:ext cx="7863840" cy="777240"/>
+          </a:xfrm>
+          <a:prstGeom prst="rect">
+            <a:avLst/>
+          </a:prstGeom>
+          <a:noFill/>
+          <a:ln/>
+        </p:spPr>
+        <p:txBody>
+          <a:bodyPr wrap="square" lIns="0" tIns="0" rIns="0" bIns="0" rtlCol="0" anchor="ctr"/>
+          <a:lstStyle/>
+          <a:p>
+            <a:pPr marL="0" indent="0">
+              <a:buNone/>
+            </a:pPr>
+            <a:r>
+              <a:rPr lang="en-US" sz="1200" dirty="0">
+                <a:solidFill>
+                  <a:srgbClr val="34D399"/>
+                </a:solidFill>
+                <a:latin typeface="Menlo" pitchFamily="34" charset="0"/>
+                <a:ea typeface="Menlo" pitchFamily="34" charset="-122"/>
+                <a:cs typeface="Menlo" pitchFamily="34" charset="-120"/>
+              </a:rPr>
+              <a:t>$ /implement  auto-promote the next waitlisted guest when a confirmed guest cancels</a:t>
+            </a:r>
+            <a:endParaRPr lang="en-US" sz="1200" dirty="0"/>
+          </a:p>
+          <a:p>
+            <a:pPr marL="0" indent="0">
+              <a:buNone/>
+            </a:pPr>
+            <a:r>
+              <a:rPr lang="en-US" sz="1000" dirty="0">
+                <a:solidFill>
+                  <a:srgbClr val="94A3B8"/>
+                </a:solidFill>
+                <a:latin typeface="Menlo" pitchFamily="34" charset="0"/>
+                <a:ea typeface="Menlo" pitchFamily="34" charset="-122"/>
+                <a:cs typeface="Menlo" pitchFamily="34" charset="-120"/>
+              </a:rPr>
+              <a:t>→ the team: code-reviewer · security-auditor · test-writer  (in parallel)</a:t>
+            </a:r>
+            <a:endParaRPr lang="en-US" sz="1000" dirty="0"/>
+          </a:p>
+        </p:txBody>
+      </p:sp>
+    </p:spTree>
+  </p:cSld>
+  <p:clrMapOvr>
+    <a:masterClrMapping/>
+  </p:clrMapOvr>
+</p:sld>
 </file>
 
 <file path=ppt/slides/slide16.xml><?xml version="1.0" encoding="utf-8"?>

</xml_diff>

<commit_message>
fix(deck): repair malformed slide 15 XML (PowerPoint repair prompt) (#41)
The demo-moments edit (#37) added the "→ the team: …" line to slide 15 but
dropped the run's closing </a:r>, leaving mismatched tags. The zip stayed valid
so it passed checks, but PowerPoint's schema validator rejected it ("detected a
problem… Repair"). Adds the missing </a:r>; all 114 parts now parse. Redesign
content unchanged.

Co-authored-by: dev-servicecat <dev@servicecat.local>
Co-authored-by: Claude Opus 4.8 (1M context) <noreply@anthropic.com>
</commit_message>
<xml_diff>
--- a/orchestrer-intelligence-gatherly.pptx
+++ b/orchestrer-intelligence-gatherly.pptx
@@ -6812,8 +6812,278 @@
 </p:sld>
 </file>
 
-<file path=ppt/slides/slide15.xml><?xml version="1.0" encoding="UTF-8" standalone="yes"?>
-<p:sld xmlns:a="http://schemas.openxmlformats.org/drawingml/2006/main" xmlns:r="http://schemas.openxmlformats.org/officeDocument/2006/relationships" xmlns:p="http://schemas.openxmlformats.org/presentationml/2006/main"><p:cSld name="Slide 15"><p:bg><p:bgPr><a:solidFill><a:srgbClr val="0F1729"/></a:solidFill><a:effectLst/></p:bgPr></p:bg><p:spTree><p:nvGrpSpPr><p:cNvPr id="1" name=""/><p:cNvGrpSpPr/><p:nvPr/></p:nvGrpSpPr><p:grpSpPr><a:xfrm><a:off x="0" y="0"/><a:ext cx="0" cy="0"/><a:chOff x="0" y="0"/><a:chExt cx="0" cy="0"/></a:xfrm></p:grpSpPr><p:sp><p:nvSpPr><p:cNvPr id="2" name="Text 0"/><p:cNvSpPr/><p:nvPr/></p:nvSpPr><p:spPr><a:xfrm><a:off x="457200" y="4796028"/><a:ext cx="4572000" cy="274320"/></a:xfrm><a:prstGeom prst="rect"><a:avLst/></a:prstGeom><a:noFill/><a:ln/></p:spPr><p:txBody><a:bodyPr wrap="square" lIns="0" tIns="0" rIns="0" bIns="0" rtlCol="0" anchor="ctr"/><a:lstStyle/><a:p><a:pPr marL="0" indent="0"><a:buNone/></a:pPr><a:r><a:rPr lang="en-US" sz="800" kern="0" spc="200" dirty="0"><a:solidFill><a:srgbClr val="64748B"/></a:solidFill><a:latin typeface="Inter" pitchFamily="34" charset="0"/><a:ea typeface="Inter" pitchFamily="34" charset="-122"/><a:cs typeface="Inter" pitchFamily="34" charset="-120"/></a:rPr><a:t>03 · demo · moment 1</a:t></a:r><a:endParaRPr lang="en-US" sz="800" dirty="0"/></a:p></p:txBody></p:sp><p:sp><p:nvSpPr><p:cNvPr id="3" name="Text 1"/><p:cNvSpPr/><p:nvPr/></p:nvSpPr><p:spPr><a:xfrm><a:off x="8229600" y="4796028"/><a:ext cx="457200" cy="274320"/></a:xfrm><a:prstGeom prst="rect"><a:avLst/></a:prstGeom><a:noFill/><a:ln/></p:spPr><p:txBody><a:bodyPr wrap="square" lIns="0" tIns="0" rIns="0" bIns="0" rtlCol="0" anchor="ctr"/><a:lstStyle/><a:p><a:pPr marL="0" indent="0" algn="r"><a:buNone/></a:pPr><a:r><a:rPr lang="en-US" sz="800" dirty="0"><a:solidFill><a:srgbClr val="64748B"/></a:solidFill><a:latin typeface="Inter" pitchFamily="34" charset="0"/><a:ea typeface="Inter" pitchFamily="34" charset="-122"/><a:cs typeface="Inter" pitchFamily="34" charset="-120"/></a:rPr><a:t>15</a:t></a:r><a:endParaRPr lang="en-US" sz="800" dirty="0"/></a:p></p:txBody></p:sp><p:sp><p:nvSpPr><p:cNvPr id="4" name="Text 2"/><p:cNvSpPr/><p:nvPr/></p:nvSpPr><p:spPr><a:xfrm><a:off x="457200" y="384048"/><a:ext cx="8229600" cy="274320"/></a:xfrm><a:prstGeom prst="rect"><a:avLst/></a:prstGeom><a:noFill/><a:ln/></p:spPr><p:txBody><a:bodyPr wrap="square" lIns="0" tIns="0" rIns="0" bIns="0" rtlCol="0" anchor="ctr"/><a:lstStyle/><a:p><a:pPr marL="0" indent="0"><a:buNone/></a:pPr><a:r><a:rPr lang="en-US" sz="1000" b="1" kern="0" spc="300" dirty="0"><a:solidFill><a:srgbClr val="FBBF24"/></a:solidFill><a:latin typeface="Inter" pitchFamily="34" charset="0"/><a:ea typeface="Inter" pitchFamily="34" charset="-122"/><a:cs typeface="Inter" pitchFamily="34" charset="-120"/></a:rPr><a:t>MOMENT 1 OF 3</a:t></a:r><a:endParaRPr lang="en-US" sz="1000" dirty="0"/></a:p></p:txBody></p:sp><p:sp><p:nvSpPr><p:cNvPr id="5" name="Text 3"/><p:cNvSpPr/><p:nvPr/></p:nvSpPr><p:spPr><a:xfrm><a:off x="457200" y="1371600"/><a:ext cx="8229600" cy="731520"/></a:xfrm><a:prstGeom prst="rect"><a:avLst/></a:prstGeom><a:noFill/><a:ln/></p:spPr><p:txBody><a:bodyPr wrap="square" lIns="0" tIns="0" rIns="0" bIns="0" rtlCol="0" anchor="ctr"/><a:lstStyle/><a:p><a:pPr marL="0" indent="0"><a:buNone/></a:pPr><a:r><a:rPr lang="en-US" sz="3600" b="1" dirty="0"><a:solidFill><a:srgbClr val="F8FAFC"/></a:solidFill><a:latin typeface="Montserrat" pitchFamily="34" charset="0"/><a:ea typeface="Inter" pitchFamily="34" charset="-122"/><a:cs typeface="Inter" pitchFamily="34" charset="-120"/></a:rPr><a:t>watch the team assemble</a:t></a:r><a:endParaRPr lang="en-US" sz="3600" dirty="0"/></a:p></p:txBody></p:sp><p:sp><p:nvSpPr><p:cNvPr id="6" name="Shape 4"/><p:cNvSpPr/><p:nvPr/></p:nvSpPr><p:spPr><a:xfrm><a:off x="457200" y="2331720"/><a:ext cx="8229600" cy="777240"/></a:xfrm><a:prstGeom prst="roundRect"><a:avLst><a:gd name="adj" fmla="val 7059"/></a:avLst></a:prstGeom><a:solidFill><a:srgbClr val="0A101F"/></a:solidFill><a:ln/></p:spPr><p:txBody><a:bodyPr/><a:lstStyle/><a:p><a:endParaRPr/></a:p></p:txBody></p:sp><p:sp><p:nvSpPr><p:cNvPr id="7" name="Text 5"/><p:cNvSpPr/><p:nvPr/></p:nvSpPr><p:spPr><a:xfrm><a:off x="640080" y="2331720"/><a:ext cx="7863840" cy="777240"/></a:xfrm><a:prstGeom prst="rect"><a:avLst/></a:prstGeom><a:noFill/><a:ln/></p:spPr><p:txBody><a:bodyPr wrap="square" lIns="0" tIns="0" rIns="0" bIns="0" rtlCol="0" anchor="ctr"/><a:lstStyle/><a:p><a:pPr marL="0" indent="0"><a:buNone/></a:pPr><a:r><a:rPr lang="en-US" sz="1200" dirty="0"><a:solidFill><a:srgbClr val="34D399"/></a:solidFill><a:latin typeface="Menlo" pitchFamily="34" charset="0"/><a:ea typeface="Menlo" pitchFamily="34" charset="-122"/><a:cs typeface="Menlo" pitchFamily="34" charset="-120"/></a:rPr><a:t>$ /implement  auto-promote the next waitlisted guest when a confirmed guest cancels</a:t></a:r><a:endParaRPr lang="en-US" sz="1200" dirty="0"/></a:p><a:p><a:pPr marL="0" indent="0"><a:buNone/></a:pPr><a:r><a:rPr lang="en-US" sz="1000" dirty="0"><a:solidFill><a:srgbClr val="94A3B8"/></a:solidFill><a:latin typeface="Menlo" pitchFamily="34" charset="0"/><a:ea typeface="Menlo" pitchFamily="34" charset="-122"/><a:cs typeface="Menlo" pitchFamily="34" charset="-120"/></a:rPr><a:t>→ the team: code-reviewer · security-auditor · test-writer  (in parallel)</a:t><a:endParaRPr lang="en-US" sz="1000" dirty="0"/></a:p></p:txBody></p:sp></p:spTree></p:cSld><p:clrMapOvr><a:masterClrMapping/></p:clrMapOvr></p:sld>
+<file path=ppt/slides/slide15.xml><?xml version="1.0" encoding="utf-8"?>
+<p:sld xmlns:a="http://schemas.openxmlformats.org/drawingml/2006/main" xmlns:r="http://schemas.openxmlformats.org/officeDocument/2006/relationships" xmlns:p="http://schemas.openxmlformats.org/presentationml/2006/main">
+  <p:cSld name="Slide 15">
+    <p:bg>
+      <p:bgPr>
+        <a:solidFill>
+          <a:srgbClr val="0F1729"/>
+        </a:solidFill>
+        <a:effectLst/>
+      </p:bgPr>
+    </p:bg>
+    <p:spTree>
+      <p:nvGrpSpPr>
+        <p:cNvPr id="1" name=""/>
+        <p:cNvGrpSpPr/>
+        <p:nvPr/>
+      </p:nvGrpSpPr>
+      <p:grpSpPr>
+        <a:xfrm>
+          <a:off x="0" y="0"/>
+          <a:ext cx="0" cy="0"/>
+          <a:chOff x="0" y="0"/>
+          <a:chExt cx="0" cy="0"/>
+        </a:xfrm>
+      </p:grpSpPr>
+      <p:sp>
+        <p:nvSpPr>
+          <p:cNvPr id="2" name="Text 0"/>
+          <p:cNvSpPr/>
+          <p:nvPr/>
+        </p:nvSpPr>
+        <p:spPr>
+          <a:xfrm>
+            <a:off x="457200" y="4796028"/>
+            <a:ext cx="4572000" cy="274320"/>
+          </a:xfrm>
+          <a:prstGeom prst="rect">
+            <a:avLst/>
+          </a:prstGeom>
+          <a:noFill/>
+          <a:ln/>
+        </p:spPr>
+        <p:txBody>
+          <a:bodyPr wrap="square" lIns="0" tIns="0" rIns="0" bIns="0" rtlCol="0" anchor="ctr"/>
+          <a:lstStyle/>
+          <a:p>
+            <a:pPr marL="0" indent="0">
+              <a:buNone/>
+            </a:pPr>
+            <a:r>
+              <a:rPr lang="en-US" sz="800" kern="0" spc="200" dirty="0">
+                <a:solidFill>
+                  <a:srgbClr val="64748B"/>
+                </a:solidFill>
+                <a:latin typeface="Inter" pitchFamily="34" charset="0"/>
+                <a:ea typeface="Inter" pitchFamily="34" charset="-122"/>
+                <a:cs typeface="Inter" pitchFamily="34" charset="-120"/>
+              </a:rPr>
+              <a:t>03 · demo · moment 1</a:t>
+            </a:r>
+            <a:endParaRPr lang="en-US" sz="800" dirty="0"/>
+          </a:p>
+        </p:txBody>
+      </p:sp>
+      <p:sp>
+        <p:nvSpPr>
+          <p:cNvPr id="3" name="Text 1"/>
+          <p:cNvSpPr/>
+          <p:nvPr/>
+        </p:nvSpPr>
+        <p:spPr>
+          <a:xfrm>
+            <a:off x="8229600" y="4796028"/>
+            <a:ext cx="457200" cy="274320"/>
+          </a:xfrm>
+          <a:prstGeom prst="rect">
+            <a:avLst/>
+          </a:prstGeom>
+          <a:noFill/>
+          <a:ln/>
+        </p:spPr>
+        <p:txBody>
+          <a:bodyPr wrap="square" lIns="0" tIns="0" rIns="0" bIns="0" rtlCol="0" anchor="ctr"/>
+          <a:lstStyle/>
+          <a:p>
+            <a:pPr marL="0" indent="0" algn="r">
+              <a:buNone/>
+            </a:pPr>
+            <a:r>
+              <a:rPr lang="en-US" sz="800" dirty="0">
+                <a:solidFill>
+                  <a:srgbClr val="64748B"/>
+                </a:solidFill>
+                <a:latin typeface="Inter" pitchFamily="34" charset="0"/>
+                <a:ea typeface="Inter" pitchFamily="34" charset="-122"/>
+                <a:cs typeface="Inter" pitchFamily="34" charset="-120"/>
+              </a:rPr>
+              <a:t>15</a:t>
+            </a:r>
+            <a:endParaRPr lang="en-US" sz="800" dirty="0"/>
+          </a:p>
+        </p:txBody>
+      </p:sp>
+      <p:sp>
+        <p:nvSpPr>
+          <p:cNvPr id="4" name="Text 2"/>
+          <p:cNvSpPr/>
+          <p:nvPr/>
+        </p:nvSpPr>
+        <p:spPr>
+          <a:xfrm>
+            <a:off x="457200" y="384048"/>
+            <a:ext cx="8229600" cy="274320"/>
+          </a:xfrm>
+          <a:prstGeom prst="rect">
+            <a:avLst/>
+          </a:prstGeom>
+          <a:noFill/>
+          <a:ln/>
+        </p:spPr>
+        <p:txBody>
+          <a:bodyPr wrap="square" lIns="0" tIns="0" rIns="0" bIns="0" rtlCol="0" anchor="ctr"/>
+          <a:lstStyle/>
+          <a:p>
+            <a:pPr marL="0" indent="0">
+              <a:buNone/>
+            </a:pPr>
+            <a:r>
+              <a:rPr lang="en-US" sz="1000" b="1" kern="0" spc="300" dirty="0">
+                <a:solidFill>
+                  <a:srgbClr val="FBBF24"/>
+                </a:solidFill>
+                <a:latin typeface="Inter" pitchFamily="34" charset="0"/>
+                <a:ea typeface="Inter" pitchFamily="34" charset="-122"/>
+                <a:cs typeface="Inter" pitchFamily="34" charset="-120"/>
+              </a:rPr>
+              <a:t>MOMENT 1 OF 3</a:t>
+            </a:r>
+            <a:endParaRPr lang="en-US" sz="1000" dirty="0"/>
+          </a:p>
+        </p:txBody>
+      </p:sp>
+      <p:sp>
+        <p:nvSpPr>
+          <p:cNvPr id="5" name="Text 3"/>
+          <p:cNvSpPr/>
+          <p:nvPr/>
+        </p:nvSpPr>
+        <p:spPr>
+          <a:xfrm>
+            <a:off x="457200" y="1371600"/>
+            <a:ext cx="8229600" cy="731520"/>
+          </a:xfrm>
+          <a:prstGeom prst="rect">
+            <a:avLst/>
+          </a:prstGeom>
+          <a:noFill/>
+          <a:ln/>
+        </p:spPr>
+        <p:txBody>
+          <a:bodyPr wrap="square" lIns="0" tIns="0" rIns="0" bIns="0" rtlCol="0" anchor="ctr"/>
+          <a:lstStyle/>
+          <a:p>
+            <a:pPr marL="0" indent="0">
+              <a:buNone/>
+            </a:pPr>
+            <a:r>
+              <a:rPr lang="en-US" sz="3600" b="1" dirty="0">
+                <a:solidFill>
+                  <a:srgbClr val="F8FAFC"/>
+                </a:solidFill>
+                <a:latin typeface="Montserrat" pitchFamily="34" charset="0"/>
+                <a:ea typeface="Inter" pitchFamily="34" charset="-122"/>
+                <a:cs typeface="Inter" pitchFamily="34" charset="-120"/>
+              </a:rPr>
+              <a:t>watch the team assemble</a:t>
+            </a:r>
+            <a:endParaRPr lang="en-US" sz="3600" dirty="0"/>
+          </a:p>
+        </p:txBody>
+      </p:sp>
+      <p:sp>
+        <p:nvSpPr>
+          <p:cNvPr id="6" name="Shape 4"/>
+          <p:cNvSpPr/>
+          <p:nvPr/>
+        </p:nvSpPr>
+        <p:spPr>
+          <a:xfrm>
+            <a:off x="457200" y="2331720"/>
+            <a:ext cx="8229600" cy="777240"/>
+          </a:xfrm>
+          <a:prstGeom prst="roundRect">
+            <a:avLst>
+              <a:gd name="adj" fmla="val 7059"/>
+            </a:avLst>
+          </a:prstGeom>
+          <a:solidFill>
+            <a:srgbClr val="0A101F"/>
+          </a:solidFill>
+          <a:ln/>
+        </p:spPr>
+        <p:txBody>
+          <a:bodyPr/>
+          <a:lstStyle/>
+          <a:p>
+            <a:endParaRPr/>
+          </a:p>
+        </p:txBody>
+      </p:sp>
+      <p:sp>
+        <p:nvSpPr>
+          <p:cNvPr id="7" name="Text 5"/>
+          <p:cNvSpPr/>
+          <p:nvPr/>
+        </p:nvSpPr>
+        <p:spPr>
+          <a:xfrm>
+            <a:off x="640080" y="2331720"/>
+            <a:ext cx="7863840" cy="777240"/>
+          </a:xfrm>
+          <a:prstGeom prst="rect">
+            <a:avLst/>
+          </a:prstGeom>
+          <a:noFill/>
+          <a:ln/>
+        </p:spPr>
+        <p:txBody>
+          <a:bodyPr wrap="square" lIns="0" tIns="0" rIns="0" bIns="0" rtlCol="0" anchor="ctr"/>
+          <a:lstStyle/>
+          <a:p>
+            <a:pPr marL="0" indent="0">
+              <a:buNone/>
+            </a:pPr>
+            <a:r>
+              <a:rPr lang="en-US" sz="1200" dirty="0">
+                <a:solidFill>
+                  <a:srgbClr val="34D399"/>
+                </a:solidFill>
+                <a:latin typeface="Menlo" pitchFamily="34" charset="0"/>
+                <a:ea typeface="Menlo" pitchFamily="34" charset="-122"/>
+                <a:cs typeface="Menlo" pitchFamily="34" charset="-120"/>
+              </a:rPr>
+              <a:t>$ /implement  auto-promote the next waitlisted guest when a confirmed guest cancels</a:t>
+            </a:r>
+            <a:endParaRPr lang="en-US" sz="1200" dirty="0"/>
+          </a:p>
+          <a:p>
+            <a:pPr marL="0" indent="0">
+              <a:buNone/>
+            </a:pPr>
+            <a:r>
+              <a:rPr lang="en-US" sz="1000" dirty="0">
+                <a:solidFill>
+                  <a:srgbClr val="94A3B8"/>
+                </a:solidFill>
+                <a:latin typeface="Menlo" pitchFamily="34" charset="0"/>
+                <a:ea typeface="Menlo" pitchFamily="34" charset="-122"/>
+                <a:cs typeface="Menlo" pitchFamily="34" charset="-120"/>
+              </a:rPr>
+              <a:t>→ the team: code-reviewer · security-auditor · test-writer  (in parallel)</a:t>
+            </a:r>
+            <a:endParaRPr lang="en-US" sz="1000" dirty="0"/>
+          </a:p>
+        </p:txBody>
+      </p:sp>
+    </p:spTree>
+  </p:cSld>
+  <p:clrMapOvr>
+    <a:masterClrMapping/>
+  </p:clrMapOvr>
+</p:sld>
 </file>
 
 <file path=ppt/slides/slide16.xml><?xml version="1.0" encoding="utf-8"?>

</xml_diff>

<commit_message>
chore(deck): rebuild gatherly slide 11 as the full REPL loop
Replace the single-row "the loop" flow on page 11 with the full
WORKFLOW.md REPL loop: Phase 0 plan, the per-step inner loop (with the
test-retry note), the acceptance gate, and the ship sequence ending in
mandatory human review. Keeps the deck's theme, fonts, header, footer.

Co-Authored-By: Claude Opus 4.8 (1M context) <noreply@anthropic.com>
</commit_message>
<xml_diff>
--- a/orchestrer-intelligence-gatherly.pptx
+++ b/orchestrer-intelligence-gatherly.pptx
@@ -3584,85 +3584,7 @@
       </p:grpSpPr>
       <p:sp>
         <p:nvSpPr>
-          <p:cNvPr id="2" name="Text 0"/>
-          <p:cNvSpPr/>
-          <p:nvPr/>
-        </p:nvSpPr>
-        <p:spPr>
-          <a:xfrm>
-            <a:off x="457200" y="4796028"/>
-            <a:ext cx="4572000" cy="274320"/>
-          </a:xfrm>
-          <a:prstGeom prst="rect">
-            <a:avLst/>
-          </a:prstGeom>
-          <a:noFill/>
-          <a:ln/>
-        </p:spPr>
-        <p:txBody>
-          <a:bodyPr wrap="square" lIns="0" tIns="0" rIns="0" bIns="0" rtlCol="0" anchor="ctr"/>
-          <a:lstStyle/>
-          <a:p>
-            <a:pPr marL="0" indent="0">
-              <a:buNone/>
-            </a:pPr>
-            <a:r>
-              <a:rPr lang="en-US" sz="800" kern="0" spc="200" dirty="0">
-                <a:solidFill>
-                  <a:srgbClr val="64748B"/>
-                </a:solidFill>
-                <a:latin typeface="Inter" pitchFamily="34" charset="0"/>
-                <a:ea typeface="Inter" pitchFamily="34" charset="-122"/>
-                <a:cs typeface="Inter" pitchFamily="34" charset="-120"/>
-              </a:rPr>
-              <a:t>02 · how it works</a:t>
-            </a:r>
-            <a:endParaRPr lang="en-US" sz="800" dirty="0"/>
-          </a:p>
-        </p:txBody>
-      </p:sp>
-      <p:sp>
-        <p:nvSpPr>
-          <p:cNvPr id="3" name="Text 1"/>
-          <p:cNvSpPr/>
-          <p:nvPr/>
-        </p:nvSpPr>
-        <p:spPr>
-          <a:xfrm>
-            <a:off x="8229600" y="4796028"/>
-            <a:ext cx="457200" cy="274320"/>
-          </a:xfrm>
-          <a:prstGeom prst="rect">
-            <a:avLst/>
-          </a:prstGeom>
-          <a:noFill/>
-          <a:ln/>
-        </p:spPr>
-        <p:txBody>
-          <a:bodyPr wrap="square" lIns="0" tIns="0" rIns="0" bIns="0" rtlCol="0" anchor="ctr"/>
-          <a:lstStyle/>
-          <a:p>
-            <a:pPr marL="0" indent="0" algn="r">
-              <a:buNone/>
-            </a:pPr>
-            <a:r>
-              <a:rPr lang="en-US" sz="800" dirty="0">
-                <a:solidFill>
-                  <a:srgbClr val="64748B"/>
-                </a:solidFill>
-                <a:latin typeface="Inter" pitchFamily="34" charset="0"/>
-                <a:ea typeface="Inter" pitchFamily="34" charset="-122"/>
-                <a:cs typeface="Inter" pitchFamily="34" charset="-120"/>
-              </a:rPr>
-              <a:t>11</a:t>
-            </a:r>
-            <a:endParaRPr lang="en-US" sz="800" dirty="0"/>
-          </a:p>
-        </p:txBody>
-      </p:sp>
-      <p:sp>
-        <p:nvSpPr>
-          <p:cNvPr id="4" name="Text 2"/>
+          <p:cNvPr id="2" name="Text"/>
           <p:cNvSpPr/>
           <p:nvPr/>
         </p:nvSpPr>
@@ -3681,7 +3603,7 @@
           <a:bodyPr wrap="square" lIns="0" tIns="0" rIns="0" bIns="0" rtlCol="0" anchor="ctr"/>
           <a:lstStyle/>
           <a:p>
-            <a:pPr marL="0" indent="0">
+            <a:pPr marL="0" indent="0" algn="l">
               <a:buNone/>
             </a:pPr>
             <a:r>
@@ -3695,13 +3617,12 @@
               </a:rPr>
               <a:t>02 · HOW IT WORKS</a:t>
             </a:r>
-            <a:endParaRPr lang="en-US" sz="1000" dirty="0"/>
-          </a:p>
-        </p:txBody>
-      </p:sp>
-      <p:sp>
-        <p:nvSpPr>
-          <p:cNvPr id="5" name="Text 3"/>
+          </a:p>
+        </p:txBody>
+      </p:sp>
+      <p:sp>
+        <p:nvSpPr>
+          <p:cNvPr id="3" name="Text"/>
           <p:cNvSpPr/>
           <p:nvPr/>
         </p:nvSpPr>
@@ -3720,34 +3641,71 @@
           <a:bodyPr wrap="square" lIns="0" tIns="0" rIns="0" bIns="0" rtlCol="0" anchor="ctr"/>
           <a:lstStyle/>
           <a:p>
-            <a:pPr marL="0" indent="0">
-              <a:buNone/>
-            </a:pPr>
-            <a:r>
-              <a:rPr lang="en-US" sz="2800" b="1" dirty="0">
+            <a:pPr marL="0" indent="0" algn="l">
+              <a:buNone/>
+            </a:pPr>
+            <a:r>
+              <a:rPr lang="en-US" sz="2800" b="1" kern="0" dirty="0">
                 <a:solidFill>
                   <a:srgbClr val="F8FAFC"/>
                 </a:solidFill>
                 <a:latin typeface="Montserrat" pitchFamily="34" charset="0"/>
-                <a:ea typeface="Inter" pitchFamily="34" charset="-122"/>
-                <a:cs typeface="Inter" pitchFamily="34" charset="-120"/>
+                <a:ea typeface="Montserrat" pitchFamily="34" charset="-122"/>
+                <a:cs typeface="Montserrat" pitchFamily="34" charset="-120"/>
               </a:rPr>
               <a:t>the loop</a:t>
             </a:r>
-            <a:endParaRPr lang="en-US" sz="2800" dirty="0"/>
-          </a:p>
-        </p:txBody>
-      </p:sp>
-      <p:sp>
-        <p:nvSpPr>
-          <p:cNvPr id="6" name="Shape 4"/>
-          <p:cNvSpPr/>
-          <p:nvPr/>
-        </p:nvSpPr>
-        <p:spPr>
-          <a:xfrm>
-            <a:off x="457200" y="2103120"/>
-            <a:ext cx="932688" cy="502920"/>
+          </a:p>
+        </p:txBody>
+      </p:sp>
+      <p:sp>
+        <p:nvSpPr>
+          <p:cNvPr id="4" name="Text"/>
+          <p:cNvSpPr/>
+          <p:nvPr/>
+        </p:nvSpPr>
+        <p:spPr>
+          <a:xfrm>
+            <a:off x="457200" y="1420000"/>
+            <a:ext cx="8229600" cy="180000"/>
+          </a:xfrm>
+          <a:prstGeom prst="rect">
+            <a:avLst/>
+          </a:prstGeom>
+          <a:noFill/>
+          <a:ln/>
+        </p:spPr>
+        <p:txBody>
+          <a:bodyPr wrap="square" lIns="0" tIns="0" rIns="0" bIns="0" rtlCol="0" anchor="ctr"/>
+          <a:lstStyle/>
+          <a:p>
+            <a:pPr marL="0" indent="0" algn="l">
+              <a:buNone/>
+            </a:pPr>
+            <a:r>
+              <a:rPr lang="en-US" sz="900" b="1" kern="0" spc="200" dirty="0">
+                <a:solidFill>
+                  <a:srgbClr val="3B82F6"/>
+                </a:solidFill>
+                <a:latin typeface="Inter" pitchFamily="34" charset="0"/>
+                <a:ea typeface="Inter" pitchFamily="34" charset="-122"/>
+                <a:cs typeface="Inter" pitchFamily="34" charset="-120"/>
+              </a:rPr>
+              <a:t>PHASE 0 · BEFORE ANY CODE</a:t>
+            </a:r>
+          </a:p>
+        </p:txBody>
+      </p:sp>
+      <p:sp>
+        <p:nvSpPr>
+          <p:cNvPr id="5" name="Pill"/>
+          <p:cNvSpPr/>
+          <p:nvPr/>
+        </p:nvSpPr>
+        <p:spPr>
+          <a:xfrm>
+            <a:off x="457200" y="1620000"/>
+            <a:ext cx="1234440" cy="560000"/>
           </a:xfrm>
           <a:prstGeom prst="roundRect">
             <a:avLst>
@@ -3765,39 +3723,14 @@
           </a:ln>
         </p:spPr>
         <p:txBody>
-          <a:bodyPr/>
-          <a:lstStyle/>
-          <a:p>
-            <a:endParaRPr/>
-          </a:p>
-        </p:txBody>
-      </p:sp>
-      <p:sp>
-        <p:nvSpPr>
-          <p:cNvPr id="7" name="Text 5"/>
-          <p:cNvSpPr/>
-          <p:nvPr/>
-        </p:nvSpPr>
-        <p:spPr>
-          <a:xfrm>
-            <a:off x="457200" y="2103120"/>
-            <a:ext cx="932688" cy="502920"/>
-          </a:xfrm>
-          <a:prstGeom prst="rect">
-            <a:avLst/>
-          </a:prstGeom>
-          <a:noFill/>
-          <a:ln/>
-        </p:spPr>
-        <p:txBody>
-          <a:bodyPr wrap="square" lIns="0" tIns="0" rIns="0" bIns="0" rtlCol="0" anchor="ctr"/>
+          <a:bodyPr wrap="square" lIns="36000" tIns="0" rIns="36000" bIns="0" rtlCol="0" anchor="ctr"/>
           <a:lstStyle/>
           <a:p>
             <a:pPr marL="0" indent="0" algn="ctr">
               <a:buNone/>
             </a:pPr>
             <a:r>
-              <a:rPr lang="en-US" sz="1100" b="1" dirty="0">
+              <a:rPr lang="en-US" sz="1050" b="1" kern="0" dirty="0">
                 <a:solidFill>
                   <a:srgbClr val="F8FAFC"/>
                 </a:solidFill>
@@ -3807,36 +3740,13 @@
               </a:rPr>
               <a:t>plan</a:t>
             </a:r>
-            <a:endParaRPr lang="en-US" sz="1100" dirty="0"/>
-          </a:p>
-        </p:txBody>
-      </p:sp>
-      <p:sp>
-        <p:nvSpPr>
-          <p:cNvPr id="8" name="Text 6"/>
-          <p:cNvSpPr/>
-          <p:nvPr/>
-        </p:nvSpPr>
-        <p:spPr>
-          <a:xfrm>
-            <a:off x="1371600" y="2103120"/>
-            <a:ext cx="164592" cy="502920"/>
-          </a:xfrm>
-          <a:prstGeom prst="rect">
-            <a:avLst/>
-          </a:prstGeom>
-          <a:noFill/>
-          <a:ln/>
-        </p:spPr>
-        <p:txBody>
-          <a:bodyPr wrap="square" lIns="0" tIns="0" rIns="0" bIns="0" rtlCol="0" anchor="ctr"/>
-          <a:lstStyle/>
+          </a:p>
           <a:p>
             <a:pPr marL="0" indent="0" algn="ctr">
               <a:buNone/>
             </a:pPr>
             <a:r>
-              <a:rPr lang="en-US" sz="1000" dirty="0">
+              <a:rPr lang="en-US" sz="750" kern="0" dirty="0">
                 <a:solidFill>
                   <a:srgbClr val="3B82F6"/>
                 </a:solidFill>
@@ -3844,22 +3754,135 @@
                 <a:ea typeface="Inter" pitchFamily="34" charset="-122"/>
                 <a:cs typeface="Inter" pitchFamily="34" charset="-120"/>
               </a:rPr>
-              <a:t>→</a:t>
-            </a:r>
-            <a:endParaRPr lang="en-US" sz="1000" dirty="0"/>
-          </a:p>
-        </p:txBody>
-      </p:sp>
-      <p:sp>
-        <p:nvSpPr>
-          <p:cNvPr id="9" name="Shape 7"/>
-          <p:cNvSpPr/>
-          <p:nvPr/>
-        </p:nvSpPr>
-        <p:spPr>
-          <a:xfrm>
-            <a:off x="1499616" y="2103120"/>
-            <a:ext cx="932688" cy="502920"/>
+              <a:t>/plan-feature</a:t>
+            </a:r>
+          </a:p>
+        </p:txBody>
+      </p:sp>
+      <p:sp>
+        <p:nvSpPr>
+          <p:cNvPr id="6" name="Text"/>
+          <p:cNvSpPr/>
+          <p:nvPr/>
+        </p:nvSpPr>
+        <p:spPr>
+          <a:xfrm>
+            <a:off x="1911640" y="1620000"/>
+            <a:ext cx="6775160" cy="560000"/>
+          </a:xfrm>
+          <a:prstGeom prst="rect">
+            <a:avLst/>
+          </a:prstGeom>
+          <a:noFill/>
+          <a:ln/>
+        </p:spPr>
+        <p:txBody>
+          <a:bodyPr wrap="square" lIns="0" tIns="0" rIns="0" bIns="0" rtlCol="0" anchor="ctr"/>
+          <a:lstStyle/>
+          <a:p>
+            <a:pPr marL="0" indent="0" algn="l">
+              <a:buNone/>
+            </a:pPr>
+            <a:r>
+              <a:rPr lang="en-US" sz="1200" kern="0" dirty="0">
+                <a:solidFill>
+                  <a:srgbClr val="94A3B8"/>
+                </a:solidFill>
+                <a:latin typeface="Inter" pitchFamily="34" charset="0"/>
+                <a:ea typeface="Inter" pitchFamily="34" charset="-122"/>
+                <a:cs typeface="Inter" pitchFamily="34" charset="-120"/>
+              </a:rPr>
+              <a:t>define AC-1 … AC-6 before writing any code</a:t>
+            </a:r>
+          </a:p>
+        </p:txBody>
+      </p:sp>
+      <p:sp>
+        <p:nvSpPr>
+          <p:cNvPr id="7" name="Text"/>
+          <p:cNvSpPr/>
+          <p:nvPr/>
+        </p:nvSpPr>
+        <p:spPr>
+          <a:xfrm>
+            <a:off x="4472000" y="2200000"/>
+            <a:ext cx="200000" cy="170000"/>
+          </a:xfrm>
+          <a:prstGeom prst="rect">
+            <a:avLst/>
+          </a:prstGeom>
+          <a:noFill/>
+          <a:ln/>
+        </p:spPr>
+        <p:txBody>
+          <a:bodyPr wrap="square" lIns="0" tIns="0" rIns="0" bIns="0" rtlCol="0" anchor="ctr"/>
+          <a:lstStyle/>
+          <a:p>
+            <a:pPr marL="0" indent="0" algn="ctr">
+              <a:buNone/>
+            </a:pPr>
+            <a:r>
+              <a:rPr lang="en-US" sz="1400" kern="0" dirty="0">
+                <a:solidFill>
+                  <a:srgbClr val="3B82F6"/>
+                </a:solidFill>
+                <a:latin typeface="Inter" pitchFamily="34" charset="0"/>
+                <a:ea typeface="Inter" pitchFamily="34" charset="-122"/>
+                <a:cs typeface="Inter" pitchFamily="34" charset="-120"/>
+              </a:rPr>
+              <a:t>↓</a:t>
+            </a:r>
+          </a:p>
+        </p:txBody>
+      </p:sp>
+      <p:sp>
+        <p:nvSpPr>
+          <p:cNvPr id="8" name="Text"/>
+          <p:cNvSpPr/>
+          <p:nvPr/>
+        </p:nvSpPr>
+        <p:spPr>
+          <a:xfrm>
+            <a:off x="457200" y="2370000"/>
+            <a:ext cx="8229600" cy="180000"/>
+          </a:xfrm>
+          <a:prstGeom prst="rect">
+            <a:avLst/>
+          </a:prstGeom>
+          <a:noFill/>
+          <a:ln/>
+        </p:spPr>
+        <p:txBody>
+          <a:bodyPr wrap="square" lIns="0" tIns="0" rIns="0" bIns="0" rtlCol="0" anchor="ctr"/>
+          <a:lstStyle/>
+          <a:p>
+            <a:pPr marL="0" indent="0" algn="l">
+              <a:buNone/>
+            </a:pPr>
+            <a:r>
+              <a:rPr lang="en-US" sz="900" b="1" kern="0" spc="200" dirty="0">
+                <a:solidFill>
+                  <a:srgbClr val="3B82F6"/>
+                </a:solidFill>
+                <a:latin typeface="Inter" pitchFamily="34" charset="0"/>
+                <a:ea typeface="Inter" pitchFamily="34" charset="-122"/>
+                <a:cs typeface="Inter" pitchFamily="34" charset="-120"/>
+              </a:rPr>
+              <a:t>FOR EACH STEP IN THE PLAN</a:t>
+            </a:r>
+          </a:p>
+        </p:txBody>
+      </p:sp>
+      <p:sp>
+        <p:nvSpPr>
+          <p:cNvPr id="9" name="Pill"/>
+          <p:cNvSpPr/>
+          <p:nvPr/>
+        </p:nvSpPr>
+        <p:spPr>
+          <a:xfrm>
+            <a:off x="457200" y="2550000"/>
+            <a:ext cx="1234440" cy="560000"/>
           </a:xfrm>
           <a:prstGeom prst="roundRect">
             <a:avLst>
@@ -3877,39 +3900,14 @@
           </a:ln>
         </p:spPr>
         <p:txBody>
-          <a:bodyPr/>
-          <a:lstStyle/>
-          <a:p>
-            <a:endParaRPr/>
-          </a:p>
-        </p:txBody>
-      </p:sp>
-      <p:sp>
-        <p:nvSpPr>
-          <p:cNvPr id="10" name="Text 8"/>
-          <p:cNvSpPr/>
-          <p:nvPr/>
-        </p:nvSpPr>
-        <p:spPr>
-          <a:xfrm>
-            <a:off x="1499616" y="2103120"/>
-            <a:ext cx="932688" cy="502920"/>
-          </a:xfrm>
-          <a:prstGeom prst="rect">
-            <a:avLst/>
-          </a:prstGeom>
-          <a:noFill/>
-          <a:ln/>
-        </p:spPr>
-        <p:txBody>
-          <a:bodyPr wrap="square" lIns="0" tIns="0" rIns="0" bIns="0" rtlCol="0" anchor="ctr"/>
+          <a:bodyPr wrap="square" lIns="36000" tIns="0" rIns="36000" bIns="0" rtlCol="0" anchor="ctr"/>
           <a:lstStyle/>
           <a:p>
             <a:pPr marL="0" indent="0" algn="ctr">
               <a:buNone/>
             </a:pPr>
             <a:r>
-              <a:rPr lang="en-US" sz="1100" b="1" dirty="0">
+              <a:rPr lang="en-US" sz="1050" b="1" kern="0" dirty="0">
                 <a:solidFill>
                   <a:srgbClr val="F8FAFC"/>
                 </a:solidFill>
@@ -3919,36 +3917,13 @@
               </a:rPr>
               <a:t>explore</a:t>
             </a:r>
-            <a:endParaRPr lang="en-US" sz="1100" dirty="0"/>
-          </a:p>
-        </p:txBody>
-      </p:sp>
-      <p:sp>
-        <p:nvSpPr>
-          <p:cNvPr id="11" name="Text 9"/>
-          <p:cNvSpPr/>
-          <p:nvPr/>
-        </p:nvSpPr>
-        <p:spPr>
-          <a:xfrm>
-            <a:off x="2414016" y="2103120"/>
-            <a:ext cx="164592" cy="502920"/>
-          </a:xfrm>
-          <a:prstGeom prst="rect">
-            <a:avLst/>
-          </a:prstGeom>
-          <a:noFill/>
-          <a:ln/>
-        </p:spPr>
-        <p:txBody>
-          <a:bodyPr wrap="square" lIns="0" tIns="0" rIns="0" bIns="0" rtlCol="0" anchor="ctr"/>
-          <a:lstStyle/>
+          </a:p>
           <a:p>
             <a:pPr marL="0" indent="0" algn="ctr">
               <a:buNone/>
             </a:pPr>
             <a:r>
-              <a:rPr lang="en-US" sz="1000" dirty="0">
+              <a:rPr lang="en-US" sz="750" kern="0" dirty="0">
                 <a:solidFill>
                   <a:srgbClr val="3B82F6"/>
                 </a:solidFill>
@@ -3956,22 +3931,59 @@
                 <a:ea typeface="Inter" pitchFamily="34" charset="-122"/>
                 <a:cs typeface="Inter" pitchFamily="34" charset="-120"/>
               </a:rPr>
+              <a:t>/explore-codebase</a:t>
+            </a:r>
+          </a:p>
+        </p:txBody>
+      </p:sp>
+      <p:sp>
+        <p:nvSpPr>
+          <p:cNvPr id="10" name="Arrow"/>
+          <p:cNvSpPr/>
+          <p:nvPr/>
+        </p:nvSpPr>
+        <p:spPr>
+          <a:xfrm>
+            <a:off x="1691640" y="2550000"/>
+            <a:ext cx="164592" cy="560000"/>
+          </a:xfrm>
+          <a:prstGeom prst="rect">
+            <a:avLst/>
+          </a:prstGeom>
+          <a:noFill/>
+          <a:ln/>
+        </p:spPr>
+        <p:txBody>
+          <a:bodyPr wrap="square" lIns="0" tIns="0" rIns="0" bIns="0" rtlCol="0" anchor="ctr"/>
+          <a:lstStyle/>
+          <a:p>
+            <a:pPr marL="0" indent="0" algn="ctr">
+              <a:buNone/>
+            </a:pPr>
+            <a:r>
+              <a:rPr lang="en-US" sz="1000" kern="0" dirty="0">
+                <a:solidFill>
+                  <a:srgbClr val="3B82F6"/>
+                </a:solidFill>
+                <a:latin typeface="Inter" pitchFamily="34" charset="0"/>
+                <a:ea typeface="Inter" pitchFamily="34" charset="-122"/>
+                <a:cs typeface="Inter" pitchFamily="34" charset="-120"/>
+              </a:rPr>
               <a:t>→</a:t>
             </a:r>
-            <a:endParaRPr lang="en-US" sz="1000" dirty="0"/>
-          </a:p>
-        </p:txBody>
-      </p:sp>
-      <p:sp>
-        <p:nvSpPr>
-          <p:cNvPr id="12" name="Shape 10"/>
-          <p:cNvSpPr/>
-          <p:nvPr/>
-        </p:nvSpPr>
-        <p:spPr>
-          <a:xfrm>
-            <a:off x="2542032" y="2103120"/>
-            <a:ext cx="932688" cy="502920"/>
+          </a:p>
+        </p:txBody>
+      </p:sp>
+      <p:sp>
+        <p:nvSpPr>
+          <p:cNvPr id="11" name="Pill"/>
+          <p:cNvSpPr/>
+          <p:nvPr/>
+        </p:nvSpPr>
+        <p:spPr>
+          <a:xfrm>
+            <a:off x="1856232" y="2550000"/>
+            <a:ext cx="1234440" cy="560000"/>
           </a:xfrm>
           <a:prstGeom prst="roundRect">
             <a:avLst>
@@ -3989,39 +4001,14 @@
           </a:ln>
         </p:spPr>
         <p:txBody>
-          <a:bodyPr/>
-          <a:lstStyle/>
-          <a:p>
-            <a:endParaRPr/>
-          </a:p>
-        </p:txBody>
-      </p:sp>
-      <p:sp>
-        <p:nvSpPr>
-          <p:cNvPr id="13" name="Text 11"/>
-          <p:cNvSpPr/>
-          <p:nvPr/>
-        </p:nvSpPr>
-        <p:spPr>
-          <a:xfrm>
-            <a:off x="2542032" y="2103120"/>
-            <a:ext cx="932688" cy="502920"/>
-          </a:xfrm>
-          <a:prstGeom prst="rect">
-            <a:avLst/>
-          </a:prstGeom>
-          <a:noFill/>
-          <a:ln/>
-        </p:spPr>
-        <p:txBody>
-          <a:bodyPr wrap="square" lIns="0" tIns="0" rIns="0" bIns="0" rtlCol="0" anchor="ctr"/>
+          <a:bodyPr wrap="square" lIns="36000" tIns="0" rIns="36000" bIns="0" rtlCol="0" anchor="ctr"/>
           <a:lstStyle/>
           <a:p>
             <a:pPr marL="0" indent="0" algn="ctr">
               <a:buNone/>
             </a:pPr>
             <a:r>
-              <a:rPr lang="en-US" sz="1100" b="1" dirty="0">
+              <a:rPr lang="en-US" sz="1050" b="1" kern="0" dirty="0">
                 <a:solidFill>
                   <a:srgbClr val="F8FAFC"/>
                 </a:solidFill>
@@ -4031,36 +4018,13 @@
               </a:rPr>
               <a:t>implement</a:t>
             </a:r>
-            <a:endParaRPr lang="en-US" sz="1100" dirty="0"/>
-          </a:p>
-        </p:txBody>
-      </p:sp>
-      <p:sp>
-        <p:nvSpPr>
-          <p:cNvPr id="14" name="Text 12"/>
-          <p:cNvSpPr/>
-          <p:nvPr/>
-        </p:nvSpPr>
-        <p:spPr>
-          <a:xfrm>
-            <a:off x="3456432" y="2103120"/>
-            <a:ext cx="164592" cy="502920"/>
-          </a:xfrm>
-          <a:prstGeom prst="rect">
-            <a:avLst/>
-          </a:prstGeom>
-          <a:noFill/>
-          <a:ln/>
-        </p:spPr>
-        <p:txBody>
-          <a:bodyPr wrap="square" lIns="0" tIns="0" rIns="0" bIns="0" rtlCol="0" anchor="ctr"/>
-          <a:lstStyle/>
+          </a:p>
           <a:p>
             <a:pPr marL="0" indent="0" algn="ctr">
               <a:buNone/>
             </a:pPr>
             <a:r>
-              <a:rPr lang="en-US" sz="1000" dirty="0">
+              <a:rPr lang="en-US" sz="750" kern="0" dirty="0">
                 <a:solidFill>
                   <a:srgbClr val="3B82F6"/>
                 </a:solidFill>
@@ -4068,22 +4032,59 @@
                 <a:ea typeface="Inter" pitchFamily="34" charset="-122"/>
                 <a:cs typeface="Inter" pitchFamily="34" charset="-120"/>
               </a:rPr>
+              <a:t>/new-endpoint</a:t>
+            </a:r>
+          </a:p>
+        </p:txBody>
+      </p:sp>
+      <p:sp>
+        <p:nvSpPr>
+          <p:cNvPr id="12" name="Arrow"/>
+          <p:cNvSpPr/>
+          <p:nvPr/>
+        </p:nvSpPr>
+        <p:spPr>
+          <a:xfrm>
+            <a:off x="3090672" y="2550000"/>
+            <a:ext cx="164592" cy="560000"/>
+          </a:xfrm>
+          <a:prstGeom prst="rect">
+            <a:avLst/>
+          </a:prstGeom>
+          <a:noFill/>
+          <a:ln/>
+        </p:spPr>
+        <p:txBody>
+          <a:bodyPr wrap="square" lIns="0" tIns="0" rIns="0" bIns="0" rtlCol="0" anchor="ctr"/>
+          <a:lstStyle/>
+          <a:p>
+            <a:pPr marL="0" indent="0" algn="ctr">
+              <a:buNone/>
+            </a:pPr>
+            <a:r>
+              <a:rPr lang="en-US" sz="1000" kern="0" dirty="0">
+                <a:solidFill>
+                  <a:srgbClr val="3B82F6"/>
+                </a:solidFill>
+                <a:latin typeface="Inter" pitchFamily="34" charset="0"/>
+                <a:ea typeface="Inter" pitchFamily="34" charset="-122"/>
+                <a:cs typeface="Inter" pitchFamily="34" charset="-120"/>
+              </a:rPr>
               <a:t>→</a:t>
             </a:r>
-            <a:endParaRPr lang="en-US" sz="1000" dirty="0"/>
-          </a:p>
-        </p:txBody>
-      </p:sp>
-      <p:sp>
-        <p:nvSpPr>
-          <p:cNvPr id="15" name="Shape 13"/>
-          <p:cNvSpPr/>
-          <p:nvPr/>
-        </p:nvSpPr>
-        <p:spPr>
-          <a:xfrm>
-            <a:off x="3584448" y="2103120"/>
-            <a:ext cx="932688" cy="502920"/>
+          </a:p>
+        </p:txBody>
+      </p:sp>
+      <p:sp>
+        <p:nvSpPr>
+          <p:cNvPr id="13" name="Pill"/>
+          <p:cNvSpPr/>
+          <p:nvPr/>
+        </p:nvSpPr>
+        <p:spPr>
+          <a:xfrm>
+            <a:off x="3255264" y="2550000"/>
+            <a:ext cx="1234440" cy="560000"/>
           </a:xfrm>
           <a:prstGeom prst="roundRect">
             <a:avLst>
@@ -4101,39 +4102,14 @@
           </a:ln>
         </p:spPr>
         <p:txBody>
-          <a:bodyPr/>
-          <a:lstStyle/>
-          <a:p>
-            <a:endParaRPr/>
-          </a:p>
-        </p:txBody>
-      </p:sp>
-      <p:sp>
-        <p:nvSpPr>
-          <p:cNvPr id="16" name="Text 14"/>
-          <p:cNvSpPr/>
-          <p:nvPr/>
-        </p:nvSpPr>
-        <p:spPr>
-          <a:xfrm>
-            <a:off x="3584448" y="2103120"/>
-            <a:ext cx="932688" cy="502920"/>
-          </a:xfrm>
-          <a:prstGeom prst="rect">
-            <a:avLst/>
-          </a:prstGeom>
-          <a:noFill/>
-          <a:ln/>
-        </p:spPr>
-        <p:txBody>
-          <a:bodyPr wrap="square" lIns="0" tIns="0" rIns="0" bIns="0" rtlCol="0" anchor="ctr"/>
+          <a:bodyPr wrap="square" lIns="36000" tIns="0" rIns="36000" bIns="0" rtlCol="0" anchor="ctr"/>
           <a:lstStyle/>
           <a:p>
             <a:pPr marL="0" indent="0" algn="ctr">
               <a:buNone/>
             </a:pPr>
             <a:r>
-              <a:rPr lang="en-US" sz="1100" b="1" dirty="0">
+              <a:rPr lang="en-US" sz="1050" b="1" kern="0" dirty="0">
                 <a:solidFill>
                   <a:srgbClr val="F8FAFC"/>
                 </a:solidFill>
@@ -4143,36 +4119,13 @@
               </a:rPr>
               <a:t>test</a:t>
             </a:r>
-            <a:endParaRPr lang="en-US" sz="1100" dirty="0"/>
-          </a:p>
-        </p:txBody>
-      </p:sp>
-      <p:sp>
-        <p:nvSpPr>
-          <p:cNvPr id="17" name="Text 15"/>
-          <p:cNvSpPr/>
-          <p:nvPr/>
-        </p:nvSpPr>
-        <p:spPr>
-          <a:xfrm>
-            <a:off x="4498848" y="2103120"/>
-            <a:ext cx="164592" cy="502920"/>
-          </a:xfrm>
-          <a:prstGeom prst="rect">
-            <a:avLst/>
-          </a:prstGeom>
-          <a:noFill/>
-          <a:ln/>
-        </p:spPr>
-        <p:txBody>
-          <a:bodyPr wrap="square" lIns="0" tIns="0" rIns="0" bIns="0" rtlCol="0" anchor="ctr"/>
-          <a:lstStyle/>
+          </a:p>
           <a:p>
             <a:pPr marL="0" indent="0" algn="ctr">
               <a:buNone/>
             </a:pPr>
             <a:r>
-              <a:rPr lang="en-US" sz="1000" dirty="0">
+              <a:rPr lang="en-US" sz="750" kern="0" dirty="0">
                 <a:solidFill>
                   <a:srgbClr val="3B82F6"/>
                 </a:solidFill>
@@ -4180,22 +4133,59 @@
                 <a:ea typeface="Inter" pitchFamily="34" charset="-122"/>
                 <a:cs typeface="Inter" pitchFamily="34" charset="-120"/>
               </a:rPr>
+              <a:t>make test</a:t>
+            </a:r>
+          </a:p>
+        </p:txBody>
+      </p:sp>
+      <p:sp>
+        <p:nvSpPr>
+          <p:cNvPr id="14" name="Arrow"/>
+          <p:cNvSpPr/>
+          <p:nvPr/>
+        </p:nvSpPr>
+        <p:spPr>
+          <a:xfrm>
+            <a:off x="4489704" y="2550000"/>
+            <a:ext cx="164592" cy="560000"/>
+          </a:xfrm>
+          <a:prstGeom prst="rect">
+            <a:avLst/>
+          </a:prstGeom>
+          <a:noFill/>
+          <a:ln/>
+        </p:spPr>
+        <p:txBody>
+          <a:bodyPr wrap="square" lIns="0" tIns="0" rIns="0" bIns="0" rtlCol="0" anchor="ctr"/>
+          <a:lstStyle/>
+          <a:p>
+            <a:pPr marL="0" indent="0" algn="ctr">
+              <a:buNone/>
+            </a:pPr>
+            <a:r>
+              <a:rPr lang="en-US" sz="1000" kern="0" dirty="0">
+                <a:solidFill>
+                  <a:srgbClr val="3B82F6"/>
+                </a:solidFill>
+                <a:latin typeface="Inter" pitchFamily="34" charset="0"/>
+                <a:ea typeface="Inter" pitchFamily="34" charset="-122"/>
+                <a:cs typeface="Inter" pitchFamily="34" charset="-120"/>
+              </a:rPr>
               <a:t>→</a:t>
             </a:r>
-            <a:endParaRPr lang="en-US" sz="1000" dirty="0"/>
-          </a:p>
-        </p:txBody>
-      </p:sp>
-      <p:sp>
-        <p:nvSpPr>
-          <p:cNvPr id="18" name="Shape 16"/>
-          <p:cNvSpPr/>
-          <p:nvPr/>
-        </p:nvSpPr>
-        <p:spPr>
-          <a:xfrm>
-            <a:off x="4626864" y="2103120"/>
-            <a:ext cx="932688" cy="502920"/>
+          </a:p>
+        </p:txBody>
+      </p:sp>
+      <p:sp>
+        <p:nvSpPr>
+          <p:cNvPr id="15" name="Pill"/>
+          <p:cNvSpPr/>
+          <p:nvPr/>
+        </p:nvSpPr>
+        <p:spPr>
+          <a:xfrm>
+            <a:off x="4654296" y="2550000"/>
+            <a:ext cx="1234440" cy="560000"/>
           </a:xfrm>
           <a:prstGeom prst="roundRect">
             <a:avLst>
@@ -4213,39 +4203,14 @@
           </a:ln>
         </p:spPr>
         <p:txBody>
-          <a:bodyPr/>
-          <a:lstStyle/>
-          <a:p>
-            <a:endParaRPr/>
-          </a:p>
-        </p:txBody>
-      </p:sp>
-      <p:sp>
-        <p:nvSpPr>
-          <p:cNvPr id="19" name="Text 17"/>
-          <p:cNvSpPr/>
-          <p:nvPr/>
-        </p:nvSpPr>
-        <p:spPr>
-          <a:xfrm>
-            <a:off x="4626864" y="2103120"/>
-            <a:ext cx="932688" cy="502920"/>
-          </a:xfrm>
-          <a:prstGeom prst="rect">
-            <a:avLst/>
-          </a:prstGeom>
-          <a:noFill/>
-          <a:ln/>
-        </p:spPr>
-        <p:txBody>
-          <a:bodyPr wrap="square" lIns="0" tIns="0" rIns="0" bIns="0" rtlCol="0" anchor="ctr"/>
+          <a:bodyPr wrap="square" lIns="36000" tIns="0" rIns="36000" bIns="0" rtlCol="0" anchor="ctr"/>
           <a:lstStyle/>
           <a:p>
             <a:pPr marL="0" indent="0" algn="ctr">
               <a:buNone/>
             </a:pPr>
             <a:r>
-              <a:rPr lang="en-US" sz="1100" b="1" dirty="0">
+              <a:rPr lang="en-US" sz="1050" b="1" kern="0" dirty="0">
                 <a:solidFill>
                   <a:srgbClr val="F8FAFC"/>
                 </a:solidFill>
@@ -4255,36 +4220,13 @@
               </a:rPr>
               <a:t>review</a:t>
             </a:r>
-            <a:endParaRPr lang="en-US" sz="1100" dirty="0"/>
-          </a:p>
-        </p:txBody>
-      </p:sp>
-      <p:sp>
-        <p:nvSpPr>
-          <p:cNvPr id="20" name="Text 18"/>
-          <p:cNvSpPr/>
-          <p:nvPr/>
-        </p:nvSpPr>
-        <p:spPr>
-          <a:xfrm>
-            <a:off x="5541264" y="2103120"/>
-            <a:ext cx="164592" cy="502920"/>
-          </a:xfrm>
-          <a:prstGeom prst="rect">
-            <a:avLst/>
-          </a:prstGeom>
-          <a:noFill/>
-          <a:ln/>
-        </p:spPr>
-        <p:txBody>
-          <a:bodyPr wrap="square" lIns="0" tIns="0" rIns="0" bIns="0" rtlCol="0" anchor="ctr"/>
-          <a:lstStyle/>
+          </a:p>
           <a:p>
             <a:pPr marL="0" indent="0" algn="ctr">
               <a:buNone/>
             </a:pPr>
             <a:r>
-              <a:rPr lang="en-US" sz="1000" dirty="0">
+              <a:rPr lang="en-US" sz="750" kern="0" dirty="0">
                 <a:solidFill>
                   <a:srgbClr val="3B82F6"/>
                 </a:solidFill>
@@ -4292,22 +4234,59 @@
                 <a:ea typeface="Inter" pitchFamily="34" charset="-122"/>
                 <a:cs typeface="Inter" pitchFamily="34" charset="-120"/>
               </a:rPr>
+              <a:t>/simplify</a:t>
+            </a:r>
+          </a:p>
+        </p:txBody>
+      </p:sp>
+      <p:sp>
+        <p:nvSpPr>
+          <p:cNvPr id="16" name="Arrow"/>
+          <p:cNvSpPr/>
+          <p:nvPr/>
+        </p:nvSpPr>
+        <p:spPr>
+          <a:xfrm>
+            <a:off x="5888736" y="2550000"/>
+            <a:ext cx="164592" cy="560000"/>
+          </a:xfrm>
+          <a:prstGeom prst="rect">
+            <a:avLst/>
+          </a:prstGeom>
+          <a:noFill/>
+          <a:ln/>
+        </p:spPr>
+        <p:txBody>
+          <a:bodyPr wrap="square" lIns="0" tIns="0" rIns="0" bIns="0" rtlCol="0" anchor="ctr"/>
+          <a:lstStyle/>
+          <a:p>
+            <a:pPr marL="0" indent="0" algn="ctr">
+              <a:buNone/>
+            </a:pPr>
+            <a:r>
+              <a:rPr lang="en-US" sz="1000" kern="0" dirty="0">
+                <a:solidFill>
+                  <a:srgbClr val="3B82F6"/>
+                </a:solidFill>
+                <a:latin typeface="Inter" pitchFamily="34" charset="0"/>
+                <a:ea typeface="Inter" pitchFamily="34" charset="-122"/>
+                <a:cs typeface="Inter" pitchFamily="34" charset="-120"/>
+              </a:rPr>
               <a:t>→</a:t>
             </a:r>
-            <a:endParaRPr lang="en-US" sz="1000" dirty="0"/>
-          </a:p>
-        </p:txBody>
-      </p:sp>
-      <p:sp>
-        <p:nvSpPr>
-          <p:cNvPr id="21" name="Shape 19"/>
-          <p:cNvSpPr/>
-          <p:nvPr/>
-        </p:nvSpPr>
-        <p:spPr>
-          <a:xfrm>
-            <a:off x="5669280" y="2103120"/>
-            <a:ext cx="932688" cy="502920"/>
+          </a:p>
+        </p:txBody>
+      </p:sp>
+      <p:sp>
+        <p:nvSpPr>
+          <p:cNvPr id="17" name="Pill"/>
+          <p:cNvSpPr/>
+          <p:nvPr/>
+        </p:nvSpPr>
+        <p:spPr>
+          <a:xfrm>
+            <a:off x="6053328" y="2550000"/>
+            <a:ext cx="1234440" cy="560000"/>
           </a:xfrm>
           <a:prstGeom prst="roundRect">
             <a:avLst>
@@ -4325,39 +4304,14 @@
           </a:ln>
         </p:spPr>
         <p:txBody>
-          <a:bodyPr/>
-          <a:lstStyle/>
-          <a:p>
-            <a:endParaRPr/>
-          </a:p>
-        </p:txBody>
-      </p:sp>
-      <p:sp>
-        <p:nvSpPr>
-          <p:cNvPr id="22" name="Text 20"/>
-          <p:cNvSpPr/>
-          <p:nvPr/>
-        </p:nvSpPr>
-        <p:spPr>
-          <a:xfrm>
-            <a:off x="5669280" y="2103120"/>
-            <a:ext cx="932688" cy="502920"/>
-          </a:xfrm>
-          <a:prstGeom prst="rect">
-            <a:avLst/>
-          </a:prstGeom>
-          <a:noFill/>
-          <a:ln/>
-        </p:spPr>
-        <p:txBody>
-          <a:bodyPr wrap="square" lIns="0" tIns="0" rIns="0" bIns="0" rtlCol="0" anchor="ctr"/>
+          <a:bodyPr wrap="square" lIns="36000" tIns="0" rIns="36000" bIns="0" rtlCol="0" anchor="ctr"/>
           <a:lstStyle/>
           <a:p>
             <a:pPr marL="0" indent="0" algn="ctr">
               <a:buNone/>
             </a:pPr>
             <a:r>
-              <a:rPr lang="en-US" sz="1100" b="1" dirty="0">
+              <a:rPr lang="en-US" sz="1050" b="1" kern="0" dirty="0">
                 <a:solidFill>
                   <a:srgbClr val="F8FAFC"/>
                 </a:solidFill>
@@ -4367,36 +4321,13 @@
               </a:rPr>
               <a:t>audit</a:t>
             </a:r>
-            <a:endParaRPr lang="en-US" sz="1100" dirty="0"/>
-          </a:p>
-        </p:txBody>
-      </p:sp>
-      <p:sp>
-        <p:nvSpPr>
-          <p:cNvPr id="23" name="Text 21"/>
-          <p:cNvSpPr/>
-          <p:nvPr/>
-        </p:nvSpPr>
-        <p:spPr>
-          <a:xfrm>
-            <a:off x="6583680" y="2103120"/>
-            <a:ext cx="164592" cy="502920"/>
-          </a:xfrm>
-          <a:prstGeom prst="rect">
-            <a:avLst/>
-          </a:prstGeom>
-          <a:noFill/>
-          <a:ln/>
-        </p:spPr>
-        <p:txBody>
-          <a:bodyPr wrap="square" lIns="0" tIns="0" rIns="0" bIns="0" rtlCol="0" anchor="ctr"/>
-          <a:lstStyle/>
+          </a:p>
           <a:p>
             <a:pPr marL="0" indent="0" algn="ctr">
               <a:buNone/>
             </a:pPr>
             <a:r>
-              <a:rPr lang="en-US" sz="1000" dirty="0">
+              <a:rPr lang="en-US" sz="750" kern="0" dirty="0">
                 <a:solidFill>
                   <a:srgbClr val="3B82F6"/>
                 </a:solidFill>
@@ -4404,22 +4335,59 @@
                 <a:ea typeface="Inter" pitchFamily="34" charset="-122"/>
                 <a:cs typeface="Inter" pitchFamily="34" charset="-120"/>
               </a:rPr>
+              <a:t>/audit-security</a:t>
+            </a:r>
+          </a:p>
+        </p:txBody>
+      </p:sp>
+      <p:sp>
+        <p:nvSpPr>
+          <p:cNvPr id="18" name="Arrow"/>
+          <p:cNvSpPr/>
+          <p:nvPr/>
+        </p:nvSpPr>
+        <p:spPr>
+          <a:xfrm>
+            <a:off x="7287768" y="2550000"/>
+            <a:ext cx="164592" cy="560000"/>
+          </a:xfrm>
+          <a:prstGeom prst="rect">
+            <a:avLst/>
+          </a:prstGeom>
+          <a:noFill/>
+          <a:ln/>
+        </p:spPr>
+        <p:txBody>
+          <a:bodyPr wrap="square" lIns="0" tIns="0" rIns="0" bIns="0" rtlCol="0" anchor="ctr"/>
+          <a:lstStyle/>
+          <a:p>
+            <a:pPr marL="0" indent="0" algn="ctr">
+              <a:buNone/>
+            </a:pPr>
+            <a:r>
+              <a:rPr lang="en-US" sz="1000" kern="0" dirty="0">
+                <a:solidFill>
+                  <a:srgbClr val="3B82F6"/>
+                </a:solidFill>
+                <a:latin typeface="Inter" pitchFamily="34" charset="0"/>
+                <a:ea typeface="Inter" pitchFamily="34" charset="-122"/>
+                <a:cs typeface="Inter" pitchFamily="34" charset="-120"/>
+              </a:rPr>
               <a:t>→</a:t>
             </a:r>
-            <a:endParaRPr lang="en-US" sz="1000" dirty="0"/>
-          </a:p>
-        </p:txBody>
-      </p:sp>
-      <p:sp>
-        <p:nvSpPr>
-          <p:cNvPr id="24" name="Shape 22"/>
-          <p:cNvSpPr/>
-          <p:nvPr/>
-        </p:nvSpPr>
-        <p:spPr>
-          <a:xfrm>
-            <a:off x="6711696" y="2103120"/>
-            <a:ext cx="932688" cy="502920"/>
+          </a:p>
+        </p:txBody>
+      </p:sp>
+      <p:sp>
+        <p:nvSpPr>
+          <p:cNvPr id="19" name="Pill"/>
+          <p:cNvSpPr/>
+          <p:nvPr/>
+        </p:nvSpPr>
+        <p:spPr>
+          <a:xfrm>
+            <a:off x="7452360" y="2550000"/>
+            <a:ext cx="1234440" cy="560000"/>
           </a:xfrm>
           <a:prstGeom prst="roundRect">
             <a:avLst>
@@ -4437,39 +4405,14 @@
           </a:ln>
         </p:spPr>
         <p:txBody>
-          <a:bodyPr/>
-          <a:lstStyle/>
-          <a:p>
-            <a:endParaRPr/>
-          </a:p>
-        </p:txBody>
-      </p:sp>
-      <p:sp>
-        <p:nvSpPr>
-          <p:cNvPr id="25" name="Text 23"/>
-          <p:cNvSpPr/>
-          <p:nvPr/>
-        </p:nvSpPr>
-        <p:spPr>
-          <a:xfrm>
-            <a:off x="6711696" y="2103120"/>
-            <a:ext cx="932688" cy="502920"/>
-          </a:xfrm>
-          <a:prstGeom prst="rect">
-            <a:avLst/>
-          </a:prstGeom>
-          <a:noFill/>
-          <a:ln/>
-        </p:spPr>
-        <p:txBody>
-          <a:bodyPr wrap="square" lIns="0" tIns="0" rIns="0" bIns="0" rtlCol="0" anchor="ctr"/>
+          <a:bodyPr wrap="square" lIns="36000" tIns="0" rIns="36000" bIns="0" rtlCol="0" anchor="ctr"/>
           <a:lstStyle/>
           <a:p>
             <a:pPr marL="0" indent="0" algn="ctr">
               <a:buNone/>
             </a:pPr>
             <a:r>
-              <a:rPr lang="en-US" sz="1100" b="1" dirty="0">
+              <a:rPr lang="en-US" sz="1050" b="1" kern="0" dirty="0">
                 <a:solidFill>
                   <a:srgbClr val="F8FAFC"/>
                 </a:solidFill>
@@ -4479,36 +4422,13 @@
               </a:rPr>
               <a:t>commit</a:t>
             </a:r>
-            <a:endParaRPr lang="en-US" sz="1100" dirty="0"/>
-          </a:p>
-        </p:txBody>
-      </p:sp>
-      <p:sp>
-        <p:nvSpPr>
-          <p:cNvPr id="26" name="Text 24"/>
-          <p:cNvSpPr/>
-          <p:nvPr/>
-        </p:nvSpPr>
-        <p:spPr>
-          <a:xfrm>
-            <a:off x="7626096" y="2103120"/>
-            <a:ext cx="164592" cy="502920"/>
-          </a:xfrm>
-          <a:prstGeom prst="rect">
-            <a:avLst/>
-          </a:prstGeom>
-          <a:noFill/>
-          <a:ln/>
-        </p:spPr>
-        <p:txBody>
-          <a:bodyPr wrap="square" lIns="0" tIns="0" rIns="0" bIns="0" rtlCol="0" anchor="ctr"/>
-          <a:lstStyle/>
+          </a:p>
           <a:p>
             <a:pPr marL="0" indent="0" algn="ctr">
               <a:buNone/>
             </a:pPr>
             <a:r>
-              <a:rPr lang="en-US" sz="1000" dirty="0">
+              <a:rPr lang="en-US" sz="750" kern="0" dirty="0">
                 <a:solidFill>
                   <a:srgbClr val="3B82F6"/>
                 </a:solidFill>
@@ -4516,22 +4436,135 @@
                 <a:ea typeface="Inter" pitchFamily="34" charset="-122"/>
                 <a:cs typeface="Inter" pitchFamily="34" charset="-120"/>
               </a:rPr>
-              <a:t>→</a:t>
-            </a:r>
-            <a:endParaRPr lang="en-US" sz="1000" dirty="0"/>
-          </a:p>
-        </p:txBody>
-      </p:sp>
-      <p:sp>
-        <p:nvSpPr>
-          <p:cNvPr id="27" name="Shape 25"/>
-          <p:cNvSpPr/>
-          <p:nvPr/>
-        </p:nvSpPr>
-        <p:spPr>
-          <a:xfrm>
-            <a:off x="7754112" y="2103120"/>
-            <a:ext cx="932688" cy="502920"/>
+              <a:t>/commit-sc</a:t>
+            </a:r>
+          </a:p>
+        </p:txBody>
+      </p:sp>
+      <p:sp>
+        <p:nvSpPr>
+          <p:cNvPr id="20" name="Text"/>
+          <p:cNvSpPr/>
+          <p:nvPr/>
+        </p:nvSpPr>
+        <p:spPr>
+          <a:xfrm>
+            <a:off x="3255264" y="3120000"/>
+            <a:ext cx="1234440" cy="150000"/>
+          </a:xfrm>
+          <a:prstGeom prst="rect">
+            <a:avLst/>
+          </a:prstGeom>
+          <a:noFill/>
+          <a:ln/>
+        </p:spPr>
+        <p:txBody>
+          <a:bodyPr wrap="square" lIns="0" tIns="0" rIns="0" bIns="0" rtlCol="0" anchor="ctr"/>
+          <a:lstStyle/>
+          <a:p>
+            <a:pPr marL="0" indent="0" algn="ctr">
+              <a:buNone/>
+            </a:pPr>
+            <a:r>
+              <a:rPr lang="en-US" sz="800" kern="0" dirty="0">
+                <a:solidFill>
+                  <a:srgbClr val="94A3B8"/>
+                </a:solidFill>
+                <a:latin typeface="Inter" pitchFamily="34" charset="0"/>
+                <a:ea typeface="Inter" pitchFamily="34" charset="-122"/>
+                <a:cs typeface="Inter" pitchFamily="34" charset="-120"/>
+              </a:rPr>
+              <a:t>↺ fails → fix → retry × n</a:t>
+            </a:r>
+          </a:p>
+        </p:txBody>
+      </p:sp>
+      <p:sp>
+        <p:nvSpPr>
+          <p:cNvPr id="21" name="Text"/>
+          <p:cNvSpPr/>
+          <p:nvPr/>
+        </p:nvSpPr>
+        <p:spPr>
+          <a:xfrm>
+            <a:off x="4472000" y="3300000"/>
+            <a:ext cx="200000" cy="170000"/>
+          </a:xfrm>
+          <a:prstGeom prst="rect">
+            <a:avLst/>
+          </a:prstGeom>
+          <a:noFill/>
+          <a:ln/>
+        </p:spPr>
+        <p:txBody>
+          <a:bodyPr wrap="square" lIns="0" tIns="0" rIns="0" bIns="0" rtlCol="0" anchor="ctr"/>
+          <a:lstStyle/>
+          <a:p>
+            <a:pPr marL="0" indent="0" algn="ctr">
+              <a:buNone/>
+            </a:pPr>
+            <a:r>
+              <a:rPr lang="en-US" sz="1400" kern="0" dirty="0">
+                <a:solidFill>
+                  <a:srgbClr val="3B82F6"/>
+                </a:solidFill>
+                <a:latin typeface="Inter" pitchFamily="34" charset="0"/>
+                <a:ea typeface="Inter" pitchFamily="34" charset="-122"/>
+                <a:cs typeface="Inter" pitchFamily="34" charset="-120"/>
+              </a:rPr>
+              <a:t>↓</a:t>
+            </a:r>
+          </a:p>
+        </p:txBody>
+      </p:sp>
+      <p:sp>
+        <p:nvSpPr>
+          <p:cNvPr id="22" name="Text"/>
+          <p:cNvSpPr/>
+          <p:nvPr/>
+        </p:nvSpPr>
+        <p:spPr>
+          <a:xfrm>
+            <a:off x="457200" y="3470000"/>
+            <a:ext cx="8229600" cy="180000"/>
+          </a:xfrm>
+          <a:prstGeom prst="rect">
+            <a:avLst/>
+          </a:prstGeom>
+          <a:noFill/>
+          <a:ln/>
+        </p:spPr>
+        <p:txBody>
+          <a:bodyPr wrap="square" lIns="0" tIns="0" rIns="0" bIns="0" rtlCol="0" anchor="ctr"/>
+          <a:lstStyle/>
+          <a:p>
+            <a:pPr marL="0" indent="0" algn="l">
+              <a:buNone/>
+            </a:pPr>
+            <a:r>
+              <a:rPr lang="en-US" sz="900" b="1" kern="0" spc="200" dirty="0">
+                <a:solidFill>
+                  <a:srgbClr val="3B82F6"/>
+                </a:solidFill>
+                <a:latin typeface="Inter" pitchFamily="34" charset="0"/>
+                <a:ea typeface="Inter" pitchFamily="34" charset="-122"/>
+                <a:cs typeface="Inter" pitchFamily="34" charset="-120"/>
+              </a:rPr>
+              <a:t>ACCEPTANCE GATE · THEN SHIP</a:t>
+            </a:r>
+          </a:p>
+        </p:txBody>
+      </p:sp>
+      <p:sp>
+        <p:nvSpPr>
+          <p:cNvPr id="23" name="Pill"/>
+          <p:cNvSpPr/>
+          <p:nvPr/>
+        </p:nvSpPr>
+        <p:spPr>
+          <a:xfrm>
+            <a:off x="457200" y="3650000"/>
+            <a:ext cx="1514246" cy="560000"/>
           </a:xfrm>
           <a:prstGeom prst="roundRect">
             <a:avLst>
@@ -4549,39 +4582,14 @@
           </a:ln>
         </p:spPr>
         <p:txBody>
-          <a:bodyPr/>
-          <a:lstStyle/>
-          <a:p>
-            <a:endParaRPr/>
-          </a:p>
-        </p:txBody>
-      </p:sp>
-      <p:sp>
-        <p:nvSpPr>
-          <p:cNvPr id="28" name="Text 26"/>
-          <p:cNvSpPr/>
-          <p:nvPr/>
-        </p:nvSpPr>
-        <p:spPr>
-          <a:xfrm>
-            <a:off x="7754112" y="2103120"/>
-            <a:ext cx="932688" cy="502920"/>
-          </a:xfrm>
-          <a:prstGeom prst="rect">
-            <a:avLst/>
-          </a:prstGeom>
-          <a:noFill/>
-          <a:ln/>
-        </p:spPr>
-        <p:txBody>
-          <a:bodyPr wrap="square" lIns="0" tIns="0" rIns="0" bIns="0" rtlCol="0" anchor="ctr"/>
+          <a:bodyPr wrap="square" lIns="36000" tIns="0" rIns="36000" bIns="0" rtlCol="0" anchor="ctr"/>
           <a:lstStyle/>
           <a:p>
             <a:pPr marL="0" indent="0" algn="ctr">
               <a:buNone/>
             </a:pPr>
             <a:r>
-              <a:rPr lang="en-US" sz="1100" b="1" dirty="0">
+              <a:rPr lang="en-US" sz="1050" b="1" kern="0" dirty="0">
                 <a:solidFill>
                   <a:srgbClr val="F8FAFC"/>
                 </a:solidFill>
@@ -4589,38 +4597,457 @@
                 <a:ea typeface="Inter" pitchFamily="34" charset="-122"/>
                 <a:cs typeface="Inter" pitchFamily="34" charset="-120"/>
               </a:rPr>
-              <a:t>PR</a:t>
-            </a:r>
-            <a:endParaRPr lang="en-US" sz="1100" dirty="0"/>
-          </a:p>
-        </p:txBody>
-      </p:sp>
-      <p:sp>
-        <p:nvSpPr>
-          <p:cNvPr id="29" name="Text 27"/>
-          <p:cNvSpPr/>
-          <p:nvPr/>
-        </p:nvSpPr>
-        <p:spPr>
-          <a:xfrm>
-            <a:off x="457200" y="3108960"/>
-            <a:ext cx="8229600" cy="640080"/>
-          </a:xfrm>
-          <a:prstGeom prst="rect">
-            <a:avLst/>
-          </a:prstGeom>
-          <a:noFill/>
-          <a:ln/>
-        </p:spPr>
-        <p:txBody>
-          <a:bodyPr wrap="square" lIns="0" tIns="0" rIns="0" bIns="0" rtlCol="0" anchor="ctr"/>
-          <a:lstStyle/>
+              <a:t>acceptance gate</a:t>
+            </a:r>
+          </a:p>
           <a:p>
             <a:pPr marL="0" indent="0" algn="ctr">
               <a:buNone/>
             </a:pPr>
             <a:r>
-              <a:rPr lang="en-US" sz="1400" dirty="0">
+              <a:rPr lang="en-US" sz="750" kern="0" dirty="0">
+                <a:solidFill>
+                  <a:srgbClr val="3B82F6"/>
+                </a:solidFill>
+                <a:latin typeface="Inter" pitchFamily="34" charset="0"/>
+                <a:ea typeface="Inter" pitchFamily="34" charset="-122"/>
+                <a:cs typeface="Inter" pitchFamily="34" charset="-120"/>
+              </a:rPr>
+              <a:t>AC-1 … AC-6</a:t>
+            </a:r>
+          </a:p>
+        </p:txBody>
+      </p:sp>
+      <p:sp>
+        <p:nvSpPr>
+          <p:cNvPr id="24" name="Arrow"/>
+          <p:cNvSpPr/>
+          <p:nvPr/>
+        </p:nvSpPr>
+        <p:spPr>
+          <a:xfrm>
+            <a:off x="1971446" y="3650000"/>
+            <a:ext cx="164592" cy="560000"/>
+          </a:xfrm>
+          <a:prstGeom prst="rect">
+            <a:avLst/>
+          </a:prstGeom>
+          <a:noFill/>
+          <a:ln/>
+        </p:spPr>
+        <p:txBody>
+          <a:bodyPr wrap="square" lIns="0" tIns="0" rIns="0" bIns="0" rtlCol="0" anchor="ctr"/>
+          <a:lstStyle/>
+          <a:p>
+            <a:pPr marL="0" indent="0" algn="ctr">
+              <a:buNone/>
+            </a:pPr>
+            <a:r>
+              <a:rPr lang="en-US" sz="1000" kern="0" dirty="0">
+                <a:solidFill>
+                  <a:srgbClr val="3B82F6"/>
+                </a:solidFill>
+                <a:latin typeface="Inter" pitchFamily="34" charset="0"/>
+                <a:ea typeface="Inter" pitchFamily="34" charset="-122"/>
+                <a:cs typeface="Inter" pitchFamily="34" charset="-120"/>
+              </a:rPr>
+              <a:t>→</a:t>
+            </a:r>
+          </a:p>
+        </p:txBody>
+      </p:sp>
+      <p:sp>
+        <p:nvSpPr>
+          <p:cNvPr id="25" name="Pill"/>
+          <p:cNvSpPr/>
+          <p:nvPr/>
+        </p:nvSpPr>
+        <p:spPr>
+          <a:xfrm>
+            <a:off x="2136038" y="3650000"/>
+            <a:ext cx="1514246" cy="560000"/>
+          </a:xfrm>
+          <a:prstGeom prst="roundRect">
+            <a:avLst>
+              <a:gd name="adj" fmla="val 9091"/>
+            </a:avLst>
+          </a:prstGeom>
+          <a:solidFill>
+            <a:srgbClr val="1B2640"/>
+          </a:solidFill>
+          <a:ln w="9525">
+            <a:solidFill>
+              <a:srgbClr val="64748B"/>
+            </a:solidFill>
+            <a:prstDash val="solid"/>
+          </a:ln>
+        </p:spPr>
+        <p:txBody>
+          <a:bodyPr wrap="square" lIns="36000" tIns="0" rIns="36000" bIns="0" rtlCol="0" anchor="ctr"/>
+          <a:lstStyle/>
+          <a:p>
+            <a:pPr marL="0" indent="0" algn="ctr">
+              <a:buNone/>
+            </a:pPr>
+            <a:r>
+              <a:rPr lang="en-US" sz="1050" b="1" kern="0" dirty="0">
+                <a:solidFill>
+                  <a:srgbClr val="F8FAFC"/>
+                </a:solidFill>
+                <a:latin typeface="Inter" pitchFamily="34" charset="0"/>
+                <a:ea typeface="Inter" pitchFamily="34" charset="-122"/>
+                <a:cs typeface="Inter" pitchFamily="34" charset="-120"/>
+              </a:rPr>
+              <a:t>PR review</a:t>
+            </a:r>
+          </a:p>
+          <a:p>
+            <a:pPr marL="0" indent="0" algn="ctr">
+              <a:buNone/>
+            </a:pPr>
+            <a:r>
+              <a:rPr lang="en-US" sz="750" kern="0" dirty="0">
+                <a:solidFill>
+                  <a:srgbClr val="3B82F6"/>
+                </a:solidFill>
+                <a:latin typeface="Inter" pitchFamily="34" charset="0"/>
+                <a:ea typeface="Inter" pitchFamily="34" charset="-122"/>
+                <a:cs typeface="Inter" pitchFamily="34" charset="-120"/>
+              </a:rPr>
+              <a:t>/review-pr</a:t>
+            </a:r>
+          </a:p>
+        </p:txBody>
+      </p:sp>
+      <p:sp>
+        <p:nvSpPr>
+          <p:cNvPr id="26" name="Arrow"/>
+          <p:cNvSpPr/>
+          <p:nvPr/>
+        </p:nvSpPr>
+        <p:spPr>
+          <a:xfrm>
+            <a:off x="3650284" y="3650000"/>
+            <a:ext cx="164592" cy="560000"/>
+          </a:xfrm>
+          <a:prstGeom prst="rect">
+            <a:avLst/>
+          </a:prstGeom>
+          <a:noFill/>
+          <a:ln/>
+        </p:spPr>
+        <p:txBody>
+          <a:bodyPr wrap="square" lIns="0" tIns="0" rIns="0" bIns="0" rtlCol="0" anchor="ctr"/>
+          <a:lstStyle/>
+          <a:p>
+            <a:pPr marL="0" indent="0" algn="ctr">
+              <a:buNone/>
+            </a:pPr>
+            <a:r>
+              <a:rPr lang="en-US" sz="1000" kern="0" dirty="0">
+                <a:solidFill>
+                  <a:srgbClr val="3B82F6"/>
+                </a:solidFill>
+                <a:latin typeface="Inter" pitchFamily="34" charset="0"/>
+                <a:ea typeface="Inter" pitchFamily="34" charset="-122"/>
+                <a:cs typeface="Inter" pitchFamily="34" charset="-120"/>
+              </a:rPr>
+              <a:t>→</a:t>
+            </a:r>
+          </a:p>
+        </p:txBody>
+      </p:sp>
+      <p:sp>
+        <p:nvSpPr>
+          <p:cNvPr id="27" name="Pill"/>
+          <p:cNvSpPr/>
+          <p:nvPr/>
+        </p:nvSpPr>
+        <p:spPr>
+          <a:xfrm>
+            <a:off x="3814876" y="3650000"/>
+            <a:ext cx="1514246" cy="560000"/>
+          </a:xfrm>
+          <a:prstGeom prst="roundRect">
+            <a:avLst>
+              <a:gd name="adj" fmla="val 9091"/>
+            </a:avLst>
+          </a:prstGeom>
+          <a:solidFill>
+            <a:srgbClr val="1B2640"/>
+          </a:solidFill>
+          <a:ln w="9525">
+            <a:solidFill>
+              <a:srgbClr val="64748B"/>
+            </a:solidFill>
+            <a:prstDash val="solid"/>
+          </a:ln>
+        </p:spPr>
+        <p:txBody>
+          <a:bodyPr wrap="square" lIns="36000" tIns="0" rIns="36000" bIns="0" rtlCol="0" anchor="ctr"/>
+          <a:lstStyle/>
+          <a:p>
+            <a:pPr marL="0" indent="0" algn="ctr">
+              <a:buNone/>
+            </a:pPr>
+            <a:r>
+              <a:rPr lang="en-US" sz="1050" b="1" kern="0" dirty="0">
+                <a:solidFill>
+                  <a:srgbClr val="F8FAFC"/>
+                </a:solidFill>
+                <a:latin typeface="Inter" pitchFamily="34" charset="0"/>
+                <a:ea typeface="Inter" pitchFamily="34" charset="-122"/>
+                <a:cs typeface="Inter" pitchFamily="34" charset="-120"/>
+              </a:rPr>
+              <a:t>create PR</a:t>
+            </a:r>
+          </a:p>
+          <a:p>
+            <a:pPr marL="0" indent="0" algn="ctr">
+              <a:buNone/>
+            </a:pPr>
+            <a:r>
+              <a:rPr lang="en-US" sz="750" kern="0" dirty="0">
+                <a:solidFill>
+                  <a:srgbClr val="3B82F6"/>
+                </a:solidFill>
+                <a:latin typeface="Inter" pitchFamily="34" charset="0"/>
+                <a:ea typeface="Inter" pitchFamily="34" charset="-122"/>
+                <a:cs typeface="Inter" pitchFamily="34" charset="-120"/>
+              </a:rPr>
+              <a:t>/create-pr</a:t>
+            </a:r>
+          </a:p>
+        </p:txBody>
+      </p:sp>
+      <p:sp>
+        <p:nvSpPr>
+          <p:cNvPr id="28" name="Arrow"/>
+          <p:cNvSpPr/>
+          <p:nvPr/>
+        </p:nvSpPr>
+        <p:spPr>
+          <a:xfrm>
+            <a:off x="5329122" y="3650000"/>
+            <a:ext cx="164592" cy="560000"/>
+          </a:xfrm>
+          <a:prstGeom prst="rect">
+            <a:avLst/>
+          </a:prstGeom>
+          <a:noFill/>
+          <a:ln/>
+        </p:spPr>
+        <p:txBody>
+          <a:bodyPr wrap="square" lIns="0" tIns="0" rIns="0" bIns="0" rtlCol="0" anchor="ctr"/>
+          <a:lstStyle/>
+          <a:p>
+            <a:pPr marL="0" indent="0" algn="ctr">
+              <a:buNone/>
+            </a:pPr>
+            <a:r>
+              <a:rPr lang="en-US" sz="1000" kern="0" dirty="0">
+                <a:solidFill>
+                  <a:srgbClr val="3B82F6"/>
+                </a:solidFill>
+                <a:latin typeface="Inter" pitchFamily="34" charset="0"/>
+                <a:ea typeface="Inter" pitchFamily="34" charset="-122"/>
+                <a:cs typeface="Inter" pitchFamily="34" charset="-120"/>
+              </a:rPr>
+              <a:t>→</a:t>
+            </a:r>
+          </a:p>
+        </p:txBody>
+      </p:sp>
+      <p:sp>
+        <p:nvSpPr>
+          <p:cNvPr id="29" name="Pill"/>
+          <p:cNvSpPr/>
+          <p:nvPr/>
+        </p:nvSpPr>
+        <p:spPr>
+          <a:xfrm>
+            <a:off x="5493714" y="3650000"/>
+            <a:ext cx="1514246" cy="560000"/>
+          </a:xfrm>
+          <a:prstGeom prst="roundRect">
+            <a:avLst>
+              <a:gd name="adj" fmla="val 9091"/>
+            </a:avLst>
+          </a:prstGeom>
+          <a:solidFill>
+            <a:srgbClr val="1B2640"/>
+          </a:solidFill>
+          <a:ln w="9525">
+            <a:solidFill>
+              <a:srgbClr val="64748B"/>
+            </a:solidFill>
+            <a:prstDash val="solid"/>
+          </a:ln>
+        </p:spPr>
+        <p:txBody>
+          <a:bodyPr wrap="square" lIns="36000" tIns="0" rIns="36000" bIns="0" rtlCol="0" anchor="ctr"/>
+          <a:lstStyle/>
+          <a:p>
+            <a:pPr marL="0" indent="0" algn="ctr">
+              <a:buNone/>
+            </a:pPr>
+            <a:r>
+              <a:rPr lang="en-US" sz="1050" b="1" kern="0" dirty="0">
+                <a:solidFill>
+                  <a:srgbClr val="F8FAFC"/>
+                </a:solidFill>
+                <a:latin typeface="Inter" pitchFamily="34" charset="0"/>
+                <a:ea typeface="Inter" pitchFamily="34" charset="-122"/>
+                <a:cs typeface="Inter" pitchFamily="34" charset="-120"/>
+              </a:rPr>
+              <a:t>pipeline</a:t>
+            </a:r>
+          </a:p>
+          <a:p>
+            <a:pPr marL="0" indent="0" algn="ctr">
+              <a:buNone/>
+            </a:pPr>
+            <a:r>
+              <a:rPr lang="en-US" sz="750" kern="0" dirty="0">
+                <a:solidFill>
+                  <a:srgbClr val="3B82F6"/>
+                </a:solidFill>
+                <a:latin typeface="Inter" pitchFamily="34" charset="0"/>
+                <a:ea typeface="Inter" pitchFamily="34" charset="-122"/>
+                <a:cs typeface="Inter" pitchFamily="34" charset="-120"/>
+              </a:rPr>
+              <a:t>/devops watch</a:t>
+            </a:r>
+          </a:p>
+        </p:txBody>
+      </p:sp>
+      <p:sp>
+        <p:nvSpPr>
+          <p:cNvPr id="30" name="Arrow"/>
+          <p:cNvSpPr/>
+          <p:nvPr/>
+        </p:nvSpPr>
+        <p:spPr>
+          <a:xfrm>
+            <a:off x="7007960" y="3650000"/>
+            <a:ext cx="164592" cy="560000"/>
+          </a:xfrm>
+          <a:prstGeom prst="rect">
+            <a:avLst/>
+          </a:prstGeom>
+          <a:noFill/>
+          <a:ln/>
+        </p:spPr>
+        <p:txBody>
+          <a:bodyPr wrap="square" lIns="0" tIns="0" rIns="0" bIns="0" rtlCol="0" anchor="ctr"/>
+          <a:lstStyle/>
+          <a:p>
+            <a:pPr marL="0" indent="0" algn="ctr">
+              <a:buNone/>
+            </a:pPr>
+            <a:r>
+              <a:rPr lang="en-US" sz="1000" kern="0" dirty="0">
+                <a:solidFill>
+                  <a:srgbClr val="3B82F6"/>
+                </a:solidFill>
+                <a:latin typeface="Inter" pitchFamily="34" charset="0"/>
+                <a:ea typeface="Inter" pitchFamily="34" charset="-122"/>
+                <a:cs typeface="Inter" pitchFamily="34" charset="-120"/>
+              </a:rPr>
+              <a:t>→</a:t>
+            </a:r>
+          </a:p>
+        </p:txBody>
+      </p:sp>
+      <p:sp>
+        <p:nvSpPr>
+          <p:cNvPr id="31" name="Pill"/>
+          <p:cNvSpPr/>
+          <p:nvPr/>
+        </p:nvSpPr>
+        <p:spPr>
+          <a:xfrm>
+            <a:off x="7172552" y="3650000"/>
+            <a:ext cx="1514246" cy="560000"/>
+          </a:xfrm>
+          <a:prstGeom prst="roundRect">
+            <a:avLst>
+              <a:gd name="adj" fmla="val 9091"/>
+            </a:avLst>
+          </a:prstGeom>
+          <a:solidFill>
+            <a:srgbClr val="1B2640"/>
+          </a:solidFill>
+          <a:ln w="19050">
+            <a:solidFill>
+              <a:srgbClr val="3B82F6"/>
+            </a:solidFill>
+            <a:prstDash val="solid"/>
+          </a:ln>
+        </p:spPr>
+        <p:txBody>
+          <a:bodyPr wrap="square" lIns="36000" tIns="0" rIns="36000" bIns="0" rtlCol="0" anchor="ctr"/>
+          <a:lstStyle/>
+          <a:p>
+            <a:pPr marL="0" indent="0" algn="ctr">
+              <a:buNone/>
+            </a:pPr>
+            <a:r>
+              <a:rPr lang="en-US" sz="1050" b="1" kern="0" dirty="0">
+                <a:solidFill>
+                  <a:srgbClr val="F8FAFC"/>
+                </a:solidFill>
+                <a:latin typeface="Inter" pitchFamily="34" charset="0"/>
+                <a:ea typeface="Inter" pitchFamily="34" charset="-122"/>
+                <a:cs typeface="Inter" pitchFamily="34" charset="-120"/>
+              </a:rPr>
+              <a:t>human review</a:t>
+            </a:r>
+          </a:p>
+          <a:p>
+            <a:pPr marL="0" indent="0" algn="ctr">
+              <a:buNone/>
+            </a:pPr>
+            <a:r>
+              <a:rPr lang="en-US" sz="750" kern="0" dirty="0">
+                <a:solidFill>
+                  <a:srgbClr val="3B82F6"/>
+                </a:solidFill>
+                <a:latin typeface="Inter" pitchFamily="34" charset="0"/>
+                <a:ea typeface="Inter" pitchFamily="34" charset="-122"/>
+                <a:cs typeface="Inter" pitchFamily="34" charset="-120"/>
+              </a:rPr>
+              <a:t>mandatory</a:t>
+            </a:r>
+          </a:p>
+        </p:txBody>
+      </p:sp>
+      <p:sp>
+        <p:nvSpPr>
+          <p:cNvPr id="32" name="Text"/>
+          <p:cNvSpPr/>
+          <p:nvPr/>
+        </p:nvSpPr>
+        <p:spPr>
+          <a:xfrm>
+            <a:off x="457200" y="4300000"/>
+            <a:ext cx="8229600" cy="420000"/>
+          </a:xfrm>
+          <a:prstGeom prst="rect">
+            <a:avLst/>
+          </a:prstGeom>
+          <a:noFill/>
+          <a:ln/>
+        </p:spPr>
+        <p:txBody>
+          <a:bodyPr wrap="square" lIns="0" tIns="0" rIns="0" bIns="0" rtlCol="0" anchor="ctr"/>
+          <a:lstStyle/>
+          <a:p>
+            <a:pPr marL="0" indent="0" algn="ctr">
+              <a:buNone/>
+            </a:pPr>
+            <a:r>
+              <a:rPr lang="en-US" sz="1100" kern="0" dirty="0">
                 <a:solidFill>
                   <a:srgbClr val="94A3B8"/>
                 </a:solidFill>
@@ -4628,16 +5055,15 @@
                 <a:ea typeface="Inter" pitchFamily="34" charset="-122"/>
                 <a:cs typeface="Inter" pitchFamily="34" charset="-120"/>
               </a:rPr>
-              <a:t>each box is a specialist — the orchestrator picks which one, when,</a:t>
-            </a:r>
-            <a:endParaRPr lang="en-US" sz="1400" dirty="0"/>
+              <a:t>each box is a skill the orchestrator invokes — it decides which, when, and how to recover.</a:t>
+            </a:r>
           </a:p>
           <a:p>
             <a:pPr marL="0" indent="0" algn="ctr">
               <a:buNone/>
             </a:pPr>
             <a:r>
-              <a:rPr lang="en-US" sz="1400" dirty="0">
+              <a:rPr lang="en-US" sz="1100" kern="0" dirty="0">
                 <a:solidFill>
                   <a:srgbClr val="94A3B8"/>
                 </a:solidFill>
@@ -4645,9 +5071,84 @@
                 <a:ea typeface="Inter" pitchFamily="34" charset="-122"/>
                 <a:cs typeface="Inter" pitchFamily="34" charset="-120"/>
               </a:rPr>
-              <a:t>and what to do when one fails</a:t>
-            </a:r>
-            <a:endParaRPr lang="en-US" sz="1400" dirty="0"/>
+              <a:t>the inner loop retries on failure; a human must approve before merge.</a:t>
+            </a:r>
+          </a:p>
+        </p:txBody>
+      </p:sp>
+      <p:sp>
+        <p:nvSpPr>
+          <p:cNvPr id="33" name="Text"/>
+          <p:cNvSpPr/>
+          <p:nvPr/>
+        </p:nvSpPr>
+        <p:spPr>
+          <a:xfrm>
+            <a:off x="457200" y="4796028"/>
+            <a:ext cx="4572000" cy="274320"/>
+          </a:xfrm>
+          <a:prstGeom prst="rect">
+            <a:avLst/>
+          </a:prstGeom>
+          <a:noFill/>
+          <a:ln/>
+        </p:spPr>
+        <p:txBody>
+          <a:bodyPr wrap="square" lIns="0" tIns="0" rIns="0" bIns="0" rtlCol="0" anchor="ctr"/>
+          <a:lstStyle/>
+          <a:p>
+            <a:pPr marL="0" indent="0" algn="l">
+              <a:buNone/>
+            </a:pPr>
+            <a:r>
+              <a:rPr lang="en-US" sz="800" kern="0" spc="200" dirty="0">
+                <a:solidFill>
+                  <a:srgbClr val="64748B"/>
+                </a:solidFill>
+                <a:latin typeface="Inter" pitchFamily="34" charset="0"/>
+                <a:ea typeface="Inter" pitchFamily="34" charset="-122"/>
+                <a:cs typeface="Inter" pitchFamily="34" charset="-120"/>
+              </a:rPr>
+              <a:t>02 · how it works</a:t>
+            </a:r>
+          </a:p>
+        </p:txBody>
+      </p:sp>
+      <p:sp>
+        <p:nvSpPr>
+          <p:cNvPr id="34" name="Text"/>
+          <p:cNvSpPr/>
+          <p:nvPr/>
+        </p:nvSpPr>
+        <p:spPr>
+          <a:xfrm>
+            <a:off x="8229600" y="4796028"/>
+            <a:ext cx="457200" cy="274320"/>
+          </a:xfrm>
+          <a:prstGeom prst="rect">
+            <a:avLst/>
+          </a:prstGeom>
+          <a:noFill/>
+          <a:ln/>
+        </p:spPr>
+        <p:txBody>
+          <a:bodyPr wrap="square" lIns="0" tIns="0" rIns="0" bIns="0" rtlCol="0" anchor="ctr"/>
+          <a:lstStyle/>
+          <a:p>
+            <a:pPr marL="0" indent="0" algn="r">
+              <a:buNone/>
+            </a:pPr>
+            <a:r>
+              <a:rPr lang="en-US" sz="800" kern="0" dirty="0">
+                <a:solidFill>
+                  <a:srgbClr val="64748B"/>
+                </a:solidFill>
+                <a:latin typeface="Inter" pitchFamily="34" charset="0"/>
+                <a:ea typeface="Inter" pitchFamily="34" charset="-122"/>
+                <a:cs typeface="Inter" pitchFamily="34" charset="-120"/>
+              </a:rPr>
+              <a:t>11</a:t>
+            </a:r>
           </a:p>
         </p:txBody>
       </p:sp>

</xml_diff>

<commit_message>
chore(deck): rebuild gatherly slide 11 as the full REPL loop (#42)
Replace the single-row "the loop" flow on page 11 with the full
WORKFLOW.md REPL loop: Phase 0 plan, the per-step inner loop (with the
test-retry note), the acceptance gate, and the ship sequence ending in
mandatory human review. Keeps the deck's theme, fonts, header, footer.

Co-authored-by: dev-servicecat <dev@servicecat.local>
Co-authored-by: Claude Opus 4.8 (1M context) <noreply@anthropic.com>
</commit_message>
<xml_diff>
--- a/orchestrer-intelligence-gatherly.pptx
+++ b/orchestrer-intelligence-gatherly.pptx
@@ -3584,85 +3584,7 @@
       </p:grpSpPr>
       <p:sp>
         <p:nvSpPr>
-          <p:cNvPr id="2" name="Text 0"/>
-          <p:cNvSpPr/>
-          <p:nvPr/>
-        </p:nvSpPr>
-        <p:spPr>
-          <a:xfrm>
-            <a:off x="457200" y="4796028"/>
-            <a:ext cx="4572000" cy="274320"/>
-          </a:xfrm>
-          <a:prstGeom prst="rect">
-            <a:avLst/>
-          </a:prstGeom>
-          <a:noFill/>
-          <a:ln/>
-        </p:spPr>
-        <p:txBody>
-          <a:bodyPr wrap="square" lIns="0" tIns="0" rIns="0" bIns="0" rtlCol="0" anchor="ctr"/>
-          <a:lstStyle/>
-          <a:p>
-            <a:pPr marL="0" indent="0">
-              <a:buNone/>
-            </a:pPr>
-            <a:r>
-              <a:rPr lang="en-US" sz="800" kern="0" spc="200" dirty="0">
-                <a:solidFill>
-                  <a:srgbClr val="64748B"/>
-                </a:solidFill>
-                <a:latin typeface="Inter" pitchFamily="34" charset="0"/>
-                <a:ea typeface="Inter" pitchFamily="34" charset="-122"/>
-                <a:cs typeface="Inter" pitchFamily="34" charset="-120"/>
-              </a:rPr>
-              <a:t>02 · how it works</a:t>
-            </a:r>
-            <a:endParaRPr lang="en-US" sz="800" dirty="0"/>
-          </a:p>
-        </p:txBody>
-      </p:sp>
-      <p:sp>
-        <p:nvSpPr>
-          <p:cNvPr id="3" name="Text 1"/>
-          <p:cNvSpPr/>
-          <p:nvPr/>
-        </p:nvSpPr>
-        <p:spPr>
-          <a:xfrm>
-            <a:off x="8229600" y="4796028"/>
-            <a:ext cx="457200" cy="274320"/>
-          </a:xfrm>
-          <a:prstGeom prst="rect">
-            <a:avLst/>
-          </a:prstGeom>
-          <a:noFill/>
-          <a:ln/>
-        </p:spPr>
-        <p:txBody>
-          <a:bodyPr wrap="square" lIns="0" tIns="0" rIns="0" bIns="0" rtlCol="0" anchor="ctr"/>
-          <a:lstStyle/>
-          <a:p>
-            <a:pPr marL="0" indent="0" algn="r">
-              <a:buNone/>
-            </a:pPr>
-            <a:r>
-              <a:rPr lang="en-US" sz="800" dirty="0">
-                <a:solidFill>
-                  <a:srgbClr val="64748B"/>
-                </a:solidFill>
-                <a:latin typeface="Inter" pitchFamily="34" charset="0"/>
-                <a:ea typeface="Inter" pitchFamily="34" charset="-122"/>
-                <a:cs typeface="Inter" pitchFamily="34" charset="-120"/>
-              </a:rPr>
-              <a:t>11</a:t>
-            </a:r>
-            <a:endParaRPr lang="en-US" sz="800" dirty="0"/>
-          </a:p>
-        </p:txBody>
-      </p:sp>
-      <p:sp>
-        <p:nvSpPr>
-          <p:cNvPr id="4" name="Text 2"/>
+          <p:cNvPr id="2" name="Text"/>
           <p:cNvSpPr/>
           <p:nvPr/>
         </p:nvSpPr>
@@ -3681,11 +3603,11 @@
           <a:bodyPr wrap="square" lIns="0" tIns="0" rIns="0" bIns="0" rtlCol="0" anchor="ctr"/>
           <a:lstStyle/>
           <a:p>
-            <a:pPr marL="0" indent="0">
-              <a:buNone/>
-            </a:pPr>
-            <a:r>
-              <a:rPr lang="en-US" sz="1000" b="1" kern="0" spc="300" dirty="0">
+            <a:pPr marL="0" indent="0" algn="l">
+              <a:buNone/>
+            </a:pPr>
+            <a:r>
+              <a:rPr lang="en-US" sz="1000" b="1" spc="300" kern="0" dirty="0">
                 <a:solidFill>
                   <a:srgbClr val="3B82F6"/>
                 </a:solidFill>
@@ -3695,13 +3617,12 @@
               </a:rPr>
               <a:t>02 · HOW IT WORKS</a:t>
             </a:r>
-            <a:endParaRPr lang="en-US" sz="1000" dirty="0"/>
-          </a:p>
-        </p:txBody>
-      </p:sp>
-      <p:sp>
-        <p:nvSpPr>
-          <p:cNvPr id="5" name="Text 3"/>
+          </a:p>
+        </p:txBody>
+      </p:sp>
+      <p:sp>
+        <p:nvSpPr>
+          <p:cNvPr id="3" name="Text"/>
           <p:cNvSpPr/>
           <p:nvPr/>
         </p:nvSpPr>
@@ -3720,34 +3641,71 @@
           <a:bodyPr wrap="square" lIns="0" tIns="0" rIns="0" bIns="0" rtlCol="0" anchor="ctr"/>
           <a:lstStyle/>
           <a:p>
-            <a:pPr marL="0" indent="0">
-              <a:buNone/>
-            </a:pPr>
-            <a:r>
-              <a:rPr lang="en-US" sz="2800" b="1" dirty="0">
+            <a:pPr marL="0" indent="0" algn="l">
+              <a:buNone/>
+            </a:pPr>
+            <a:r>
+              <a:rPr lang="en-US" sz="2800" b="1" kern="0" dirty="0">
                 <a:solidFill>
                   <a:srgbClr val="F8FAFC"/>
                 </a:solidFill>
                 <a:latin typeface="Montserrat" pitchFamily="34" charset="0"/>
-                <a:ea typeface="Inter" pitchFamily="34" charset="-122"/>
-                <a:cs typeface="Inter" pitchFamily="34" charset="-120"/>
+                <a:ea typeface="Montserrat" pitchFamily="34" charset="-122"/>
+                <a:cs typeface="Montserrat" pitchFamily="34" charset="-120"/>
               </a:rPr>
               <a:t>the loop</a:t>
             </a:r>
-            <a:endParaRPr lang="en-US" sz="2800" dirty="0"/>
-          </a:p>
-        </p:txBody>
-      </p:sp>
-      <p:sp>
-        <p:nvSpPr>
-          <p:cNvPr id="6" name="Shape 4"/>
-          <p:cNvSpPr/>
-          <p:nvPr/>
-        </p:nvSpPr>
-        <p:spPr>
-          <a:xfrm>
-            <a:off x="457200" y="2103120"/>
-            <a:ext cx="932688" cy="502920"/>
+          </a:p>
+        </p:txBody>
+      </p:sp>
+      <p:sp>
+        <p:nvSpPr>
+          <p:cNvPr id="4" name="Text"/>
+          <p:cNvSpPr/>
+          <p:nvPr/>
+        </p:nvSpPr>
+        <p:spPr>
+          <a:xfrm>
+            <a:off x="457200" y="1420000"/>
+            <a:ext cx="8229600" cy="180000"/>
+          </a:xfrm>
+          <a:prstGeom prst="rect">
+            <a:avLst/>
+          </a:prstGeom>
+          <a:noFill/>
+          <a:ln/>
+        </p:spPr>
+        <p:txBody>
+          <a:bodyPr wrap="square" lIns="0" tIns="0" rIns="0" bIns="0" rtlCol="0" anchor="ctr"/>
+          <a:lstStyle/>
+          <a:p>
+            <a:pPr marL="0" indent="0" algn="l">
+              <a:buNone/>
+            </a:pPr>
+            <a:r>
+              <a:rPr lang="en-US" sz="900" b="1" spc="200" kern="0" dirty="0">
+                <a:solidFill>
+                  <a:srgbClr val="3B82F6"/>
+                </a:solidFill>
+                <a:latin typeface="Inter" pitchFamily="34" charset="0"/>
+                <a:ea typeface="Inter" pitchFamily="34" charset="-122"/>
+                <a:cs typeface="Inter" pitchFamily="34" charset="-120"/>
+              </a:rPr>
+              <a:t>PHASE 0 · BEFORE ANY CODE</a:t>
+            </a:r>
+          </a:p>
+        </p:txBody>
+      </p:sp>
+      <p:sp>
+        <p:nvSpPr>
+          <p:cNvPr id="5" name="Pill"/>
+          <p:cNvSpPr/>
+          <p:nvPr/>
+        </p:nvSpPr>
+        <p:spPr>
+          <a:xfrm>
+            <a:off x="457200" y="1620000"/>
+            <a:ext cx="1234440" cy="560000"/>
           </a:xfrm>
           <a:prstGeom prst="roundRect">
             <a:avLst>
@@ -3765,39 +3723,14 @@
           </a:ln>
         </p:spPr>
         <p:txBody>
-          <a:bodyPr/>
-          <a:lstStyle/>
-          <a:p>
-            <a:endParaRPr/>
-          </a:p>
-        </p:txBody>
-      </p:sp>
-      <p:sp>
-        <p:nvSpPr>
-          <p:cNvPr id="7" name="Text 5"/>
-          <p:cNvSpPr/>
-          <p:nvPr/>
-        </p:nvSpPr>
-        <p:spPr>
-          <a:xfrm>
-            <a:off x="457200" y="2103120"/>
-            <a:ext cx="932688" cy="502920"/>
-          </a:xfrm>
-          <a:prstGeom prst="rect">
-            <a:avLst/>
-          </a:prstGeom>
-          <a:noFill/>
-          <a:ln/>
-        </p:spPr>
-        <p:txBody>
-          <a:bodyPr wrap="square" lIns="0" tIns="0" rIns="0" bIns="0" rtlCol="0" anchor="ctr"/>
+          <a:bodyPr wrap="square" lIns="36000" tIns="0" rIns="36000" bIns="0" rtlCol="0" anchor="ctr"/>
           <a:lstStyle/>
           <a:p>
             <a:pPr marL="0" indent="0" algn="ctr">
               <a:buNone/>
             </a:pPr>
             <a:r>
-              <a:rPr lang="en-US" sz="1100" b="1" dirty="0">
+              <a:rPr lang="en-US" sz="1050" b="1" kern="0" dirty="0">
                 <a:solidFill>
                   <a:srgbClr val="F8FAFC"/>
                 </a:solidFill>
@@ -3807,36 +3740,13 @@
               </a:rPr>
               <a:t>plan</a:t>
             </a:r>
-            <a:endParaRPr lang="en-US" sz="1100" dirty="0"/>
-          </a:p>
-        </p:txBody>
-      </p:sp>
-      <p:sp>
-        <p:nvSpPr>
-          <p:cNvPr id="8" name="Text 6"/>
-          <p:cNvSpPr/>
-          <p:nvPr/>
-        </p:nvSpPr>
-        <p:spPr>
-          <a:xfrm>
-            <a:off x="1371600" y="2103120"/>
-            <a:ext cx="164592" cy="502920"/>
-          </a:xfrm>
-          <a:prstGeom prst="rect">
-            <a:avLst/>
-          </a:prstGeom>
-          <a:noFill/>
-          <a:ln/>
-        </p:spPr>
-        <p:txBody>
-          <a:bodyPr wrap="square" lIns="0" tIns="0" rIns="0" bIns="0" rtlCol="0" anchor="ctr"/>
-          <a:lstStyle/>
+          </a:p>
           <a:p>
             <a:pPr marL="0" indent="0" algn="ctr">
               <a:buNone/>
             </a:pPr>
             <a:r>
-              <a:rPr lang="en-US" sz="1000" dirty="0">
+              <a:rPr lang="en-US" sz="750" kern="0" dirty="0">
                 <a:solidFill>
                   <a:srgbClr val="3B82F6"/>
                 </a:solidFill>
@@ -3844,22 +3754,135 @@
                 <a:ea typeface="Inter" pitchFamily="34" charset="-122"/>
                 <a:cs typeface="Inter" pitchFamily="34" charset="-120"/>
               </a:rPr>
-              <a:t>→</a:t>
-            </a:r>
-            <a:endParaRPr lang="en-US" sz="1000" dirty="0"/>
-          </a:p>
-        </p:txBody>
-      </p:sp>
-      <p:sp>
-        <p:nvSpPr>
-          <p:cNvPr id="9" name="Shape 7"/>
-          <p:cNvSpPr/>
-          <p:nvPr/>
-        </p:nvSpPr>
-        <p:spPr>
-          <a:xfrm>
-            <a:off x="1499616" y="2103120"/>
-            <a:ext cx="932688" cy="502920"/>
+              <a:t>/plan-feature</a:t>
+            </a:r>
+          </a:p>
+        </p:txBody>
+      </p:sp>
+      <p:sp>
+        <p:nvSpPr>
+          <p:cNvPr id="6" name="Text"/>
+          <p:cNvSpPr/>
+          <p:nvPr/>
+        </p:nvSpPr>
+        <p:spPr>
+          <a:xfrm>
+            <a:off x="1911640" y="1620000"/>
+            <a:ext cx="6775160" cy="560000"/>
+          </a:xfrm>
+          <a:prstGeom prst="rect">
+            <a:avLst/>
+          </a:prstGeom>
+          <a:noFill/>
+          <a:ln/>
+        </p:spPr>
+        <p:txBody>
+          <a:bodyPr wrap="square" lIns="0" tIns="0" rIns="0" bIns="0" rtlCol="0" anchor="ctr"/>
+          <a:lstStyle/>
+          <a:p>
+            <a:pPr marL="0" indent="0" algn="l">
+              <a:buNone/>
+            </a:pPr>
+            <a:r>
+              <a:rPr lang="en-US" sz="1200" kern="0" dirty="0">
+                <a:solidFill>
+                  <a:srgbClr val="94A3B8"/>
+                </a:solidFill>
+                <a:latin typeface="Inter" pitchFamily="34" charset="0"/>
+                <a:ea typeface="Inter" pitchFamily="34" charset="-122"/>
+                <a:cs typeface="Inter" pitchFamily="34" charset="-120"/>
+              </a:rPr>
+              <a:t>define AC-1 … AC-6 before writing any code</a:t>
+            </a:r>
+          </a:p>
+        </p:txBody>
+      </p:sp>
+      <p:sp>
+        <p:nvSpPr>
+          <p:cNvPr id="7" name="Text"/>
+          <p:cNvSpPr/>
+          <p:nvPr/>
+        </p:nvSpPr>
+        <p:spPr>
+          <a:xfrm>
+            <a:off x="4472000" y="2200000"/>
+            <a:ext cx="200000" cy="170000"/>
+          </a:xfrm>
+          <a:prstGeom prst="rect">
+            <a:avLst/>
+          </a:prstGeom>
+          <a:noFill/>
+          <a:ln/>
+        </p:spPr>
+        <p:txBody>
+          <a:bodyPr wrap="square" lIns="0" tIns="0" rIns="0" bIns="0" rtlCol="0" anchor="ctr"/>
+          <a:lstStyle/>
+          <a:p>
+            <a:pPr marL="0" indent="0" algn="ctr">
+              <a:buNone/>
+            </a:pPr>
+            <a:r>
+              <a:rPr lang="en-US" sz="1400" kern="0" dirty="0">
+                <a:solidFill>
+                  <a:srgbClr val="3B82F6"/>
+                </a:solidFill>
+                <a:latin typeface="Inter" pitchFamily="34" charset="0"/>
+                <a:ea typeface="Inter" pitchFamily="34" charset="-122"/>
+                <a:cs typeface="Inter" pitchFamily="34" charset="-120"/>
+              </a:rPr>
+              <a:t>↓</a:t>
+            </a:r>
+          </a:p>
+        </p:txBody>
+      </p:sp>
+      <p:sp>
+        <p:nvSpPr>
+          <p:cNvPr id="8" name="Text"/>
+          <p:cNvSpPr/>
+          <p:nvPr/>
+        </p:nvSpPr>
+        <p:spPr>
+          <a:xfrm>
+            <a:off x="457200" y="2370000"/>
+            <a:ext cx="8229600" cy="180000"/>
+          </a:xfrm>
+          <a:prstGeom prst="rect">
+            <a:avLst/>
+          </a:prstGeom>
+          <a:noFill/>
+          <a:ln/>
+        </p:spPr>
+        <p:txBody>
+          <a:bodyPr wrap="square" lIns="0" tIns="0" rIns="0" bIns="0" rtlCol="0" anchor="ctr"/>
+          <a:lstStyle/>
+          <a:p>
+            <a:pPr marL="0" indent="0" algn="l">
+              <a:buNone/>
+            </a:pPr>
+            <a:r>
+              <a:rPr lang="en-US" sz="900" b="1" spc="200" kern="0" dirty="0">
+                <a:solidFill>
+                  <a:srgbClr val="3B82F6"/>
+                </a:solidFill>
+                <a:latin typeface="Inter" pitchFamily="34" charset="0"/>
+                <a:ea typeface="Inter" pitchFamily="34" charset="-122"/>
+                <a:cs typeface="Inter" pitchFamily="34" charset="-120"/>
+              </a:rPr>
+              <a:t>FOR EACH STEP IN THE PLAN</a:t>
+            </a:r>
+          </a:p>
+        </p:txBody>
+      </p:sp>
+      <p:sp>
+        <p:nvSpPr>
+          <p:cNvPr id="9" name="Pill"/>
+          <p:cNvSpPr/>
+          <p:nvPr/>
+        </p:nvSpPr>
+        <p:spPr>
+          <a:xfrm>
+            <a:off x="457200" y="2550000"/>
+            <a:ext cx="1234440" cy="560000"/>
           </a:xfrm>
           <a:prstGeom prst="roundRect">
             <a:avLst>
@@ -3877,39 +3900,14 @@
           </a:ln>
         </p:spPr>
         <p:txBody>
-          <a:bodyPr/>
-          <a:lstStyle/>
-          <a:p>
-            <a:endParaRPr/>
-          </a:p>
-        </p:txBody>
-      </p:sp>
-      <p:sp>
-        <p:nvSpPr>
-          <p:cNvPr id="10" name="Text 8"/>
-          <p:cNvSpPr/>
-          <p:nvPr/>
-        </p:nvSpPr>
-        <p:spPr>
-          <a:xfrm>
-            <a:off x="1499616" y="2103120"/>
-            <a:ext cx="932688" cy="502920"/>
-          </a:xfrm>
-          <a:prstGeom prst="rect">
-            <a:avLst/>
-          </a:prstGeom>
-          <a:noFill/>
-          <a:ln/>
-        </p:spPr>
-        <p:txBody>
-          <a:bodyPr wrap="square" lIns="0" tIns="0" rIns="0" bIns="0" rtlCol="0" anchor="ctr"/>
+          <a:bodyPr wrap="square" lIns="36000" tIns="0" rIns="36000" bIns="0" rtlCol="0" anchor="ctr"/>
           <a:lstStyle/>
           <a:p>
             <a:pPr marL="0" indent="0" algn="ctr">
               <a:buNone/>
             </a:pPr>
             <a:r>
-              <a:rPr lang="en-US" sz="1100" b="1" dirty="0">
+              <a:rPr lang="en-US" sz="1050" b="1" kern="0" dirty="0">
                 <a:solidFill>
                   <a:srgbClr val="F8FAFC"/>
                 </a:solidFill>
@@ -3919,36 +3917,13 @@
               </a:rPr>
               <a:t>explore</a:t>
             </a:r>
-            <a:endParaRPr lang="en-US" sz="1100" dirty="0"/>
-          </a:p>
-        </p:txBody>
-      </p:sp>
-      <p:sp>
-        <p:nvSpPr>
-          <p:cNvPr id="11" name="Text 9"/>
-          <p:cNvSpPr/>
-          <p:nvPr/>
-        </p:nvSpPr>
-        <p:spPr>
-          <a:xfrm>
-            <a:off x="2414016" y="2103120"/>
-            <a:ext cx="164592" cy="502920"/>
-          </a:xfrm>
-          <a:prstGeom prst="rect">
-            <a:avLst/>
-          </a:prstGeom>
-          <a:noFill/>
-          <a:ln/>
-        </p:spPr>
-        <p:txBody>
-          <a:bodyPr wrap="square" lIns="0" tIns="0" rIns="0" bIns="0" rtlCol="0" anchor="ctr"/>
-          <a:lstStyle/>
+          </a:p>
           <a:p>
             <a:pPr marL="0" indent="0" algn="ctr">
               <a:buNone/>
             </a:pPr>
             <a:r>
-              <a:rPr lang="en-US" sz="1000" dirty="0">
+              <a:rPr lang="en-US" sz="750" kern="0" dirty="0">
                 <a:solidFill>
                   <a:srgbClr val="3B82F6"/>
                 </a:solidFill>
@@ -3956,22 +3931,59 @@
                 <a:ea typeface="Inter" pitchFamily="34" charset="-122"/>
                 <a:cs typeface="Inter" pitchFamily="34" charset="-120"/>
               </a:rPr>
+              <a:t>/explore-codebase</a:t>
+            </a:r>
+          </a:p>
+        </p:txBody>
+      </p:sp>
+      <p:sp>
+        <p:nvSpPr>
+          <p:cNvPr id="10" name="Arrow"/>
+          <p:cNvSpPr/>
+          <p:nvPr/>
+        </p:nvSpPr>
+        <p:spPr>
+          <a:xfrm>
+            <a:off x="1691640" y="2550000"/>
+            <a:ext cx="164592" cy="560000"/>
+          </a:xfrm>
+          <a:prstGeom prst="rect">
+            <a:avLst/>
+          </a:prstGeom>
+          <a:noFill/>
+          <a:ln/>
+        </p:spPr>
+        <p:txBody>
+          <a:bodyPr wrap="square" lIns="0" tIns="0" rIns="0" bIns="0" rtlCol="0" anchor="ctr"/>
+          <a:lstStyle/>
+          <a:p>
+            <a:pPr marL="0" indent="0" algn="ctr">
+              <a:buNone/>
+            </a:pPr>
+            <a:r>
+              <a:rPr lang="en-US" sz="1000" kern="0" dirty="0">
+                <a:solidFill>
+                  <a:srgbClr val="3B82F6"/>
+                </a:solidFill>
+                <a:latin typeface="Inter" pitchFamily="34" charset="0"/>
+                <a:ea typeface="Inter" pitchFamily="34" charset="-122"/>
+                <a:cs typeface="Inter" pitchFamily="34" charset="-120"/>
+              </a:rPr>
               <a:t>→</a:t>
             </a:r>
-            <a:endParaRPr lang="en-US" sz="1000" dirty="0"/>
-          </a:p>
-        </p:txBody>
-      </p:sp>
-      <p:sp>
-        <p:nvSpPr>
-          <p:cNvPr id="12" name="Shape 10"/>
-          <p:cNvSpPr/>
-          <p:nvPr/>
-        </p:nvSpPr>
-        <p:spPr>
-          <a:xfrm>
-            <a:off x="2542032" y="2103120"/>
-            <a:ext cx="932688" cy="502920"/>
+          </a:p>
+        </p:txBody>
+      </p:sp>
+      <p:sp>
+        <p:nvSpPr>
+          <p:cNvPr id="11" name="Pill"/>
+          <p:cNvSpPr/>
+          <p:nvPr/>
+        </p:nvSpPr>
+        <p:spPr>
+          <a:xfrm>
+            <a:off x="1856232" y="2550000"/>
+            <a:ext cx="1234440" cy="560000"/>
           </a:xfrm>
           <a:prstGeom prst="roundRect">
             <a:avLst>
@@ -3989,39 +4001,14 @@
           </a:ln>
         </p:spPr>
         <p:txBody>
-          <a:bodyPr/>
-          <a:lstStyle/>
-          <a:p>
-            <a:endParaRPr/>
-          </a:p>
-        </p:txBody>
-      </p:sp>
-      <p:sp>
-        <p:nvSpPr>
-          <p:cNvPr id="13" name="Text 11"/>
-          <p:cNvSpPr/>
-          <p:nvPr/>
-        </p:nvSpPr>
-        <p:spPr>
-          <a:xfrm>
-            <a:off x="2542032" y="2103120"/>
-            <a:ext cx="932688" cy="502920"/>
-          </a:xfrm>
-          <a:prstGeom prst="rect">
-            <a:avLst/>
-          </a:prstGeom>
-          <a:noFill/>
-          <a:ln/>
-        </p:spPr>
-        <p:txBody>
-          <a:bodyPr wrap="square" lIns="0" tIns="0" rIns="0" bIns="0" rtlCol="0" anchor="ctr"/>
+          <a:bodyPr wrap="square" lIns="36000" tIns="0" rIns="36000" bIns="0" rtlCol="0" anchor="ctr"/>
           <a:lstStyle/>
           <a:p>
             <a:pPr marL="0" indent="0" algn="ctr">
               <a:buNone/>
             </a:pPr>
             <a:r>
-              <a:rPr lang="en-US" sz="1100" b="1" dirty="0">
+              <a:rPr lang="en-US" sz="1050" b="1" kern="0" dirty="0">
                 <a:solidFill>
                   <a:srgbClr val="F8FAFC"/>
                 </a:solidFill>
@@ -4031,36 +4018,13 @@
               </a:rPr>
               <a:t>implement</a:t>
             </a:r>
-            <a:endParaRPr lang="en-US" sz="1100" dirty="0"/>
-          </a:p>
-        </p:txBody>
-      </p:sp>
-      <p:sp>
-        <p:nvSpPr>
-          <p:cNvPr id="14" name="Text 12"/>
-          <p:cNvSpPr/>
-          <p:nvPr/>
-        </p:nvSpPr>
-        <p:spPr>
-          <a:xfrm>
-            <a:off x="3456432" y="2103120"/>
-            <a:ext cx="164592" cy="502920"/>
-          </a:xfrm>
-          <a:prstGeom prst="rect">
-            <a:avLst/>
-          </a:prstGeom>
-          <a:noFill/>
-          <a:ln/>
-        </p:spPr>
-        <p:txBody>
-          <a:bodyPr wrap="square" lIns="0" tIns="0" rIns="0" bIns="0" rtlCol="0" anchor="ctr"/>
-          <a:lstStyle/>
+          </a:p>
           <a:p>
             <a:pPr marL="0" indent="0" algn="ctr">
               <a:buNone/>
             </a:pPr>
             <a:r>
-              <a:rPr lang="en-US" sz="1000" dirty="0">
+              <a:rPr lang="en-US" sz="750" kern="0" dirty="0">
                 <a:solidFill>
                   <a:srgbClr val="3B82F6"/>
                 </a:solidFill>
@@ -4068,22 +4032,59 @@
                 <a:ea typeface="Inter" pitchFamily="34" charset="-122"/>
                 <a:cs typeface="Inter" pitchFamily="34" charset="-120"/>
               </a:rPr>
+              <a:t>/new-endpoint</a:t>
+            </a:r>
+          </a:p>
+        </p:txBody>
+      </p:sp>
+      <p:sp>
+        <p:nvSpPr>
+          <p:cNvPr id="12" name="Arrow"/>
+          <p:cNvSpPr/>
+          <p:nvPr/>
+        </p:nvSpPr>
+        <p:spPr>
+          <a:xfrm>
+            <a:off x="3090672" y="2550000"/>
+            <a:ext cx="164592" cy="560000"/>
+          </a:xfrm>
+          <a:prstGeom prst="rect">
+            <a:avLst/>
+          </a:prstGeom>
+          <a:noFill/>
+          <a:ln/>
+        </p:spPr>
+        <p:txBody>
+          <a:bodyPr wrap="square" lIns="0" tIns="0" rIns="0" bIns="0" rtlCol="0" anchor="ctr"/>
+          <a:lstStyle/>
+          <a:p>
+            <a:pPr marL="0" indent="0" algn="ctr">
+              <a:buNone/>
+            </a:pPr>
+            <a:r>
+              <a:rPr lang="en-US" sz="1000" kern="0" dirty="0">
+                <a:solidFill>
+                  <a:srgbClr val="3B82F6"/>
+                </a:solidFill>
+                <a:latin typeface="Inter" pitchFamily="34" charset="0"/>
+                <a:ea typeface="Inter" pitchFamily="34" charset="-122"/>
+                <a:cs typeface="Inter" pitchFamily="34" charset="-120"/>
+              </a:rPr>
               <a:t>→</a:t>
             </a:r>
-            <a:endParaRPr lang="en-US" sz="1000" dirty="0"/>
-          </a:p>
-        </p:txBody>
-      </p:sp>
-      <p:sp>
-        <p:nvSpPr>
-          <p:cNvPr id="15" name="Shape 13"/>
-          <p:cNvSpPr/>
-          <p:nvPr/>
-        </p:nvSpPr>
-        <p:spPr>
-          <a:xfrm>
-            <a:off x="3584448" y="2103120"/>
-            <a:ext cx="932688" cy="502920"/>
+          </a:p>
+        </p:txBody>
+      </p:sp>
+      <p:sp>
+        <p:nvSpPr>
+          <p:cNvPr id="13" name="Pill"/>
+          <p:cNvSpPr/>
+          <p:nvPr/>
+        </p:nvSpPr>
+        <p:spPr>
+          <a:xfrm>
+            <a:off x="3255264" y="2550000"/>
+            <a:ext cx="1234440" cy="560000"/>
           </a:xfrm>
           <a:prstGeom prst="roundRect">
             <a:avLst>
@@ -4101,39 +4102,14 @@
           </a:ln>
         </p:spPr>
         <p:txBody>
-          <a:bodyPr/>
-          <a:lstStyle/>
-          <a:p>
-            <a:endParaRPr/>
-          </a:p>
-        </p:txBody>
-      </p:sp>
-      <p:sp>
-        <p:nvSpPr>
-          <p:cNvPr id="16" name="Text 14"/>
-          <p:cNvSpPr/>
-          <p:nvPr/>
-        </p:nvSpPr>
-        <p:spPr>
-          <a:xfrm>
-            <a:off x="3584448" y="2103120"/>
-            <a:ext cx="932688" cy="502920"/>
-          </a:xfrm>
-          <a:prstGeom prst="rect">
-            <a:avLst/>
-          </a:prstGeom>
-          <a:noFill/>
-          <a:ln/>
-        </p:spPr>
-        <p:txBody>
-          <a:bodyPr wrap="square" lIns="0" tIns="0" rIns="0" bIns="0" rtlCol="0" anchor="ctr"/>
+          <a:bodyPr wrap="square" lIns="36000" tIns="0" rIns="36000" bIns="0" rtlCol="0" anchor="ctr"/>
           <a:lstStyle/>
           <a:p>
             <a:pPr marL="0" indent="0" algn="ctr">
               <a:buNone/>
             </a:pPr>
             <a:r>
-              <a:rPr lang="en-US" sz="1100" b="1" dirty="0">
+              <a:rPr lang="en-US" sz="1050" b="1" kern="0" dirty="0">
                 <a:solidFill>
                   <a:srgbClr val="F8FAFC"/>
                 </a:solidFill>
@@ -4143,36 +4119,13 @@
               </a:rPr>
               <a:t>test</a:t>
             </a:r>
-            <a:endParaRPr lang="en-US" sz="1100" dirty="0"/>
-          </a:p>
-        </p:txBody>
-      </p:sp>
-      <p:sp>
-        <p:nvSpPr>
-          <p:cNvPr id="17" name="Text 15"/>
-          <p:cNvSpPr/>
-          <p:nvPr/>
-        </p:nvSpPr>
-        <p:spPr>
-          <a:xfrm>
-            <a:off x="4498848" y="2103120"/>
-            <a:ext cx="164592" cy="502920"/>
-          </a:xfrm>
-          <a:prstGeom prst="rect">
-            <a:avLst/>
-          </a:prstGeom>
-          <a:noFill/>
-          <a:ln/>
-        </p:spPr>
-        <p:txBody>
-          <a:bodyPr wrap="square" lIns="0" tIns="0" rIns="0" bIns="0" rtlCol="0" anchor="ctr"/>
-          <a:lstStyle/>
+          </a:p>
           <a:p>
             <a:pPr marL="0" indent="0" algn="ctr">
               <a:buNone/>
             </a:pPr>
             <a:r>
-              <a:rPr lang="en-US" sz="1000" dirty="0">
+              <a:rPr lang="en-US" sz="750" kern="0" dirty="0">
                 <a:solidFill>
                   <a:srgbClr val="3B82F6"/>
                 </a:solidFill>
@@ -4180,22 +4133,59 @@
                 <a:ea typeface="Inter" pitchFamily="34" charset="-122"/>
                 <a:cs typeface="Inter" pitchFamily="34" charset="-120"/>
               </a:rPr>
+              <a:t>make test</a:t>
+            </a:r>
+          </a:p>
+        </p:txBody>
+      </p:sp>
+      <p:sp>
+        <p:nvSpPr>
+          <p:cNvPr id="14" name="Arrow"/>
+          <p:cNvSpPr/>
+          <p:nvPr/>
+        </p:nvSpPr>
+        <p:spPr>
+          <a:xfrm>
+            <a:off x="4489704" y="2550000"/>
+            <a:ext cx="164592" cy="560000"/>
+          </a:xfrm>
+          <a:prstGeom prst="rect">
+            <a:avLst/>
+          </a:prstGeom>
+          <a:noFill/>
+          <a:ln/>
+        </p:spPr>
+        <p:txBody>
+          <a:bodyPr wrap="square" lIns="0" tIns="0" rIns="0" bIns="0" rtlCol="0" anchor="ctr"/>
+          <a:lstStyle/>
+          <a:p>
+            <a:pPr marL="0" indent="0" algn="ctr">
+              <a:buNone/>
+            </a:pPr>
+            <a:r>
+              <a:rPr lang="en-US" sz="1000" kern="0" dirty="0">
+                <a:solidFill>
+                  <a:srgbClr val="3B82F6"/>
+                </a:solidFill>
+                <a:latin typeface="Inter" pitchFamily="34" charset="0"/>
+                <a:ea typeface="Inter" pitchFamily="34" charset="-122"/>
+                <a:cs typeface="Inter" pitchFamily="34" charset="-120"/>
+              </a:rPr>
               <a:t>→</a:t>
             </a:r>
-            <a:endParaRPr lang="en-US" sz="1000" dirty="0"/>
-          </a:p>
-        </p:txBody>
-      </p:sp>
-      <p:sp>
-        <p:nvSpPr>
-          <p:cNvPr id="18" name="Shape 16"/>
-          <p:cNvSpPr/>
-          <p:nvPr/>
-        </p:nvSpPr>
-        <p:spPr>
-          <a:xfrm>
-            <a:off x="4626864" y="2103120"/>
-            <a:ext cx="932688" cy="502920"/>
+          </a:p>
+        </p:txBody>
+      </p:sp>
+      <p:sp>
+        <p:nvSpPr>
+          <p:cNvPr id="15" name="Pill"/>
+          <p:cNvSpPr/>
+          <p:nvPr/>
+        </p:nvSpPr>
+        <p:spPr>
+          <a:xfrm>
+            <a:off x="4654296" y="2550000"/>
+            <a:ext cx="1234440" cy="560000"/>
           </a:xfrm>
           <a:prstGeom prst="roundRect">
             <a:avLst>
@@ -4213,39 +4203,14 @@
           </a:ln>
         </p:spPr>
         <p:txBody>
-          <a:bodyPr/>
-          <a:lstStyle/>
-          <a:p>
-            <a:endParaRPr/>
-          </a:p>
-        </p:txBody>
-      </p:sp>
-      <p:sp>
-        <p:nvSpPr>
-          <p:cNvPr id="19" name="Text 17"/>
-          <p:cNvSpPr/>
-          <p:nvPr/>
-        </p:nvSpPr>
-        <p:spPr>
-          <a:xfrm>
-            <a:off x="4626864" y="2103120"/>
-            <a:ext cx="932688" cy="502920"/>
-          </a:xfrm>
-          <a:prstGeom prst="rect">
-            <a:avLst/>
-          </a:prstGeom>
-          <a:noFill/>
-          <a:ln/>
-        </p:spPr>
-        <p:txBody>
-          <a:bodyPr wrap="square" lIns="0" tIns="0" rIns="0" bIns="0" rtlCol="0" anchor="ctr"/>
+          <a:bodyPr wrap="square" lIns="36000" tIns="0" rIns="36000" bIns="0" rtlCol="0" anchor="ctr"/>
           <a:lstStyle/>
           <a:p>
             <a:pPr marL="0" indent="0" algn="ctr">
               <a:buNone/>
             </a:pPr>
             <a:r>
-              <a:rPr lang="en-US" sz="1100" b="1" dirty="0">
+              <a:rPr lang="en-US" sz="1050" b="1" kern="0" dirty="0">
                 <a:solidFill>
                   <a:srgbClr val="F8FAFC"/>
                 </a:solidFill>
@@ -4255,36 +4220,13 @@
               </a:rPr>
               <a:t>review</a:t>
             </a:r>
-            <a:endParaRPr lang="en-US" sz="1100" dirty="0"/>
-          </a:p>
-        </p:txBody>
-      </p:sp>
-      <p:sp>
-        <p:nvSpPr>
-          <p:cNvPr id="20" name="Text 18"/>
-          <p:cNvSpPr/>
-          <p:nvPr/>
-        </p:nvSpPr>
-        <p:spPr>
-          <a:xfrm>
-            <a:off x="5541264" y="2103120"/>
-            <a:ext cx="164592" cy="502920"/>
-          </a:xfrm>
-          <a:prstGeom prst="rect">
-            <a:avLst/>
-          </a:prstGeom>
-          <a:noFill/>
-          <a:ln/>
-        </p:spPr>
-        <p:txBody>
-          <a:bodyPr wrap="square" lIns="0" tIns="0" rIns="0" bIns="0" rtlCol="0" anchor="ctr"/>
-          <a:lstStyle/>
+          </a:p>
           <a:p>
             <a:pPr marL="0" indent="0" algn="ctr">
               <a:buNone/>
             </a:pPr>
             <a:r>
-              <a:rPr lang="en-US" sz="1000" dirty="0">
+              <a:rPr lang="en-US" sz="750" kern="0" dirty="0">
                 <a:solidFill>
                   <a:srgbClr val="3B82F6"/>
                 </a:solidFill>
@@ -4292,22 +4234,59 @@
                 <a:ea typeface="Inter" pitchFamily="34" charset="-122"/>
                 <a:cs typeface="Inter" pitchFamily="34" charset="-120"/>
               </a:rPr>
+              <a:t>/simplify</a:t>
+            </a:r>
+          </a:p>
+        </p:txBody>
+      </p:sp>
+      <p:sp>
+        <p:nvSpPr>
+          <p:cNvPr id="16" name="Arrow"/>
+          <p:cNvSpPr/>
+          <p:nvPr/>
+        </p:nvSpPr>
+        <p:spPr>
+          <a:xfrm>
+            <a:off x="5888736" y="2550000"/>
+            <a:ext cx="164592" cy="560000"/>
+          </a:xfrm>
+          <a:prstGeom prst="rect">
+            <a:avLst/>
+          </a:prstGeom>
+          <a:noFill/>
+          <a:ln/>
+        </p:spPr>
+        <p:txBody>
+          <a:bodyPr wrap="square" lIns="0" tIns="0" rIns="0" bIns="0" rtlCol="0" anchor="ctr"/>
+          <a:lstStyle/>
+          <a:p>
+            <a:pPr marL="0" indent="0" algn="ctr">
+              <a:buNone/>
+            </a:pPr>
+            <a:r>
+              <a:rPr lang="en-US" sz="1000" kern="0" dirty="0">
+                <a:solidFill>
+                  <a:srgbClr val="3B82F6"/>
+                </a:solidFill>
+                <a:latin typeface="Inter" pitchFamily="34" charset="0"/>
+                <a:ea typeface="Inter" pitchFamily="34" charset="-122"/>
+                <a:cs typeface="Inter" pitchFamily="34" charset="-120"/>
+              </a:rPr>
               <a:t>→</a:t>
             </a:r>
-            <a:endParaRPr lang="en-US" sz="1000" dirty="0"/>
-          </a:p>
-        </p:txBody>
-      </p:sp>
-      <p:sp>
-        <p:nvSpPr>
-          <p:cNvPr id="21" name="Shape 19"/>
-          <p:cNvSpPr/>
-          <p:nvPr/>
-        </p:nvSpPr>
-        <p:spPr>
-          <a:xfrm>
-            <a:off x="5669280" y="2103120"/>
-            <a:ext cx="932688" cy="502920"/>
+          </a:p>
+        </p:txBody>
+      </p:sp>
+      <p:sp>
+        <p:nvSpPr>
+          <p:cNvPr id="17" name="Pill"/>
+          <p:cNvSpPr/>
+          <p:nvPr/>
+        </p:nvSpPr>
+        <p:spPr>
+          <a:xfrm>
+            <a:off x="6053328" y="2550000"/>
+            <a:ext cx="1234440" cy="560000"/>
           </a:xfrm>
           <a:prstGeom prst="roundRect">
             <a:avLst>
@@ -4325,39 +4304,14 @@
           </a:ln>
         </p:spPr>
         <p:txBody>
-          <a:bodyPr/>
-          <a:lstStyle/>
-          <a:p>
-            <a:endParaRPr/>
-          </a:p>
-        </p:txBody>
-      </p:sp>
-      <p:sp>
-        <p:nvSpPr>
-          <p:cNvPr id="22" name="Text 20"/>
-          <p:cNvSpPr/>
-          <p:nvPr/>
-        </p:nvSpPr>
-        <p:spPr>
-          <a:xfrm>
-            <a:off x="5669280" y="2103120"/>
-            <a:ext cx="932688" cy="502920"/>
-          </a:xfrm>
-          <a:prstGeom prst="rect">
-            <a:avLst/>
-          </a:prstGeom>
-          <a:noFill/>
-          <a:ln/>
-        </p:spPr>
-        <p:txBody>
-          <a:bodyPr wrap="square" lIns="0" tIns="0" rIns="0" bIns="0" rtlCol="0" anchor="ctr"/>
+          <a:bodyPr wrap="square" lIns="36000" tIns="0" rIns="36000" bIns="0" rtlCol="0" anchor="ctr"/>
           <a:lstStyle/>
           <a:p>
             <a:pPr marL="0" indent="0" algn="ctr">
               <a:buNone/>
             </a:pPr>
             <a:r>
-              <a:rPr lang="en-US" sz="1100" b="1" dirty="0">
+              <a:rPr lang="en-US" sz="1050" b="1" kern="0" dirty="0">
                 <a:solidFill>
                   <a:srgbClr val="F8FAFC"/>
                 </a:solidFill>
@@ -4367,36 +4321,13 @@
               </a:rPr>
               <a:t>audit</a:t>
             </a:r>
-            <a:endParaRPr lang="en-US" sz="1100" dirty="0"/>
-          </a:p>
-        </p:txBody>
-      </p:sp>
-      <p:sp>
-        <p:nvSpPr>
-          <p:cNvPr id="23" name="Text 21"/>
-          <p:cNvSpPr/>
-          <p:nvPr/>
-        </p:nvSpPr>
-        <p:spPr>
-          <a:xfrm>
-            <a:off x="6583680" y="2103120"/>
-            <a:ext cx="164592" cy="502920"/>
-          </a:xfrm>
-          <a:prstGeom prst="rect">
-            <a:avLst/>
-          </a:prstGeom>
-          <a:noFill/>
-          <a:ln/>
-        </p:spPr>
-        <p:txBody>
-          <a:bodyPr wrap="square" lIns="0" tIns="0" rIns="0" bIns="0" rtlCol="0" anchor="ctr"/>
-          <a:lstStyle/>
+          </a:p>
           <a:p>
             <a:pPr marL="0" indent="0" algn="ctr">
               <a:buNone/>
             </a:pPr>
             <a:r>
-              <a:rPr lang="en-US" sz="1000" dirty="0">
+              <a:rPr lang="en-US" sz="750" kern="0" dirty="0">
                 <a:solidFill>
                   <a:srgbClr val="3B82F6"/>
                 </a:solidFill>
@@ -4404,22 +4335,59 @@
                 <a:ea typeface="Inter" pitchFamily="34" charset="-122"/>
                 <a:cs typeface="Inter" pitchFamily="34" charset="-120"/>
               </a:rPr>
+              <a:t>/audit-security</a:t>
+            </a:r>
+          </a:p>
+        </p:txBody>
+      </p:sp>
+      <p:sp>
+        <p:nvSpPr>
+          <p:cNvPr id="18" name="Arrow"/>
+          <p:cNvSpPr/>
+          <p:nvPr/>
+        </p:nvSpPr>
+        <p:spPr>
+          <a:xfrm>
+            <a:off x="7287768" y="2550000"/>
+            <a:ext cx="164592" cy="560000"/>
+          </a:xfrm>
+          <a:prstGeom prst="rect">
+            <a:avLst/>
+          </a:prstGeom>
+          <a:noFill/>
+          <a:ln/>
+        </p:spPr>
+        <p:txBody>
+          <a:bodyPr wrap="square" lIns="0" tIns="0" rIns="0" bIns="0" rtlCol="0" anchor="ctr"/>
+          <a:lstStyle/>
+          <a:p>
+            <a:pPr marL="0" indent="0" algn="ctr">
+              <a:buNone/>
+            </a:pPr>
+            <a:r>
+              <a:rPr lang="en-US" sz="1000" kern="0" dirty="0">
+                <a:solidFill>
+                  <a:srgbClr val="3B82F6"/>
+                </a:solidFill>
+                <a:latin typeface="Inter" pitchFamily="34" charset="0"/>
+                <a:ea typeface="Inter" pitchFamily="34" charset="-122"/>
+                <a:cs typeface="Inter" pitchFamily="34" charset="-120"/>
+              </a:rPr>
               <a:t>→</a:t>
             </a:r>
-            <a:endParaRPr lang="en-US" sz="1000" dirty="0"/>
-          </a:p>
-        </p:txBody>
-      </p:sp>
-      <p:sp>
-        <p:nvSpPr>
-          <p:cNvPr id="24" name="Shape 22"/>
-          <p:cNvSpPr/>
-          <p:nvPr/>
-        </p:nvSpPr>
-        <p:spPr>
-          <a:xfrm>
-            <a:off x="6711696" y="2103120"/>
-            <a:ext cx="932688" cy="502920"/>
+          </a:p>
+        </p:txBody>
+      </p:sp>
+      <p:sp>
+        <p:nvSpPr>
+          <p:cNvPr id="19" name="Pill"/>
+          <p:cNvSpPr/>
+          <p:nvPr/>
+        </p:nvSpPr>
+        <p:spPr>
+          <a:xfrm>
+            <a:off x="7452360" y="2550000"/>
+            <a:ext cx="1234440" cy="560000"/>
           </a:xfrm>
           <a:prstGeom prst="roundRect">
             <a:avLst>
@@ -4437,39 +4405,14 @@
           </a:ln>
         </p:spPr>
         <p:txBody>
-          <a:bodyPr/>
-          <a:lstStyle/>
-          <a:p>
-            <a:endParaRPr/>
-          </a:p>
-        </p:txBody>
-      </p:sp>
-      <p:sp>
-        <p:nvSpPr>
-          <p:cNvPr id="25" name="Text 23"/>
-          <p:cNvSpPr/>
-          <p:nvPr/>
-        </p:nvSpPr>
-        <p:spPr>
-          <a:xfrm>
-            <a:off x="6711696" y="2103120"/>
-            <a:ext cx="932688" cy="502920"/>
-          </a:xfrm>
-          <a:prstGeom prst="rect">
-            <a:avLst/>
-          </a:prstGeom>
-          <a:noFill/>
-          <a:ln/>
-        </p:spPr>
-        <p:txBody>
-          <a:bodyPr wrap="square" lIns="0" tIns="0" rIns="0" bIns="0" rtlCol="0" anchor="ctr"/>
+          <a:bodyPr wrap="square" lIns="36000" tIns="0" rIns="36000" bIns="0" rtlCol="0" anchor="ctr"/>
           <a:lstStyle/>
           <a:p>
             <a:pPr marL="0" indent="0" algn="ctr">
               <a:buNone/>
             </a:pPr>
             <a:r>
-              <a:rPr lang="en-US" sz="1100" b="1" dirty="0">
+              <a:rPr lang="en-US" sz="1050" b="1" kern="0" dirty="0">
                 <a:solidFill>
                   <a:srgbClr val="F8FAFC"/>
                 </a:solidFill>
@@ -4479,36 +4422,13 @@
               </a:rPr>
               <a:t>commit</a:t>
             </a:r>
-            <a:endParaRPr lang="en-US" sz="1100" dirty="0"/>
-          </a:p>
-        </p:txBody>
-      </p:sp>
-      <p:sp>
-        <p:nvSpPr>
-          <p:cNvPr id="26" name="Text 24"/>
-          <p:cNvSpPr/>
-          <p:nvPr/>
-        </p:nvSpPr>
-        <p:spPr>
-          <a:xfrm>
-            <a:off x="7626096" y="2103120"/>
-            <a:ext cx="164592" cy="502920"/>
-          </a:xfrm>
-          <a:prstGeom prst="rect">
-            <a:avLst/>
-          </a:prstGeom>
-          <a:noFill/>
-          <a:ln/>
-        </p:spPr>
-        <p:txBody>
-          <a:bodyPr wrap="square" lIns="0" tIns="0" rIns="0" bIns="0" rtlCol="0" anchor="ctr"/>
-          <a:lstStyle/>
+          </a:p>
           <a:p>
             <a:pPr marL="0" indent="0" algn="ctr">
               <a:buNone/>
             </a:pPr>
             <a:r>
-              <a:rPr lang="en-US" sz="1000" dirty="0">
+              <a:rPr lang="en-US" sz="750" kern="0" dirty="0">
                 <a:solidFill>
                   <a:srgbClr val="3B82F6"/>
                 </a:solidFill>
@@ -4516,22 +4436,135 @@
                 <a:ea typeface="Inter" pitchFamily="34" charset="-122"/>
                 <a:cs typeface="Inter" pitchFamily="34" charset="-120"/>
               </a:rPr>
-              <a:t>→</a:t>
-            </a:r>
-            <a:endParaRPr lang="en-US" sz="1000" dirty="0"/>
-          </a:p>
-        </p:txBody>
-      </p:sp>
-      <p:sp>
-        <p:nvSpPr>
-          <p:cNvPr id="27" name="Shape 25"/>
-          <p:cNvSpPr/>
-          <p:nvPr/>
-        </p:nvSpPr>
-        <p:spPr>
-          <a:xfrm>
-            <a:off x="7754112" y="2103120"/>
-            <a:ext cx="932688" cy="502920"/>
+              <a:t>/commit-sc</a:t>
+            </a:r>
+          </a:p>
+        </p:txBody>
+      </p:sp>
+      <p:sp>
+        <p:nvSpPr>
+          <p:cNvPr id="20" name="Text"/>
+          <p:cNvSpPr/>
+          <p:nvPr/>
+        </p:nvSpPr>
+        <p:spPr>
+          <a:xfrm>
+            <a:off x="3255264" y="3120000"/>
+            <a:ext cx="1234440" cy="150000"/>
+          </a:xfrm>
+          <a:prstGeom prst="rect">
+            <a:avLst/>
+          </a:prstGeom>
+          <a:noFill/>
+          <a:ln/>
+        </p:spPr>
+        <p:txBody>
+          <a:bodyPr wrap="square" lIns="0" tIns="0" rIns="0" bIns="0" rtlCol="0" anchor="ctr"/>
+          <a:lstStyle/>
+          <a:p>
+            <a:pPr marL="0" indent="0" algn="ctr">
+              <a:buNone/>
+            </a:pPr>
+            <a:r>
+              <a:rPr lang="en-US" sz="800" kern="0" dirty="0">
+                <a:solidFill>
+                  <a:srgbClr val="94A3B8"/>
+                </a:solidFill>
+                <a:latin typeface="Inter" pitchFamily="34" charset="0"/>
+                <a:ea typeface="Inter" pitchFamily="34" charset="-122"/>
+                <a:cs typeface="Inter" pitchFamily="34" charset="-120"/>
+              </a:rPr>
+              <a:t>↺ fails → fix → retry ×3</a:t>
+            </a:r>
+          </a:p>
+        </p:txBody>
+      </p:sp>
+      <p:sp>
+        <p:nvSpPr>
+          <p:cNvPr id="21" name="Text"/>
+          <p:cNvSpPr/>
+          <p:nvPr/>
+        </p:nvSpPr>
+        <p:spPr>
+          <a:xfrm>
+            <a:off x="4472000" y="3300000"/>
+            <a:ext cx="200000" cy="170000"/>
+          </a:xfrm>
+          <a:prstGeom prst="rect">
+            <a:avLst/>
+          </a:prstGeom>
+          <a:noFill/>
+          <a:ln/>
+        </p:spPr>
+        <p:txBody>
+          <a:bodyPr wrap="square" lIns="0" tIns="0" rIns="0" bIns="0" rtlCol="0" anchor="ctr"/>
+          <a:lstStyle/>
+          <a:p>
+            <a:pPr marL="0" indent="0" algn="ctr">
+              <a:buNone/>
+            </a:pPr>
+            <a:r>
+              <a:rPr lang="en-US" sz="1400" kern="0" dirty="0">
+                <a:solidFill>
+                  <a:srgbClr val="3B82F6"/>
+                </a:solidFill>
+                <a:latin typeface="Inter" pitchFamily="34" charset="0"/>
+                <a:ea typeface="Inter" pitchFamily="34" charset="-122"/>
+                <a:cs typeface="Inter" pitchFamily="34" charset="-120"/>
+              </a:rPr>
+              <a:t>↓</a:t>
+            </a:r>
+          </a:p>
+        </p:txBody>
+      </p:sp>
+      <p:sp>
+        <p:nvSpPr>
+          <p:cNvPr id="22" name="Text"/>
+          <p:cNvSpPr/>
+          <p:nvPr/>
+        </p:nvSpPr>
+        <p:spPr>
+          <a:xfrm>
+            <a:off x="457200" y="3470000"/>
+            <a:ext cx="8229600" cy="180000"/>
+          </a:xfrm>
+          <a:prstGeom prst="rect">
+            <a:avLst/>
+          </a:prstGeom>
+          <a:noFill/>
+          <a:ln/>
+        </p:spPr>
+        <p:txBody>
+          <a:bodyPr wrap="square" lIns="0" tIns="0" rIns="0" bIns="0" rtlCol="0" anchor="ctr"/>
+          <a:lstStyle/>
+          <a:p>
+            <a:pPr marL="0" indent="0" algn="l">
+              <a:buNone/>
+            </a:pPr>
+            <a:r>
+              <a:rPr lang="en-US" sz="900" b="1" spc="200" kern="0" dirty="0">
+                <a:solidFill>
+                  <a:srgbClr val="3B82F6"/>
+                </a:solidFill>
+                <a:latin typeface="Inter" pitchFamily="34" charset="0"/>
+                <a:ea typeface="Inter" pitchFamily="34" charset="-122"/>
+                <a:cs typeface="Inter" pitchFamily="34" charset="-120"/>
+              </a:rPr>
+              <a:t>ACCEPTANCE GATE · THEN SHIP</a:t>
+            </a:r>
+          </a:p>
+        </p:txBody>
+      </p:sp>
+      <p:sp>
+        <p:nvSpPr>
+          <p:cNvPr id="23" name="Pill"/>
+          <p:cNvSpPr/>
+          <p:nvPr/>
+        </p:nvSpPr>
+        <p:spPr>
+          <a:xfrm>
+            <a:off x="457200" y="3650000"/>
+            <a:ext cx="1514246" cy="560000"/>
           </a:xfrm>
           <a:prstGeom prst="roundRect">
             <a:avLst>
@@ -4549,39 +4582,14 @@
           </a:ln>
         </p:spPr>
         <p:txBody>
-          <a:bodyPr/>
-          <a:lstStyle/>
-          <a:p>
-            <a:endParaRPr/>
-          </a:p>
-        </p:txBody>
-      </p:sp>
-      <p:sp>
-        <p:nvSpPr>
-          <p:cNvPr id="28" name="Text 26"/>
-          <p:cNvSpPr/>
-          <p:nvPr/>
-        </p:nvSpPr>
-        <p:spPr>
-          <a:xfrm>
-            <a:off x="7754112" y="2103120"/>
-            <a:ext cx="932688" cy="502920"/>
-          </a:xfrm>
-          <a:prstGeom prst="rect">
-            <a:avLst/>
-          </a:prstGeom>
-          <a:noFill/>
-          <a:ln/>
-        </p:spPr>
-        <p:txBody>
-          <a:bodyPr wrap="square" lIns="0" tIns="0" rIns="0" bIns="0" rtlCol="0" anchor="ctr"/>
+          <a:bodyPr wrap="square" lIns="36000" tIns="0" rIns="36000" bIns="0" rtlCol="0" anchor="ctr"/>
           <a:lstStyle/>
           <a:p>
             <a:pPr marL="0" indent="0" algn="ctr">
               <a:buNone/>
             </a:pPr>
             <a:r>
-              <a:rPr lang="en-US" sz="1100" b="1" dirty="0">
+              <a:rPr lang="en-US" sz="1050" b="1" kern="0" dirty="0">
                 <a:solidFill>
                   <a:srgbClr val="F8FAFC"/>
                 </a:solidFill>
@@ -4589,38 +4597,457 @@
                 <a:ea typeface="Inter" pitchFamily="34" charset="-122"/>
                 <a:cs typeface="Inter" pitchFamily="34" charset="-120"/>
               </a:rPr>
-              <a:t>PR</a:t>
-            </a:r>
-            <a:endParaRPr lang="en-US" sz="1100" dirty="0"/>
-          </a:p>
-        </p:txBody>
-      </p:sp>
-      <p:sp>
-        <p:nvSpPr>
-          <p:cNvPr id="29" name="Text 27"/>
-          <p:cNvSpPr/>
-          <p:nvPr/>
-        </p:nvSpPr>
-        <p:spPr>
-          <a:xfrm>
-            <a:off x="457200" y="3108960"/>
-            <a:ext cx="8229600" cy="640080"/>
-          </a:xfrm>
-          <a:prstGeom prst="rect">
-            <a:avLst/>
-          </a:prstGeom>
-          <a:noFill/>
-          <a:ln/>
-        </p:spPr>
-        <p:txBody>
-          <a:bodyPr wrap="square" lIns="0" tIns="0" rIns="0" bIns="0" rtlCol="0" anchor="ctr"/>
-          <a:lstStyle/>
+              <a:t>acceptance gate</a:t>
+            </a:r>
+          </a:p>
           <a:p>
             <a:pPr marL="0" indent="0" algn="ctr">
               <a:buNone/>
             </a:pPr>
             <a:r>
-              <a:rPr lang="en-US" sz="1400" dirty="0">
+              <a:rPr lang="en-US" sz="750" kern="0" dirty="0">
+                <a:solidFill>
+                  <a:srgbClr val="3B82F6"/>
+                </a:solidFill>
+                <a:latin typeface="Inter" pitchFamily="34" charset="0"/>
+                <a:ea typeface="Inter" pitchFamily="34" charset="-122"/>
+                <a:cs typeface="Inter" pitchFamily="34" charset="-120"/>
+              </a:rPr>
+              <a:t>AC-1 … AC-6</a:t>
+            </a:r>
+          </a:p>
+        </p:txBody>
+      </p:sp>
+      <p:sp>
+        <p:nvSpPr>
+          <p:cNvPr id="24" name="Arrow"/>
+          <p:cNvSpPr/>
+          <p:nvPr/>
+        </p:nvSpPr>
+        <p:spPr>
+          <a:xfrm>
+            <a:off x="1971446" y="3650000"/>
+            <a:ext cx="164592" cy="560000"/>
+          </a:xfrm>
+          <a:prstGeom prst="rect">
+            <a:avLst/>
+          </a:prstGeom>
+          <a:noFill/>
+          <a:ln/>
+        </p:spPr>
+        <p:txBody>
+          <a:bodyPr wrap="square" lIns="0" tIns="0" rIns="0" bIns="0" rtlCol="0" anchor="ctr"/>
+          <a:lstStyle/>
+          <a:p>
+            <a:pPr marL="0" indent="0" algn="ctr">
+              <a:buNone/>
+            </a:pPr>
+            <a:r>
+              <a:rPr lang="en-US" sz="1000" kern="0" dirty="0">
+                <a:solidFill>
+                  <a:srgbClr val="3B82F6"/>
+                </a:solidFill>
+                <a:latin typeface="Inter" pitchFamily="34" charset="0"/>
+                <a:ea typeface="Inter" pitchFamily="34" charset="-122"/>
+                <a:cs typeface="Inter" pitchFamily="34" charset="-120"/>
+              </a:rPr>
+              <a:t>→</a:t>
+            </a:r>
+          </a:p>
+        </p:txBody>
+      </p:sp>
+      <p:sp>
+        <p:nvSpPr>
+          <p:cNvPr id="25" name="Pill"/>
+          <p:cNvSpPr/>
+          <p:nvPr/>
+        </p:nvSpPr>
+        <p:spPr>
+          <a:xfrm>
+            <a:off x="2136038" y="3650000"/>
+            <a:ext cx="1514246" cy="560000"/>
+          </a:xfrm>
+          <a:prstGeom prst="roundRect">
+            <a:avLst>
+              <a:gd name="adj" fmla="val 9091"/>
+            </a:avLst>
+          </a:prstGeom>
+          <a:solidFill>
+            <a:srgbClr val="1B2640"/>
+          </a:solidFill>
+          <a:ln w="9525">
+            <a:solidFill>
+              <a:srgbClr val="64748B"/>
+            </a:solidFill>
+            <a:prstDash val="solid"/>
+          </a:ln>
+        </p:spPr>
+        <p:txBody>
+          <a:bodyPr wrap="square" lIns="36000" tIns="0" rIns="36000" bIns="0" rtlCol="0" anchor="ctr"/>
+          <a:lstStyle/>
+          <a:p>
+            <a:pPr marL="0" indent="0" algn="ctr">
+              <a:buNone/>
+            </a:pPr>
+            <a:r>
+              <a:rPr lang="en-US" sz="1050" b="1" kern="0" dirty="0">
+                <a:solidFill>
+                  <a:srgbClr val="F8FAFC"/>
+                </a:solidFill>
+                <a:latin typeface="Inter" pitchFamily="34" charset="0"/>
+                <a:ea typeface="Inter" pitchFamily="34" charset="-122"/>
+                <a:cs typeface="Inter" pitchFamily="34" charset="-120"/>
+              </a:rPr>
+              <a:t>PR review</a:t>
+            </a:r>
+          </a:p>
+          <a:p>
+            <a:pPr marL="0" indent="0" algn="ctr">
+              <a:buNone/>
+            </a:pPr>
+            <a:r>
+              <a:rPr lang="en-US" sz="750" kern="0" dirty="0">
+                <a:solidFill>
+                  <a:srgbClr val="3B82F6"/>
+                </a:solidFill>
+                <a:latin typeface="Inter" pitchFamily="34" charset="0"/>
+                <a:ea typeface="Inter" pitchFamily="34" charset="-122"/>
+                <a:cs typeface="Inter" pitchFamily="34" charset="-120"/>
+              </a:rPr>
+              <a:t>/review-pr</a:t>
+            </a:r>
+          </a:p>
+        </p:txBody>
+      </p:sp>
+      <p:sp>
+        <p:nvSpPr>
+          <p:cNvPr id="26" name="Arrow"/>
+          <p:cNvSpPr/>
+          <p:nvPr/>
+        </p:nvSpPr>
+        <p:spPr>
+          <a:xfrm>
+            <a:off x="3650284" y="3650000"/>
+            <a:ext cx="164592" cy="560000"/>
+          </a:xfrm>
+          <a:prstGeom prst="rect">
+            <a:avLst/>
+          </a:prstGeom>
+          <a:noFill/>
+          <a:ln/>
+        </p:spPr>
+        <p:txBody>
+          <a:bodyPr wrap="square" lIns="0" tIns="0" rIns="0" bIns="0" rtlCol="0" anchor="ctr"/>
+          <a:lstStyle/>
+          <a:p>
+            <a:pPr marL="0" indent="0" algn="ctr">
+              <a:buNone/>
+            </a:pPr>
+            <a:r>
+              <a:rPr lang="en-US" sz="1000" kern="0" dirty="0">
+                <a:solidFill>
+                  <a:srgbClr val="3B82F6"/>
+                </a:solidFill>
+                <a:latin typeface="Inter" pitchFamily="34" charset="0"/>
+                <a:ea typeface="Inter" pitchFamily="34" charset="-122"/>
+                <a:cs typeface="Inter" pitchFamily="34" charset="-120"/>
+              </a:rPr>
+              <a:t>→</a:t>
+            </a:r>
+          </a:p>
+        </p:txBody>
+      </p:sp>
+      <p:sp>
+        <p:nvSpPr>
+          <p:cNvPr id="27" name="Pill"/>
+          <p:cNvSpPr/>
+          <p:nvPr/>
+        </p:nvSpPr>
+        <p:spPr>
+          <a:xfrm>
+            <a:off x="3814876" y="3650000"/>
+            <a:ext cx="1514246" cy="560000"/>
+          </a:xfrm>
+          <a:prstGeom prst="roundRect">
+            <a:avLst>
+              <a:gd name="adj" fmla="val 9091"/>
+            </a:avLst>
+          </a:prstGeom>
+          <a:solidFill>
+            <a:srgbClr val="1B2640"/>
+          </a:solidFill>
+          <a:ln w="9525">
+            <a:solidFill>
+              <a:srgbClr val="64748B"/>
+            </a:solidFill>
+            <a:prstDash val="solid"/>
+          </a:ln>
+        </p:spPr>
+        <p:txBody>
+          <a:bodyPr wrap="square" lIns="36000" tIns="0" rIns="36000" bIns="0" rtlCol="0" anchor="ctr"/>
+          <a:lstStyle/>
+          <a:p>
+            <a:pPr marL="0" indent="0" algn="ctr">
+              <a:buNone/>
+            </a:pPr>
+            <a:r>
+              <a:rPr lang="en-US" sz="1050" b="1" kern="0" dirty="0">
+                <a:solidFill>
+                  <a:srgbClr val="F8FAFC"/>
+                </a:solidFill>
+                <a:latin typeface="Inter" pitchFamily="34" charset="0"/>
+                <a:ea typeface="Inter" pitchFamily="34" charset="-122"/>
+                <a:cs typeface="Inter" pitchFamily="34" charset="-120"/>
+              </a:rPr>
+              <a:t>create PR</a:t>
+            </a:r>
+          </a:p>
+          <a:p>
+            <a:pPr marL="0" indent="0" algn="ctr">
+              <a:buNone/>
+            </a:pPr>
+            <a:r>
+              <a:rPr lang="en-US" sz="750" kern="0" dirty="0">
+                <a:solidFill>
+                  <a:srgbClr val="3B82F6"/>
+                </a:solidFill>
+                <a:latin typeface="Inter" pitchFamily="34" charset="0"/>
+                <a:ea typeface="Inter" pitchFamily="34" charset="-122"/>
+                <a:cs typeface="Inter" pitchFamily="34" charset="-120"/>
+              </a:rPr>
+              <a:t>/create-pr</a:t>
+            </a:r>
+          </a:p>
+        </p:txBody>
+      </p:sp>
+      <p:sp>
+        <p:nvSpPr>
+          <p:cNvPr id="28" name="Arrow"/>
+          <p:cNvSpPr/>
+          <p:nvPr/>
+        </p:nvSpPr>
+        <p:spPr>
+          <a:xfrm>
+            <a:off x="5329122" y="3650000"/>
+            <a:ext cx="164592" cy="560000"/>
+          </a:xfrm>
+          <a:prstGeom prst="rect">
+            <a:avLst/>
+          </a:prstGeom>
+          <a:noFill/>
+          <a:ln/>
+        </p:spPr>
+        <p:txBody>
+          <a:bodyPr wrap="square" lIns="0" tIns="0" rIns="0" bIns="0" rtlCol="0" anchor="ctr"/>
+          <a:lstStyle/>
+          <a:p>
+            <a:pPr marL="0" indent="0" algn="ctr">
+              <a:buNone/>
+            </a:pPr>
+            <a:r>
+              <a:rPr lang="en-US" sz="1000" kern="0" dirty="0">
+                <a:solidFill>
+                  <a:srgbClr val="3B82F6"/>
+                </a:solidFill>
+                <a:latin typeface="Inter" pitchFamily="34" charset="0"/>
+                <a:ea typeface="Inter" pitchFamily="34" charset="-122"/>
+                <a:cs typeface="Inter" pitchFamily="34" charset="-120"/>
+              </a:rPr>
+              <a:t>→</a:t>
+            </a:r>
+          </a:p>
+        </p:txBody>
+      </p:sp>
+      <p:sp>
+        <p:nvSpPr>
+          <p:cNvPr id="29" name="Pill"/>
+          <p:cNvSpPr/>
+          <p:nvPr/>
+        </p:nvSpPr>
+        <p:spPr>
+          <a:xfrm>
+            <a:off x="5493714" y="3650000"/>
+            <a:ext cx="1514246" cy="560000"/>
+          </a:xfrm>
+          <a:prstGeom prst="roundRect">
+            <a:avLst>
+              <a:gd name="adj" fmla="val 9091"/>
+            </a:avLst>
+          </a:prstGeom>
+          <a:solidFill>
+            <a:srgbClr val="1B2640"/>
+          </a:solidFill>
+          <a:ln w="9525">
+            <a:solidFill>
+              <a:srgbClr val="64748B"/>
+            </a:solidFill>
+            <a:prstDash val="solid"/>
+          </a:ln>
+        </p:spPr>
+        <p:txBody>
+          <a:bodyPr wrap="square" lIns="36000" tIns="0" rIns="36000" bIns="0" rtlCol="0" anchor="ctr"/>
+          <a:lstStyle/>
+          <a:p>
+            <a:pPr marL="0" indent="0" algn="ctr">
+              <a:buNone/>
+            </a:pPr>
+            <a:r>
+              <a:rPr lang="en-US" sz="1050" b="1" kern="0" dirty="0">
+                <a:solidFill>
+                  <a:srgbClr val="F8FAFC"/>
+                </a:solidFill>
+                <a:latin typeface="Inter" pitchFamily="34" charset="0"/>
+                <a:ea typeface="Inter" pitchFamily="34" charset="-122"/>
+                <a:cs typeface="Inter" pitchFamily="34" charset="-120"/>
+              </a:rPr>
+              <a:t>pipeline</a:t>
+            </a:r>
+          </a:p>
+          <a:p>
+            <a:pPr marL="0" indent="0" algn="ctr">
+              <a:buNone/>
+            </a:pPr>
+            <a:r>
+              <a:rPr lang="en-US" sz="750" kern="0" dirty="0">
+                <a:solidFill>
+                  <a:srgbClr val="3B82F6"/>
+                </a:solidFill>
+                <a:latin typeface="Inter" pitchFamily="34" charset="0"/>
+                <a:ea typeface="Inter" pitchFamily="34" charset="-122"/>
+                <a:cs typeface="Inter" pitchFamily="34" charset="-120"/>
+              </a:rPr>
+              <a:t>/devops watch</a:t>
+            </a:r>
+          </a:p>
+        </p:txBody>
+      </p:sp>
+      <p:sp>
+        <p:nvSpPr>
+          <p:cNvPr id="30" name="Arrow"/>
+          <p:cNvSpPr/>
+          <p:nvPr/>
+        </p:nvSpPr>
+        <p:spPr>
+          <a:xfrm>
+            <a:off x="7007960" y="3650000"/>
+            <a:ext cx="164592" cy="560000"/>
+          </a:xfrm>
+          <a:prstGeom prst="rect">
+            <a:avLst/>
+          </a:prstGeom>
+          <a:noFill/>
+          <a:ln/>
+        </p:spPr>
+        <p:txBody>
+          <a:bodyPr wrap="square" lIns="0" tIns="0" rIns="0" bIns="0" rtlCol="0" anchor="ctr"/>
+          <a:lstStyle/>
+          <a:p>
+            <a:pPr marL="0" indent="0" algn="ctr">
+              <a:buNone/>
+            </a:pPr>
+            <a:r>
+              <a:rPr lang="en-US" sz="1000" kern="0" dirty="0">
+                <a:solidFill>
+                  <a:srgbClr val="3B82F6"/>
+                </a:solidFill>
+                <a:latin typeface="Inter" pitchFamily="34" charset="0"/>
+                <a:ea typeface="Inter" pitchFamily="34" charset="-122"/>
+                <a:cs typeface="Inter" pitchFamily="34" charset="-120"/>
+              </a:rPr>
+              <a:t>→</a:t>
+            </a:r>
+          </a:p>
+        </p:txBody>
+      </p:sp>
+      <p:sp>
+        <p:nvSpPr>
+          <p:cNvPr id="31" name="Pill"/>
+          <p:cNvSpPr/>
+          <p:nvPr/>
+        </p:nvSpPr>
+        <p:spPr>
+          <a:xfrm>
+            <a:off x="7172552" y="3650000"/>
+            <a:ext cx="1514246" cy="560000"/>
+          </a:xfrm>
+          <a:prstGeom prst="roundRect">
+            <a:avLst>
+              <a:gd name="adj" fmla="val 9091"/>
+            </a:avLst>
+          </a:prstGeom>
+          <a:solidFill>
+            <a:srgbClr val="1B2640"/>
+          </a:solidFill>
+          <a:ln w="19050">
+            <a:solidFill>
+              <a:srgbClr val="3B82F6"/>
+            </a:solidFill>
+            <a:prstDash val="solid"/>
+          </a:ln>
+        </p:spPr>
+        <p:txBody>
+          <a:bodyPr wrap="square" lIns="36000" tIns="0" rIns="36000" bIns="0" rtlCol="0" anchor="ctr"/>
+          <a:lstStyle/>
+          <a:p>
+            <a:pPr marL="0" indent="0" algn="ctr">
+              <a:buNone/>
+            </a:pPr>
+            <a:r>
+              <a:rPr lang="en-US" sz="1050" b="1" kern="0" dirty="0">
+                <a:solidFill>
+                  <a:srgbClr val="F8FAFC"/>
+                </a:solidFill>
+                <a:latin typeface="Inter" pitchFamily="34" charset="0"/>
+                <a:ea typeface="Inter" pitchFamily="34" charset="-122"/>
+                <a:cs typeface="Inter" pitchFamily="34" charset="-120"/>
+              </a:rPr>
+              <a:t>human review</a:t>
+            </a:r>
+          </a:p>
+          <a:p>
+            <a:pPr marL="0" indent="0" algn="ctr">
+              <a:buNone/>
+            </a:pPr>
+            <a:r>
+              <a:rPr lang="en-US" sz="750" kern="0" dirty="0">
+                <a:solidFill>
+                  <a:srgbClr val="3B82F6"/>
+                </a:solidFill>
+                <a:latin typeface="Inter" pitchFamily="34" charset="0"/>
+                <a:ea typeface="Inter" pitchFamily="34" charset="-122"/>
+                <a:cs typeface="Inter" pitchFamily="34" charset="-120"/>
+              </a:rPr>
+              <a:t>mandatory</a:t>
+            </a:r>
+          </a:p>
+        </p:txBody>
+      </p:sp>
+      <p:sp>
+        <p:nvSpPr>
+          <p:cNvPr id="32" name="Text"/>
+          <p:cNvSpPr/>
+          <p:nvPr/>
+        </p:nvSpPr>
+        <p:spPr>
+          <a:xfrm>
+            <a:off x="457200" y="4300000"/>
+            <a:ext cx="8229600" cy="420000"/>
+          </a:xfrm>
+          <a:prstGeom prst="rect">
+            <a:avLst/>
+          </a:prstGeom>
+          <a:noFill/>
+          <a:ln/>
+        </p:spPr>
+        <p:txBody>
+          <a:bodyPr wrap="square" lIns="0" tIns="0" rIns="0" bIns="0" rtlCol="0" anchor="ctr"/>
+          <a:lstStyle/>
+          <a:p>
+            <a:pPr marL="0" indent="0" algn="ctr">
+              <a:buNone/>
+            </a:pPr>
+            <a:r>
+              <a:rPr lang="en-US" sz="1100" kern="0" dirty="0">
                 <a:solidFill>
                   <a:srgbClr val="94A3B8"/>
                 </a:solidFill>
@@ -4628,16 +5055,15 @@
                 <a:ea typeface="Inter" pitchFamily="34" charset="-122"/>
                 <a:cs typeface="Inter" pitchFamily="34" charset="-120"/>
               </a:rPr>
-              <a:t>each box is a specialist — the orchestrator picks which one, when,</a:t>
-            </a:r>
-            <a:endParaRPr lang="en-US" sz="1400" dirty="0"/>
+              <a:t>each box is a skill the orchestrator invokes — it decides which, when, and how to recover.</a:t>
+            </a:r>
           </a:p>
           <a:p>
             <a:pPr marL="0" indent="0" algn="ctr">
               <a:buNone/>
             </a:pPr>
             <a:r>
-              <a:rPr lang="en-US" sz="1400" dirty="0">
+              <a:rPr lang="en-US" sz="1100" kern="0" dirty="0">
                 <a:solidFill>
                   <a:srgbClr val="94A3B8"/>
                 </a:solidFill>
@@ -4645,99 +5071,83 @@
                 <a:ea typeface="Inter" pitchFamily="34" charset="-122"/>
                 <a:cs typeface="Inter" pitchFamily="34" charset="-120"/>
               </a:rPr>
-              <a:t>and what to do when one fails</a:t>
-            </a:r>
-            <a:endParaRPr lang="en-US" sz="1400" dirty="0"/>
-          </a:p>
-        </p:txBody>
-      </p:sp>
-      <p:sp>
-        <p:nvSpPr>
-          <p:cNvPr id="30" name="Rectangle 29">
-            <a:extLst>
-              <a:ext uri="{FF2B5EF4-FFF2-40B4-BE49-F238E27FC236}">
-                <a16:creationId xmlns:a16="http://schemas.microsoft.com/office/drawing/2014/main" id="{57B5A57E-809B-4868-FA01-5B67EF4AEBBC}"/>
-              </a:ext>
-            </a:extLst>
-          </p:cNvPr>
-          <p:cNvSpPr/>
-          <p:nvPr/>
-        </p:nvSpPr>
-        <p:spPr>
-          <a:xfrm>
-            <a:off x="1481328" y="1611848"/>
-            <a:ext cx="6163056" cy="1159706"/>
-          </a:xfrm>
-          <a:prstGeom prst="rect">
-            <a:avLst/>
-          </a:prstGeom>
-          <a:noFill/>
-          <a:ln w="44450">
-            <a:solidFill>
-              <a:schemeClr val="bg1"/>
-            </a:solidFill>
-          </a:ln>
-        </p:spPr>
-        <p:style>
-          <a:lnRef idx="2">
-            <a:schemeClr val="accent1">
-              <a:shade val="15000"/>
-            </a:schemeClr>
-          </a:lnRef>
-          <a:fillRef idx="1">
-            <a:schemeClr val="accent1"/>
-          </a:fillRef>
-          <a:effectRef idx="0">
-            <a:schemeClr val="accent1"/>
-          </a:effectRef>
-          <a:fontRef idx="minor">
-            <a:schemeClr val="lt1"/>
-          </a:fontRef>
-        </p:style>
-        <p:txBody>
-          <a:bodyPr rtlCol="0" anchor="ctr"/>
-          <a:lstStyle/>
-          <a:p>
-            <a:pPr algn="ctr"/>
-            <a:endParaRPr lang="en-US"/>
-          </a:p>
-        </p:txBody>
-      </p:sp>
-      <p:sp>
-        <p:nvSpPr>
-          <p:cNvPr id="31" name="TextBox 30">
-            <a:extLst>
-              <a:ext uri="{FF2B5EF4-FFF2-40B4-BE49-F238E27FC236}">
-                <a16:creationId xmlns:a16="http://schemas.microsoft.com/office/drawing/2014/main" id="{626E6013-7D5F-ED52-3B73-AF150D587820}"/>
-              </a:ext>
-            </a:extLst>
-          </p:cNvPr>
-          <p:cNvSpPr txBox="1"/>
-          <p:nvPr/>
-        </p:nvSpPr>
-        <p:spPr>
-          <a:xfrm>
-            <a:off x="3751237" y="1611847"/>
-            <a:ext cx="1341971" cy="369332"/>
-          </a:xfrm>
-          <a:prstGeom prst="rect">
-            <a:avLst/>
-          </a:prstGeom>
-          <a:noFill/>
-        </p:spPr>
-        <p:txBody>
-          <a:bodyPr wrap="square" rtlCol="0">
-            <a:spAutoFit/>
-          </a:bodyPr>
-          <a:lstStyle/>
-          <a:p>
-            <a:r>
-              <a:rPr lang="en-US" dirty="0">
-                <a:solidFill>
-                  <a:schemeClr val="bg1"/>
-                </a:solidFill>
-              </a:rPr>
-              <a:t>For Each {}</a:t>
+              <a:t>the inner loop retries on failure; a human must approve before merge.</a:t>
+            </a:r>
+          </a:p>
+        </p:txBody>
+      </p:sp>
+      <p:sp>
+        <p:nvSpPr>
+          <p:cNvPr id="33" name="Text"/>
+          <p:cNvSpPr/>
+          <p:nvPr/>
+        </p:nvSpPr>
+        <p:spPr>
+          <a:xfrm>
+            <a:off x="457200" y="4796028"/>
+            <a:ext cx="4572000" cy="274320"/>
+          </a:xfrm>
+          <a:prstGeom prst="rect">
+            <a:avLst/>
+          </a:prstGeom>
+          <a:noFill/>
+          <a:ln/>
+        </p:spPr>
+        <p:txBody>
+          <a:bodyPr wrap="square" lIns="0" tIns="0" rIns="0" bIns="0" rtlCol="0" anchor="ctr"/>
+          <a:lstStyle/>
+          <a:p>
+            <a:pPr marL="0" indent="0" algn="l">
+              <a:buNone/>
+            </a:pPr>
+            <a:r>
+              <a:rPr lang="en-US" sz="800" spc="200" kern="0" dirty="0">
+                <a:solidFill>
+                  <a:srgbClr val="64748B"/>
+                </a:solidFill>
+                <a:latin typeface="Inter" pitchFamily="34" charset="0"/>
+                <a:ea typeface="Inter" pitchFamily="34" charset="-122"/>
+                <a:cs typeface="Inter" pitchFamily="34" charset="-120"/>
+              </a:rPr>
+              <a:t>02 · how it works</a:t>
+            </a:r>
+          </a:p>
+        </p:txBody>
+      </p:sp>
+      <p:sp>
+        <p:nvSpPr>
+          <p:cNvPr id="34" name="Text"/>
+          <p:cNvSpPr/>
+          <p:nvPr/>
+        </p:nvSpPr>
+        <p:spPr>
+          <a:xfrm>
+            <a:off x="8229600" y="4796028"/>
+            <a:ext cx="457200" cy="274320"/>
+          </a:xfrm>
+          <a:prstGeom prst="rect">
+            <a:avLst/>
+          </a:prstGeom>
+          <a:noFill/>
+          <a:ln/>
+        </p:spPr>
+        <p:txBody>
+          <a:bodyPr wrap="square" lIns="0" tIns="0" rIns="0" bIns="0" rtlCol="0" anchor="ctr"/>
+          <a:lstStyle/>
+          <a:p>
+            <a:pPr marL="0" indent="0" algn="r">
+              <a:buNone/>
+            </a:pPr>
+            <a:r>
+              <a:rPr lang="en-US" sz="800" kern="0" dirty="0">
+                <a:solidFill>
+                  <a:srgbClr val="64748B"/>
+                </a:solidFill>
+                <a:latin typeface="Inter" pitchFamily="34" charset="0"/>
+                <a:ea typeface="Inter" pitchFamily="34" charset="-122"/>
+                <a:cs typeface="Inter" pitchFamily="34" charset="-120"/>
+              </a:rPr>
+              <a:t>11</a:t>
             </a:r>
           </a:p>
         </p:txBody>

</xml_diff>